<commit_message>
deck 3-1: apply the author's 3-2 review preferences to slides 1-11
Gold conclusion banners reduced to three consequential slides (2, 7, 11);
em dashes removed from audience-facing text (the Act III title keeps the
author's own); the transition slide gains the module-outline strip the
presentation guide requires; cloud/container claims already carried their
qualifications. The mechanical verifier now enforces explicit per-run
sizes (effective 20pt, not inherited), bans internal references and em
dashes in audience text, and caps the banner count.

Co-Authored-By: Claude Opus 5 <noreply@anthropic.com>
</commit_message>
<xml_diff>
--- a/course/lectures/act-3-software-in-the-world/02-compute-environments-and-data-management/3-1-Compute-Environments-and-Deployment.pptx
+++ b/course/lectures/act-3-software-in-the-world/02-compute-environments-and-data-management/3-1-Compute-Environments-and-Deployment.pptx
@@ -1172,7 +1172,7 @@
           </a:p>
           <a:p>
             <a:r>
-              <a:t>ASK (the footer): which boxes are hardware, which software? EXPECTED confusion between "app server" (a node — could be a VM, could be metal) and "reservation service" (a component). That confusion is exactly why the diagram distinguishes them.</a:t>
+              <a:t>ASK: which of these boxes is hardware, and which is software? EXPECTED confusion between "app server" (a node — could be a VM, could be metal) and "reservation service" (a component). That confusion is exactly why the diagram distinguishes them.</a:t>
             </a:r>
           </a:p>
           <a:p>
@@ -1462,7 +1462,7 @@
           </a:p>
           <a:p>
             <a:r>
-              <a:t>ASK (the footer): why not teach security first, then? EXPECTED: you need something to secure — an architecture, data, a deployment — before threat modeling has an object. The order is pedagogical scaffolding, nothing more.</a:t>
+              <a:t>ASK: why not teach security first, then? EXPECTED: you need something to secure — an architecture, data, a deployment — before threat modeling has an object. The order is pedagogical scaffolding, nothing more.</a:t>
             </a:r>
           </a:p>
           <a:p>
@@ -1647,7 +1647,7 @@
           </a:p>
           <a:p>
             <a:r>
-              <a:t>ASK (the footer): which of these models have you already met? EXPECTED: the dependency graph (Act I architecture), and arguably the schema if they have used a database. Point out the pattern: none of these models is new mathematics — each is a purposeful reduction, the Act II Modeling idea applied to a new subject.</a:t>
+              <a:t>ASK: which of these models have you already met? EXPECTED: the dependency graph (Act I architecture), and arguably the schema if they have used a database. Point out the pattern: none of these models is new mathematics — each is a purposeful reduction, the Act II Modeling idea applied to a new subject.</a:t>
             </a:r>
           </a:p>
           <a:p>
@@ -1742,6 +1742,11 @@
           </a:p>
           <a:p>
             <a:r>
+              <a:t>MODULE OUTLINE (the bottom strip — this slide doubles as the lecture agenda, per the presentation guide's cover-then-outline requirement): execution environments; deployment models and configuration; CI/CD; release management; a worked deployment of the reservation service.</a:t>
+            </a:r>
+          </a:p>
+          <a:p>
+            <a:r>
               <a:t>TRANSITION: first question of the lecture proper — what does the application actually require from whatever it runs on?</a:t>
             </a:r>
           </a:p>
@@ -1917,7 +1922,7 @@
           </a:p>
           <a:p>
             <a:r>
-              <a:t>ASK (the footer): is the cloud the default? EXPECTED: many students assume yes. Push back with the rows: a pacemaker, a point-of-sale terminal, a flight computer, a campus lab machine. Cloud is one execution environment among several — the requirements decide.</a:t>
+              <a:t>ASK: is the cloud the default execution environment? EXPECTED: many students assume yes. Push back with the rows: a pacemaker, a point-of-sale terminal, a flight computer, a campus lab machine. Cloud is one execution environment among several — the requirements decide.</a:t>
             </a:r>
           </a:p>
           <a:p>
@@ -2007,7 +2012,7 @@
           </a:p>
           <a:p>
             <a:r>
-              <a:t>ASK (the footer): is a container a small VM? EXPECTED: many say yes. The corrective is the middle column: there is exactly one kernel in it. Isolation is weaker than a VM's, startup is faster, images are smaller — all consequences of that one fact.</a:t>
+              <a:t>ASK: is a container a small VM? EXPECTED: many say yes. The corrective is the middle column: there is exactly one kernel in it. Isolation is weaker than a VM's, startup is faster, images are smaller — all consequences of that one fact.</a:t>
             </a:r>
           </a:p>
           <a:p>
@@ -5681,7 +5686,7 @@
                   <a:srgbClr val="000000"/>
                 </a:solidFill>
               </a:rPr>
-              <a:t>Lecture 3-1 — Compute Environments &amp; Deployment</a:t>
+              <a:t>Compute Environments &amp; Deployment</a:t>
             </a:r>
           </a:p>
           <a:p>
@@ -6858,59 +6863,7 @@
                   <a:srgbClr val="555960"/>
                 </a:solidFill>
               </a:rPr>
-              <a:t>The storage node is the proposed production shape — today the service keeps reservations in memory</a:t>
-            </a:r>
-          </a:p>
-        </p:txBody>
-      </p:sp>
-      <p:sp>
-        <p:nvSpPr>
-          <p:cNvPr id="1019" name="FooterBand"/>
-          <p:cNvSpPr/>
-          <p:nvPr/>
-        </p:nvSpPr>
-        <p:spPr>
-          <a:xfrm>
-            <a:off x="274320" y="5512918"/>
-            <a:ext cx="8595360" cy="905256"/>
-          </a:xfrm>
-          <a:prstGeom prst="rect">
-            <a:avLst/>
-          </a:prstGeom>
-          <a:solidFill>
-            <a:srgbClr val="8E6F3E"/>
-          </a:solidFill>
-          <a:ln>
-            <a:noFill/>
-          </a:ln>
-          <a:effectLst/>
-        </p:spPr>
-        <p:style>
-          <a:lnRef idx="1">
-            <a:schemeClr val="accent1"/>
-          </a:lnRef>
-          <a:fillRef idx="3">
-            <a:schemeClr val="accent1"/>
-          </a:fillRef>
-          <a:effectRef idx="2">
-            <a:schemeClr val="accent1"/>
-          </a:effectRef>
-          <a:fontRef idx="minor">
-            <a:schemeClr val="lt1"/>
-          </a:fontRef>
-        </p:style>
-        <p:txBody>
-          <a:bodyPr wrap="square" lIns="27432" tIns="22860" rIns="27432" bIns="22860" rtlCol="0" anchor="ctr"/>
-          <a:lstStyle/>
-          <a:p>
-            <a:pPr algn="ctr"/>
-            <a:r>
-              <a:rPr sz="2000" b="1" i="0" dirty="0">
-                <a:solidFill>
-                  <a:srgbClr val="FFFFFF"/>
-                </a:solidFill>
-              </a:rPr>
-              <a:t>Which of these boxes is hardware, and which is software?</a:t>
+              <a:t>The storage node is proposed, not yet built. Today the service keeps reservations in memory.</a:t>
             </a:r>
           </a:p>
         </p:txBody>
@@ -8244,7 +8197,7 @@
                   <a:srgbClr val="5C4826"/>
                 </a:solidFill>
               </a:rPr>
-              <a:t>Requirements decide — cloud is not automatically preferable</a:t>
+              <a:t>Requirements decide. Cloud is not automatically preferable.</a:t>
             </a:r>
           </a:p>
         </p:txBody>
@@ -9655,59 +9608,7 @@
                   <a:srgbClr val="555960"/>
                 </a:solidFill>
               </a:rPr>
-              <a:t>A pedagogical order, not a chronological one — security shapes architecture from the start; operations shape deployment.</a:t>
-            </a:r>
-          </a:p>
-        </p:txBody>
-      </p:sp>
-      <p:sp>
-        <p:nvSpPr>
-          <p:cNvPr id="1016" name="FooterBand"/>
-          <p:cNvSpPr/>
-          <p:nvPr/>
-        </p:nvSpPr>
-        <p:spPr>
-          <a:xfrm>
-            <a:off x="274320" y="5512918"/>
-            <a:ext cx="8595360" cy="905256"/>
-          </a:xfrm>
-          <a:prstGeom prst="rect">
-            <a:avLst/>
-          </a:prstGeom>
-          <a:solidFill>
-            <a:srgbClr val="8E6F3E"/>
-          </a:solidFill>
-          <a:ln>
-            <a:noFill/>
-          </a:ln>
-          <a:effectLst/>
-        </p:spPr>
-        <p:style>
-          <a:lnRef idx="1">
-            <a:schemeClr val="accent1"/>
-          </a:lnRef>
-          <a:fillRef idx="3">
-            <a:schemeClr val="accent1"/>
-          </a:fillRef>
-          <a:effectRef idx="2">
-            <a:schemeClr val="accent1"/>
-          </a:effectRef>
-          <a:fontRef idx="minor">
-            <a:schemeClr val="lt1"/>
-          </a:fontRef>
-        </p:style>
-        <p:txBody>
-          <a:bodyPr wrap="square" lIns="27432" tIns="22860" rIns="27432" bIns="22860" rtlCol="0" anchor="ctr"/>
-          <a:lstStyle/>
-          <a:p>
-            <a:pPr algn="ctr"/>
-            <a:r>
-              <a:rPr sz="2000" b="1" i="0" dirty="0">
-                <a:solidFill>
-                  <a:srgbClr val="FFFFFF"/>
-                </a:solidFill>
-              </a:rPr>
-              <a:t>Why not teach security first?</a:t>
+              <a:t>This is the teaching order, not the order the concerns arrive. Security shapes architecture from the start; operations shape deployment.</a:t>
             </a:r>
           </a:p>
         </p:txBody>
@@ -11953,58 +11854,6 @@
           </a:p>
         </p:txBody>
       </p:sp>
-      <p:sp>
-        <p:nvSpPr>
-          <p:cNvPr id="1024" name="FooterBand"/>
-          <p:cNvSpPr/>
-          <p:nvPr/>
-        </p:nvSpPr>
-        <p:spPr>
-          <a:xfrm>
-            <a:off x="274320" y="5512918"/>
-            <a:ext cx="8595360" cy="905256"/>
-          </a:xfrm>
-          <a:prstGeom prst="rect">
-            <a:avLst/>
-          </a:prstGeom>
-          <a:solidFill>
-            <a:srgbClr val="8E6F3E"/>
-          </a:solidFill>
-          <a:ln>
-            <a:noFill/>
-          </a:ln>
-          <a:effectLst/>
-        </p:spPr>
-        <p:style>
-          <a:lnRef idx="1">
-            <a:schemeClr val="accent1"/>
-          </a:lnRef>
-          <a:fillRef idx="3">
-            <a:schemeClr val="accent1"/>
-          </a:fillRef>
-          <a:effectRef idx="2">
-            <a:schemeClr val="accent1"/>
-          </a:effectRef>
-          <a:fontRef idx="minor">
-            <a:schemeClr val="lt1"/>
-          </a:fontRef>
-        </p:style>
-        <p:txBody>
-          <a:bodyPr wrap="square" lIns="27432" tIns="22860" rIns="27432" bIns="22860" rtlCol="0" anchor="ctr"/>
-          <a:lstStyle/>
-          <a:p>
-            <a:pPr algn="ctr"/>
-            <a:r>
-              <a:rPr sz="2000" b="1" i="0" dirty="0">
-                <a:solidFill>
-                  <a:srgbClr val="FFFFFF"/>
-                </a:solidFill>
-              </a:rPr>
-              <a:t>Which of these models have you already met?</a:t>
-            </a:r>
-          </a:p>
-        </p:txBody>
-      </p:sp>
     </p:spTree>
   </p:cSld>
   <p:clrMapOvr>
@@ -12863,28 +12712,26 @@
                   <a:srgbClr val="555960"/>
                 </a:solidFill>
               </a:rPr>
-              <a:t>Today we make it explicit — and choose it.</a:t>
-            </a:r>
-          </a:p>
-        </p:txBody>
-      </p:sp>
-      <p:sp>
-        <p:nvSpPr>
-          <p:cNvPr id="1018" name="FooterBand"/>
+              <a:t>Today we make it explicit, and we choose it.</a:t>
+            </a:r>
+          </a:p>
+        </p:txBody>
+      </p:sp>
+      <p:sp>
+        <p:nvSpPr>
+          <p:cNvPr id="1018" name="AgendaStrip"/>
           <p:cNvSpPr/>
           <p:nvPr/>
         </p:nvSpPr>
         <p:spPr>
           <a:xfrm>
-            <a:off x="274320" y="5512918"/>
-            <a:ext cx="8595360" cy="905256"/>
+            <a:off x="457200" y="5440680"/>
+            <a:ext cx="8229600" cy="731520"/>
           </a:xfrm>
           <a:prstGeom prst="rect">
             <a:avLst/>
           </a:prstGeom>
-          <a:solidFill>
-            <a:srgbClr val="8E6F3E"/>
-          </a:solidFill>
+          <a:noFill/>
           <a:ln>
             <a:noFill/>
           </a:ln>
@@ -12908,14 +12755,14 @@
           <a:bodyPr wrap="square" lIns="27432" tIns="22860" rIns="27432" bIns="22860" rtlCol="0" anchor="ctr"/>
           <a:lstStyle/>
           <a:p>
-            <a:pPr algn="ctr"/>
-            <a:r>
-              <a:rPr sz="2000" b="1" i="0" dirty="0">
-                <a:solidFill>
-                  <a:srgbClr val="FFFFFF"/>
+            <a:pPr algn="l"/>
+            <a:r>
+              <a:rPr sz="2000" b="0" i="1" dirty="0">
+                <a:solidFill>
+                  <a:srgbClr val="555960"/>
                 </a:solidFill>
               </a:rPr>
-              <a:t>Where does the application run — and what does “run” require?</a:t>
+              <a:t>Today: execution environments, deployment models, CI/CD, release management, and a worked deployment</a:t>
             </a:r>
           </a:p>
         </p:txBody>
@@ -14249,59 +14096,7 @@
                   <a:srgbClr val="555960"/>
                 </a:solidFill>
               </a:rPr>
-              <a:t>Not exclusive — a mobile app may lean on cloud services</a:t>
-            </a:r>
-          </a:p>
-        </p:txBody>
-      </p:sp>
-      <p:sp>
-        <p:nvSpPr>
-          <p:cNvPr id="1013" name="FooterBand"/>
-          <p:cNvSpPr/>
-          <p:nvPr/>
-        </p:nvSpPr>
-        <p:spPr>
-          <a:xfrm>
-            <a:off x="274320" y="5512918"/>
-            <a:ext cx="8595360" cy="905256"/>
-          </a:xfrm>
-          <a:prstGeom prst="rect">
-            <a:avLst/>
-          </a:prstGeom>
-          <a:solidFill>
-            <a:srgbClr val="8E6F3E"/>
-          </a:solidFill>
-          <a:ln>
-            <a:noFill/>
-          </a:ln>
-          <a:effectLst/>
-        </p:spPr>
-        <p:style>
-          <a:lnRef idx="1">
-            <a:schemeClr val="accent1"/>
-          </a:lnRef>
-          <a:fillRef idx="3">
-            <a:schemeClr val="accent1"/>
-          </a:fillRef>
-          <a:effectRef idx="2">
-            <a:schemeClr val="accent1"/>
-          </a:effectRef>
-          <a:fontRef idx="minor">
-            <a:schemeClr val="lt1"/>
-          </a:fontRef>
-        </p:style>
-        <p:txBody>
-          <a:bodyPr wrap="square" lIns="27432" tIns="22860" rIns="27432" bIns="22860" rtlCol="0" anchor="ctr"/>
-          <a:lstStyle/>
-          <a:p>
-            <a:pPr algn="ctr"/>
-            <a:r>
-              <a:rPr sz="2000" b="1" i="0" dirty="0">
-                <a:solidFill>
-                  <a:srgbClr val="FFFFFF"/>
-                </a:solidFill>
-              </a:rPr>
-              <a:t>Is the cloud the default — or one environment among several?</a:t>
+              <a:t>The rows combine: a mobile app may lean on cloud services</a:t>
             </a:r>
           </a:p>
         </p:txBody>
@@ -15209,7 +15004,7 @@
                   <a:srgbClr val="5C4826"/>
                 </a:solidFill>
               </a:rPr>
-              <a:t>A container is not a miniature VM — it shares the host kernel</a:t>
+              <a:t>A container shares the host kernel. It is not a miniature VM.</a:t>
             </a:r>
           </a:p>
         </p:txBody>
@@ -15260,58 +15055,6 @@
                 </a:solidFill>
               </a:rPr>
               <a:t>Targets (embedded, mobile, desktop, server, cloud) and mechanisms (process, container, VM) are different dimensions</a:t>
-            </a:r>
-          </a:p>
-        </p:txBody>
-      </p:sp>
-      <p:sp>
-        <p:nvSpPr>
-          <p:cNvPr id="1019" name="FooterBand"/>
-          <p:cNvSpPr/>
-          <p:nvPr/>
-        </p:nvSpPr>
-        <p:spPr>
-          <a:xfrm>
-            <a:off x="274320" y="5512918"/>
-            <a:ext cx="8595360" cy="905256"/>
-          </a:xfrm>
-          <a:prstGeom prst="rect">
-            <a:avLst/>
-          </a:prstGeom>
-          <a:solidFill>
-            <a:srgbClr val="8E6F3E"/>
-          </a:solidFill>
-          <a:ln>
-            <a:noFill/>
-          </a:ln>
-          <a:effectLst/>
-        </p:spPr>
-        <p:style>
-          <a:lnRef idx="1">
-            <a:schemeClr val="accent1"/>
-          </a:lnRef>
-          <a:fillRef idx="3">
-            <a:schemeClr val="accent1"/>
-          </a:fillRef>
-          <a:effectRef idx="2">
-            <a:schemeClr val="accent1"/>
-          </a:effectRef>
-          <a:fontRef idx="minor">
-            <a:schemeClr val="lt1"/>
-          </a:fontRef>
-        </p:style>
-        <p:txBody>
-          <a:bodyPr wrap="square" lIns="27432" tIns="22860" rIns="27432" bIns="22860" rtlCol="0" anchor="ctr"/>
-          <a:lstStyle/>
-          <a:p>
-            <a:pPr algn="ctr"/>
-            <a:r>
-              <a:rPr sz="2000" b="1" i="0" dirty="0">
-                <a:solidFill>
-                  <a:srgbClr val="FFFFFF"/>
-                </a:solidFill>
-              </a:rPr>
-              <a:t>Is a container a small virtual machine?</a:t>
             </a:r>
           </a:p>
         </p:txBody>

</xml_diff>

<commit_message>
deck 3-1: CI/CD — slides 11-15
Section 3 adapted from the CI/CD source deck: the three-definition slide
gains the continuous-delivery distinction the originals lack; the
declared-workflow slide leads with the stage chain and reduces the YAML
to a minimal excerpt; the eight-slide pull-request walkthrough condenses
to one admission loop (Vasilescu et al. ICSME 2014 citation kept in
notes); the confidence slide is retitled to the evidence claim; and the
failure-modes slide stays deliberately short of the reliability unit's
territory. TIMING now 42 of 65 minutes.

Co-Authored-By: Claude Opus 5 <noreply@anthropic.com>
</commit_message>
<xml_diff>
--- a/course/lectures/act-3-software-in-the-world/02-compute-environments-and-data-management/3-1-Compute-Environments-and-Deployment.pptx
+++ b/course/lectures/act-3-software-in-the-world/02-compute-environments-and-data-management/3-1-Compute-Environments-and-Deployment.pptx
@@ -18,6 +18,11 @@
     <p:sldId id="263" r:id="rId15"/>
     <p:sldId id="264" r:id="rId16"/>
     <p:sldId id="265" r:id="rId17"/>
+    <p:sldId id="266" r:id="rId18"/>
+    <p:sldId id="267" r:id="rId19"/>
+    <p:sldId id="268" r:id="rId20"/>
+    <p:sldId id="269" r:id="rId21"/>
+    <p:sldId id="270" r:id="rId22"/>
   </p:sldIdLst>
   <p:sldSz cx="9144000" cy="6858000" type="screen4x3"/>
   <p:notesSz cx="6858000" cy="9144000"/>
@@ -1211,6 +1216,466 @@
 </p:notes>
 </file>
 
+<file path=ppt/notesSlides/notesSlide11.xml><?xml version="1.0" encoding="utf-8"?>
+<p:notes xmlns:a="http://schemas.openxmlformats.org/drawingml/2006/main" xmlns:p="http://schemas.openxmlformats.org/presentationml/2006/main" xmlns:r="http://schemas.openxmlformats.org/officeDocument/2006/relationships">
+  <p:cSld>
+    <p:spTree>
+      <p:nvGrpSpPr>
+        <p:cNvPr id="1" name=""/>
+        <p:cNvGrpSpPr/>
+        <p:nvPr/>
+      </p:nvGrpSpPr>
+      <p:grpSpPr>
+        <a:xfrm>
+          <a:off x="0" y="0"/>
+          <a:ext cx="0" cy="0"/>
+          <a:chOff x="0" y="0"/>
+          <a:chExt cx="0" cy="0"/>
+        </a:xfrm>
+      </p:grpSpPr>
+      <p:sp>
+        <p:nvSpPr>
+          <p:cNvPr id="2" name="Slide Image Placeholder 1"/>
+          <p:cNvSpPr>
+            <a:spLocks noGrp="1"/>
+          </p:cNvSpPr>
+          <p:nvPr>
+            <p:ph type="sldImg" idx="2"/>
+          </p:nvPr>
+        </p:nvSpPr>
+        <p:spPr/>
+      </p:sp>
+      <p:sp>
+        <p:nvSpPr>
+          <p:cNvPr id="3" name="Notes Placeholder 2"/>
+          <p:cNvSpPr>
+            <a:spLocks noGrp="1"/>
+          </p:cNvSpPr>
+          <p:nvPr>
+            <p:ph type="body" idx="3" sz="quarter"/>
+          </p:nvPr>
+        </p:nvSpPr>
+        <p:spPr/>
+        <p:txBody>
+          <a:bodyPr/>
+          <a:lstStyle/>
+          <a:p>
+            <a:r>
+              <a:t>TIMING: 3 minutes. THREE TERMS STUDENTS CONFLATE; separate them once, cleanly. ADAPTED from the CI/CD source deck's core-concepts slides, with the continuous-delivery distinction added: the originals introduce CI and continuous deployment but never separate delivery as its own idea.</a:t>
+            </a:r>
+          </a:p>
+          <a:p>
+            <a:r>
+              <a:t>WALK THE CARDS: continuous integration means integrating changes frequently and evaluating each one automatically; continuous delivery means the software is kept in a releasable state at all times; continuous deployment means qualifying changes deploy automatically.</a:t>
+            </a:r>
+          </a:p>
+          <a:p>
+            <a:r>
+              <a:t>THE DISTINCTION LINE: delivery is a STATE (always releasable); deployment is an ACTION (this build goes out now). The italic line carries the consequence: a delivery-practicing team still chooses its deployment moments.</a:t>
+            </a:r>
+          </a:p>
+          <a:p>
+            <a:r>
+              <a:t>ASK: which of the three does a medical-device team want? EXPECTED: CI certainly, delivery probably, automated deployment probably not. The release-management section builds on exactly this.</a:t>
+            </a:r>
+          </a:p>
+          <a:p>
+            <a:r>
+              <a:t>TRANSITION: all three rest on one artifact, the pipeline. What kind of thing is a pipeline?</a:t>
+            </a:r>
+          </a:p>
+        </p:txBody>
+      </p:sp>
+      <p:sp>
+        <p:nvSpPr>
+          <p:cNvPr id="4" name="Slide Number Placeholder 3"/>
+          <p:cNvSpPr>
+            <a:spLocks noGrp="1"/>
+          </p:cNvSpPr>
+          <p:nvPr>
+            <p:ph type="sldNum" idx="5" sz="quarter"/>
+          </p:nvPr>
+        </p:nvSpPr>
+        <p:spPr/>
+      </p:sp>
+    </p:spTree>
+  </p:cSld>
+  <p:clrMapOvr>
+    <a:masterClrMapping/>
+  </p:clrMapOvr>
+</p:notes>
+</file>
+
+<file path=ppt/notesSlides/notesSlide12.xml><?xml version="1.0" encoding="utf-8"?>
+<p:notes xmlns:a="http://schemas.openxmlformats.org/drawingml/2006/main" xmlns:p="http://schemas.openxmlformats.org/presentationml/2006/main" xmlns:r="http://schemas.openxmlformats.org/officeDocument/2006/relationships">
+  <p:cSld>
+    <p:spTree>
+      <p:nvGrpSpPr>
+        <p:cNvPr id="1" name=""/>
+        <p:cNvGrpSpPr/>
+        <p:nvPr/>
+      </p:nvGrpSpPr>
+      <p:grpSpPr>
+        <a:xfrm>
+          <a:off x="0" y="0"/>
+          <a:ext cx="0" cy="0"/>
+          <a:chOff x="0" y="0"/>
+          <a:chExt cx="0" cy="0"/>
+        </a:xfrm>
+      </p:grpSpPr>
+      <p:sp>
+        <p:nvSpPr>
+          <p:cNvPr id="2" name="Slide Image Placeholder 1"/>
+          <p:cNvSpPr>
+            <a:spLocks noGrp="1"/>
+          </p:cNvSpPr>
+          <p:nvPr>
+            <p:ph type="sldImg" idx="2"/>
+          </p:nvPr>
+        </p:nvSpPr>
+        <p:spPr/>
+      </p:sp>
+      <p:sp>
+        <p:nvSpPr>
+          <p:cNvPr id="3" name="Notes Placeholder 2"/>
+          <p:cNvSpPr>
+            <a:spLocks noGrp="1"/>
+          </p:cNvSpPr>
+          <p:nvPr>
+            <p:ph type="body" idx="3" sz="quarter"/>
+          </p:nvPr>
+        </p:nvSpPr>
+        <p:spPr/>
+        <p:txBody>
+          <a:bodyPr/>
+          <a:lstStyle/>
+          <a:p>
+            <a:r>
+              <a:t>TIMING: 3 minutes. THE MODELING CONNECTION, made explicit. ADAPTED from the source deck's 'Declaring a workflow' slide; the annotated real-world YAML was too implementation-specific to carry the explanation, so the diagram leads and a minimal excerpt follows.</a:t>
+            </a:r>
+          </a:p>
+          <a:p>
+            <a:r>
+              <a:t>WALK THE CHAIN first: commit, build, test, package, deploy. Each stage consumes the previous stage's output and emits evidence.</a:t>
+            </a:r>
+          </a:p>
+          <a:p>
+            <a:r>
+              <a:t>THEN the excerpt: the pipeline is DECLARED in a file that lives in the repository. That makes it a process model in exactly the Act II sense: a representation that automation executes. It is versioned, reviewed, and diffed like any other model.</a:t>
+            </a:r>
+          </a:p>
+          <a:p>
+            <a:r>
+              <a:t>ASK: what does putting the pipeline in the repository buy? EXPECTED: changes to the process are visible, reviewable, and attributable; the process cannot silently drift from what the file says, because the file IS the process.</a:t>
+            </a:r>
+          </a:p>
+          <a:p>
+            <a:r>
+              <a:t>NON-CLAIM: do not present this as GitHub-specific. Every mainstream CI system has an equivalent declaration; the engineering idea is the declared, executable process, not the vendor syntax.</a:t>
+            </a:r>
+          </a:p>
+          <a:p>
+            <a:r>
+              <a:t>TRANSITION: what the pipeline does with a proposed change is the next slide.</a:t>
+            </a:r>
+          </a:p>
+        </p:txBody>
+      </p:sp>
+      <p:sp>
+        <p:nvSpPr>
+          <p:cNvPr id="4" name="Slide Number Placeholder 3"/>
+          <p:cNvSpPr>
+            <a:spLocks noGrp="1"/>
+          </p:cNvSpPr>
+          <p:nvPr>
+            <p:ph type="sldNum" idx="5" sz="quarter"/>
+          </p:nvPr>
+        </p:nvSpPr>
+        <p:spPr/>
+      </p:sp>
+    </p:spTree>
+  </p:cSld>
+  <p:clrMapOvr>
+    <a:masterClrMapping/>
+  </p:clrMapOvr>
+</p:notes>
+</file>
+
+<file path=ppt/notesSlides/notesSlide13.xml><?xml version="1.0" encoding="utf-8"?>
+<p:notes xmlns:a="http://schemas.openxmlformats.org/drawingml/2006/main" xmlns:p="http://schemas.openxmlformats.org/presentationml/2006/main" xmlns:r="http://schemas.openxmlformats.org/officeDocument/2006/relationships">
+  <p:cSld>
+    <p:spTree>
+      <p:nvGrpSpPr>
+        <p:cNvPr id="1" name=""/>
+        <p:cNvGrpSpPr/>
+        <p:nvPr/>
+      </p:nvGrpSpPr>
+      <p:grpSpPr>
+        <a:xfrm>
+          <a:off x="0" y="0"/>
+          <a:ext cx="0" cy="0"/>
+          <a:chOff x="0" y="0"/>
+          <a:chExt cx="0" cy="0"/>
+        </a:xfrm>
+      </p:grpSpPr>
+      <p:sp>
+        <p:nvSpPr>
+          <p:cNvPr id="2" name="Slide Image Placeholder 1"/>
+          <p:cNvSpPr>
+            <a:spLocks noGrp="1"/>
+          </p:cNvSpPr>
+          <p:nvPr>
+            <p:ph type="sldImg" idx="2"/>
+          </p:nvPr>
+        </p:nvSpPr>
+        <p:spPr/>
+      </p:sp>
+      <p:sp>
+        <p:nvSpPr>
+          <p:cNvPr id="3" name="Notes Placeholder 2"/>
+          <p:cNvSpPr>
+            <a:spLocks noGrp="1"/>
+          </p:cNvSpPr>
+          <p:nvPr>
+            <p:ph type="body" idx="3" sz="quarter"/>
+          </p:nvPr>
+        </p:nvSpPr>
+        <p:spPr/>
+        <p:txBody>
+          <a:bodyPr/>
+          <a:lstStyle/>
+          <a:p>
+            <a:r>
+              <a:t>TIMING: 3 minutes. CONDENSED from the source deck's eight-slide pull-request walkthrough (the Travis-CI sequence, Vasilescu et al., ICSME 2014); the loop carries the same story in one figure.</a:t>
+            </a:r>
+          </a:p>
+          <a:p>
+            <a:r>
+              <a:t>WALK THE LOOP: a proposed change triggers automated checks; the checks pass or they do not; passing changes merge; failing ones return for revision and re-enter the same checks. In real projects a change loops several times before it merges, and that is the system working, not failing.</a:t>
+            </a:r>
+          </a:p>
+          <a:p>
+            <a:r>
+              <a:t>THE ALIGNMENT CONNECTION, stated plainly: the checks produce EVIDENCE; a required status check is an ADMISSION GATE. This is the kickoff flowchart's alignment box acting on a concrete pipeline: constraints on what may merge, sensors on what the change actually does.</a:t>
+            </a:r>
+          </a:p>
+          <a:p>
+            <a:r>
+              <a:t>ASK: who decided what the checks are? EXPECTED: the team, earlier, in the pipeline definition. The admission decision was made once, as policy, rather than per change under deadline pressure.</a:t>
+            </a:r>
+          </a:p>
+          <a:p>
+            <a:r>
+              <a:t>CITATION to keep in the deck's record: the pull-request cycle evidence is from Vasilescu, van Schuylenburg, Wulms, Serebrenik, and van den Brand, ICSME 2014.</a:t>
+            </a:r>
+          </a:p>
+          <a:p>
+            <a:r>
+              <a:t>TRANSITION: what does a wall of green checks actually tell you?</a:t>
+            </a:r>
+          </a:p>
+        </p:txBody>
+      </p:sp>
+      <p:sp>
+        <p:nvSpPr>
+          <p:cNvPr id="4" name="Slide Number Placeholder 3"/>
+          <p:cNvSpPr>
+            <a:spLocks noGrp="1"/>
+          </p:cNvSpPr>
+          <p:nvPr>
+            <p:ph type="sldNum" idx="5" sz="quarter"/>
+          </p:nvPr>
+        </p:nvSpPr>
+        <p:spPr/>
+      </p:sp>
+    </p:spTree>
+  </p:cSld>
+  <p:clrMapOvr>
+    <a:masterClrMapping/>
+  </p:clrMapOvr>
+</p:notes>
+</file>
+
+<file path=ppt/notesSlides/notesSlide14.xml><?xml version="1.0" encoding="utf-8"?>
+<p:notes xmlns:a="http://schemas.openxmlformats.org/drawingml/2006/main" xmlns:p="http://schemas.openxmlformats.org/presentationml/2006/main" xmlns:r="http://schemas.openxmlformats.org/officeDocument/2006/relationships">
+  <p:cSld>
+    <p:spTree>
+      <p:nvGrpSpPr>
+        <p:cNvPr id="1" name=""/>
+        <p:cNvGrpSpPr/>
+        <p:nvPr/>
+      </p:nvGrpSpPr>
+      <p:grpSpPr>
+        <a:xfrm>
+          <a:off x="0" y="0"/>
+          <a:ext cx="0" cy="0"/>
+          <a:chOff x="0" y="0"/>
+          <a:chExt cx="0" cy="0"/>
+        </a:xfrm>
+      </p:grpSpPr>
+      <p:sp>
+        <p:nvSpPr>
+          <p:cNvPr id="2" name="Slide Image Placeholder 1"/>
+          <p:cNvSpPr>
+            <a:spLocks noGrp="1"/>
+          </p:cNvSpPr>
+          <p:nvPr>
+            <p:ph type="sldImg" idx="2"/>
+          </p:nvPr>
+        </p:nvSpPr>
+        <p:spPr/>
+      </p:sp>
+      <p:sp>
+        <p:nvSpPr>
+          <p:cNvPr id="3" name="Notes Placeholder 2"/>
+          <p:cNvSpPr>
+            <a:spLocks noGrp="1"/>
+          </p:cNvSpPr>
+          <p:nvPr>
+            <p:ph type="body" idx="3" sz="quarter"/>
+          </p:nvPr>
+        </p:nvSpPr>
+        <p:spPr/>
+        <p:txBody>
+          <a:bodyPr/>
+          <a:lstStyle/>
+          <a:p>
+            <a:r>
+              <a:t>TIMING: 3 minutes. RETAINED from the source deck's strongest slide, with the title revised from 'pipelines are for confidence, not speed' to the evidence form: pipelines also do speed work by removing manual coordination, so the old title overclaimed the contrast.</a:t>
+            </a:r>
+          </a:p>
+          <a:p>
+            <a:r>
+              <a:t>WALK THE PANEL: a pull request with five checks, four green and one red. The red integration check blocks the merge; nobody has to argue about it in the moment.</a:t>
+            </a:r>
+          </a:p>
+          <a:p>
+            <a:r>
+              <a:t>ENGINEERING POINT: confidence is built through automation of evidence. Every stage generates an artifact someone could inspect: a build log, a test report, a lint result. The admission decision consumes that evidence mechanically.</a:t>
+            </a:r>
+          </a:p>
+          <a:p>
+            <a:r>
+              <a:t>ASK: the four green checks passed. What do they establish? EXPECTED: exactly the properties those checks test, in the pipeline's environment, and nothing more. This primes the next slide and the release-management section: green is evidence, not a verdict about production.</a:t>
+            </a:r>
+          </a:p>
+          <a:p>
+            <a:r>
+              <a:t>TRANSITION: the pipeline itself is software. Software fails.</a:t>
+            </a:r>
+          </a:p>
+        </p:txBody>
+      </p:sp>
+      <p:sp>
+        <p:nvSpPr>
+          <p:cNvPr id="4" name="Slide Number Placeholder 3"/>
+          <p:cNvSpPr>
+            <a:spLocks noGrp="1"/>
+          </p:cNvSpPr>
+          <p:nvPr>
+            <p:ph type="sldNum" idx="5" sz="quarter"/>
+          </p:nvPr>
+        </p:nvSpPr>
+        <p:spPr/>
+      </p:sp>
+    </p:spTree>
+  </p:cSld>
+  <p:clrMapOvr>
+    <a:masterClrMapping/>
+  </p:clrMapOvr>
+</p:notes>
+</file>
+
+<file path=ppt/notesSlides/notesSlide15.xml><?xml version="1.0" encoding="utf-8"?>
+<p:notes xmlns:a="http://schemas.openxmlformats.org/drawingml/2006/main" xmlns:p="http://schemas.openxmlformats.org/presentationml/2006/main" xmlns:r="http://schemas.openxmlformats.org/officeDocument/2006/relationships">
+  <p:cSld>
+    <p:spTree>
+      <p:nvGrpSpPr>
+        <p:cNvPr id="1" name=""/>
+        <p:cNvGrpSpPr/>
+        <p:nvPr/>
+      </p:nvGrpSpPr>
+      <p:grpSpPr>
+        <a:xfrm>
+          <a:off x="0" y="0"/>
+          <a:ext cx="0" cy="0"/>
+          <a:chOff x="0" y="0"/>
+          <a:chExt cx="0" cy="0"/>
+        </a:xfrm>
+      </p:grpSpPr>
+      <p:sp>
+        <p:nvSpPr>
+          <p:cNvPr id="2" name="Slide Image Placeholder 1"/>
+          <p:cNvSpPr>
+            <a:spLocks noGrp="1"/>
+          </p:cNvSpPr>
+          <p:nvPr>
+            <p:ph type="sldImg" idx="2"/>
+          </p:nvPr>
+        </p:nvSpPr>
+        <p:spPr/>
+      </p:sp>
+      <p:sp>
+        <p:nvSpPr>
+          <p:cNvPr id="3" name="Notes Placeholder 2"/>
+          <p:cNvSpPr>
+            <a:spLocks noGrp="1"/>
+          </p:cNvSpPr>
+          <p:nvPr>
+            <p:ph type="body" idx="3" sz="quarter"/>
+          </p:nvPr>
+        </p:nvSpPr>
+        <p:spPr/>
+        <p:txBody>
+          <a:bodyPr/>
+          <a:lstStyle/>
+          <a:p>
+            <a:r>
+              <a:t>TIMING: 2 minutes. A SHORT TREATMENT by design; the deeper study of flaky tests belongs to the reliability unit, and the source deck's think-pair-share on them is deliberately not reproduced here.</a:t>
+            </a:r>
+          </a:p>
+          <a:p>
+            <a:r>
+              <a:t>WALK THE CARDS briefly: flaky tests return different verdicts on the same code, and every flake spends some of the team's trust in the signal; environment drift lets the runner diverge from production until green stops meaning what it meant; unreliable dependencies make the network a silent stage of every pipeline run.</a:t>
+            </a:r>
+          </a:p>
+          <a:p>
+            <a:r>
+              <a:t>ENGINEERING POINT (the closing line): the pipeline is itself software, running in its own execution environment, with its own dependencies. Everything this lecture said about environments applies to it.</a:t>
+            </a:r>
+          </a:p>
+          <a:p>
+            <a:r>
+              <a:t>ASK, if time allows: when CI gives a wrong answer, which direction costs more, a false red or a false green? Take one answer each way; both are defensible, which is the discussion the reliability unit picks up.</a:t>
+            </a:r>
+          </a:p>
+          <a:p>
+            <a:r>
+              <a:t>TRANSITION: suppose the pipeline is healthy and the run is green. Should you ship?</a:t>
+            </a:r>
+          </a:p>
+        </p:txBody>
+      </p:sp>
+      <p:sp>
+        <p:nvSpPr>
+          <p:cNvPr id="4" name="Slide Number Placeholder 3"/>
+          <p:cNvSpPr>
+            <a:spLocks noGrp="1"/>
+          </p:cNvSpPr>
+          <p:nvPr>
+            <p:ph type="sldNum" idx="5" sz="quarter"/>
+          </p:nvPr>
+        </p:nvSpPr>
+        <p:spPr/>
+      </p:sp>
+    </p:spTree>
+  </p:cSld>
+  <p:clrMapOvr>
+    <a:masterClrMapping/>
+  </p:clrMapOvr>
+</p:notes>
+</file>
+
 <file path=ppt/notesSlides/notesSlide2.xml><?xml version="1.0" encoding="utf-8"?>
 <p:notes xmlns:a="http://schemas.openxmlformats.org/drawingml/2006/main" xmlns:p="http://schemas.openxmlformats.org/presentationml/2006/main" xmlns:r="http://schemas.openxmlformats.org/officeDocument/2006/relationships">
   <p:cSld>
@@ -6069,6 +6534,2456 @@
                 </a:solidFill>
               </a:rPr>
               <a:t>external services, mutable dependencies, nondeterministic builds</a:t>
+            </a:r>
+          </a:p>
+        </p:txBody>
+      </p:sp>
+    </p:spTree>
+  </p:cSld>
+  <p:clrMapOvr>
+    <a:masterClrMapping/>
+  </p:clrMapOvr>
+</p:sld>
+</file>
+
+<file path=ppt/slides/slide11.xml><?xml version="1.0" encoding="utf-8"?>
+<p:sld xmlns:a="http://schemas.openxmlformats.org/drawingml/2006/main" xmlns:p="http://schemas.openxmlformats.org/presentationml/2006/main" xmlns:r="http://schemas.openxmlformats.org/officeDocument/2006/relationships">
+  <p:cSld>
+    <p:spTree>
+      <p:nvGrpSpPr>
+        <p:cNvPr id="1" name=""/>
+        <p:cNvGrpSpPr/>
+        <p:nvPr/>
+      </p:nvGrpSpPr>
+      <p:grpSpPr/>
+      <p:sp>
+        <p:nvSpPr>
+          <p:cNvPr id="3" name="Title 2"/>
+          <p:cNvSpPr>
+            <a:spLocks noGrp="1"/>
+          </p:cNvSpPr>
+          <p:nvPr>
+            <p:ph type="title"/>
+          </p:nvPr>
+        </p:nvSpPr>
+        <p:spPr/>
+        <p:txBody>
+          <a:bodyPr wrap="square"/>
+          <a:lstStyle/>
+          <a:p>
+            <a:pPr algn="l"/>
+            <a:r>
+              <a:rPr sz="2400" b="0" i="0" dirty="0">
+                <a:solidFill>
+                  <a:srgbClr val="000000"/>
+                </a:solidFill>
+              </a:rPr>
+              <a:t>CI/CD automates the path from change to deployment</a:t>
+            </a:r>
+          </a:p>
+        </p:txBody>
+      </p:sp>
+      <p:sp>
+        <p:nvSpPr>
+          <p:cNvPr id="1001" name="Slide Number Placeholder 900"/>
+          <p:cNvSpPr>
+            <a:spLocks noGrp="1"/>
+          </p:cNvSpPr>
+          <p:nvPr>
+            <p:ph type="sldNum" sz="quarter" idx="4"/>
+          </p:nvPr>
+        </p:nvSpPr>
+        <p:spPr/>
+        <p:txBody>
+          <a:bodyPr/>
+          <a:lstStyle/>
+          <a:p>
+            <a:fld id="{B3291E67-7172-4DCF-B35F-54404EBE6160}" type="slidenum">
+              <a:rPr lang="en-US" smtClean="0"/>
+              <a:t>1</a:t>
+            </a:fld>
+            <a:endParaRPr lang="en-US"/>
+          </a:p>
+        </p:txBody>
+      </p:sp>
+      <p:sp>
+        <p:nvSpPr>
+          <p:cNvPr id="1002" name="Card"/>
+          <p:cNvSpPr/>
+          <p:nvPr/>
+        </p:nvSpPr>
+        <p:spPr>
+          <a:xfrm>
+            <a:off x="365760" y="1280160"/>
+            <a:ext cx="2651760" cy="2103120"/>
+          </a:xfrm>
+          <a:prstGeom prst="rect">
+            <a:avLst/>
+          </a:prstGeom>
+          <a:solidFill>
+            <a:srgbClr val="F5F1E8"/>
+          </a:solidFill>
+          <a:ln w="12700">
+            <a:solidFill>
+              <a:srgbClr val="C9B991"/>
+            </a:solidFill>
+          </a:ln>
+          <a:effectLst/>
+        </p:spPr>
+        <p:style>
+          <a:lnRef idx="1">
+            <a:schemeClr val="accent1"/>
+          </a:lnRef>
+          <a:fillRef idx="3">
+            <a:schemeClr val="accent1"/>
+          </a:fillRef>
+          <a:effectRef idx="2">
+            <a:schemeClr val="accent1"/>
+          </a:effectRef>
+          <a:fontRef idx="minor">
+            <a:schemeClr val="lt1"/>
+          </a:fontRef>
+        </p:style>
+        <p:txBody>
+          <a:bodyPr wrap="square" lIns="27432" tIns="22860" rIns="27432" bIns="22860" rtlCol="0" anchor="t"/>
+          <a:lstStyle/>
+          <a:p>
+            <a:pPr algn="ctr"/>
+            <a:r>
+              <a:rPr sz="2000" b="1" i="0" dirty="0">
+                <a:solidFill>
+                  <a:srgbClr val="5C4826"/>
+                </a:solidFill>
+              </a:rPr>
+              <a:t>CONTINUOUS INTEGRATION</a:t>
+            </a:r>
+          </a:p>
+          <a:p>
+            <a:pPr algn="ctr">
+              <a:spcBef>
+                <a:spcPts val="800"/>
+              </a:spcBef>
+            </a:pPr>
+            <a:r>
+              <a:rPr sz="2000" b="0" i="0" dirty="0">
+                <a:solidFill>
+                  <a:srgbClr val="5C4826"/>
+                </a:solidFill>
+              </a:rPr>
+              <a:t>integrate changes frequently;</a:t>
+            </a:r>
+          </a:p>
+          <a:p>
+            <a:pPr algn="ctr">
+              <a:spcBef>
+                <a:spcPts val="200"/>
+              </a:spcBef>
+            </a:pPr>
+            <a:r>
+              <a:rPr sz="2000" b="0" i="0" dirty="0">
+                <a:solidFill>
+                  <a:srgbClr val="5C4826"/>
+                </a:solidFill>
+              </a:rPr>
+              <a:t>evaluate each one automatically</a:t>
+            </a:r>
+          </a:p>
+        </p:txBody>
+      </p:sp>
+      <p:sp>
+        <p:nvSpPr>
+          <p:cNvPr id="1003" name="Card"/>
+          <p:cNvSpPr/>
+          <p:nvPr/>
+        </p:nvSpPr>
+        <p:spPr>
+          <a:xfrm>
+            <a:off x="3246120" y="1280160"/>
+            <a:ext cx="2651760" cy="2103120"/>
+          </a:xfrm>
+          <a:prstGeom prst="rect">
+            <a:avLst/>
+          </a:prstGeom>
+          <a:solidFill>
+            <a:srgbClr val="F5F1E8"/>
+          </a:solidFill>
+          <a:ln w="12700">
+            <a:solidFill>
+              <a:srgbClr val="C9B991"/>
+            </a:solidFill>
+          </a:ln>
+          <a:effectLst/>
+        </p:spPr>
+        <p:style>
+          <a:lnRef idx="1">
+            <a:schemeClr val="accent1"/>
+          </a:lnRef>
+          <a:fillRef idx="3">
+            <a:schemeClr val="accent1"/>
+          </a:fillRef>
+          <a:effectRef idx="2">
+            <a:schemeClr val="accent1"/>
+          </a:effectRef>
+          <a:fontRef idx="minor">
+            <a:schemeClr val="lt1"/>
+          </a:fontRef>
+        </p:style>
+        <p:txBody>
+          <a:bodyPr wrap="square" lIns="27432" tIns="22860" rIns="27432" bIns="22860" rtlCol="0" anchor="t"/>
+          <a:lstStyle/>
+          <a:p>
+            <a:pPr algn="ctr"/>
+            <a:r>
+              <a:rPr sz="2000" b="1" i="0" dirty="0">
+                <a:solidFill>
+                  <a:srgbClr val="5C4826"/>
+                </a:solidFill>
+              </a:rPr>
+              <a:t>CONTINUOUS DELIVERY</a:t>
+            </a:r>
+          </a:p>
+          <a:p>
+            <a:pPr algn="ctr">
+              <a:spcBef>
+                <a:spcPts val="800"/>
+              </a:spcBef>
+            </a:pPr>
+            <a:r>
+              <a:rPr sz="2000" b="0" i="0" dirty="0">
+                <a:solidFill>
+                  <a:srgbClr val="5C4826"/>
+                </a:solidFill>
+              </a:rPr>
+              <a:t>keep the software releasable</a:t>
+            </a:r>
+          </a:p>
+          <a:p>
+            <a:pPr algn="ctr">
+              <a:spcBef>
+                <a:spcPts val="200"/>
+              </a:spcBef>
+            </a:pPr>
+            <a:r>
+              <a:rPr sz="2000" b="0" i="0" dirty="0">
+                <a:solidFill>
+                  <a:srgbClr val="5C4826"/>
+                </a:solidFill>
+              </a:rPr>
+              <a:t>at every moment</a:t>
+            </a:r>
+          </a:p>
+        </p:txBody>
+      </p:sp>
+      <p:sp>
+        <p:nvSpPr>
+          <p:cNvPr id="1004" name="Card"/>
+          <p:cNvSpPr/>
+          <p:nvPr/>
+        </p:nvSpPr>
+        <p:spPr>
+          <a:xfrm>
+            <a:off x="6126480" y="1280160"/>
+            <a:ext cx="2651760" cy="2103120"/>
+          </a:xfrm>
+          <a:prstGeom prst="rect">
+            <a:avLst/>
+          </a:prstGeom>
+          <a:solidFill>
+            <a:srgbClr val="F5F1E8"/>
+          </a:solidFill>
+          <a:ln w="12700">
+            <a:solidFill>
+              <a:srgbClr val="C9B991"/>
+            </a:solidFill>
+          </a:ln>
+          <a:effectLst/>
+        </p:spPr>
+        <p:style>
+          <a:lnRef idx="1">
+            <a:schemeClr val="accent1"/>
+          </a:lnRef>
+          <a:fillRef idx="3">
+            <a:schemeClr val="accent1"/>
+          </a:fillRef>
+          <a:effectRef idx="2">
+            <a:schemeClr val="accent1"/>
+          </a:effectRef>
+          <a:fontRef idx="minor">
+            <a:schemeClr val="lt1"/>
+          </a:fontRef>
+        </p:style>
+        <p:txBody>
+          <a:bodyPr wrap="square" lIns="27432" tIns="22860" rIns="27432" bIns="22860" rtlCol="0" anchor="t"/>
+          <a:lstStyle/>
+          <a:p>
+            <a:pPr algn="ctr"/>
+            <a:r>
+              <a:rPr sz="2000" b="1" i="0" dirty="0">
+                <a:solidFill>
+                  <a:srgbClr val="5C4826"/>
+                </a:solidFill>
+              </a:rPr>
+              <a:t>CONTINUOUS DEPLOYMENT</a:t>
+            </a:r>
+          </a:p>
+          <a:p>
+            <a:pPr algn="ctr">
+              <a:spcBef>
+                <a:spcPts val="800"/>
+              </a:spcBef>
+            </a:pPr>
+            <a:r>
+              <a:rPr sz="2000" b="0" i="0" dirty="0">
+                <a:solidFill>
+                  <a:srgbClr val="5C4826"/>
+                </a:solidFill>
+              </a:rPr>
+              <a:t>automatically deploy changes</a:t>
+            </a:r>
+          </a:p>
+          <a:p>
+            <a:pPr algn="ctr">
+              <a:spcBef>
+                <a:spcPts val="200"/>
+              </a:spcBef>
+            </a:pPr>
+            <a:r>
+              <a:rPr sz="2000" b="0" i="0" dirty="0">
+                <a:solidFill>
+                  <a:srgbClr val="5C4826"/>
+                </a:solidFill>
+              </a:rPr>
+              <a:t>that pass the gates</a:t>
+            </a:r>
+          </a:p>
+        </p:txBody>
+      </p:sp>
+      <p:sp>
+        <p:nvSpPr>
+          <p:cNvPr id="1005" name="Label"/>
+          <p:cNvSpPr/>
+          <p:nvPr/>
+        </p:nvSpPr>
+        <p:spPr>
+          <a:xfrm>
+            <a:off x="365760" y="3657600"/>
+            <a:ext cx="8412480" cy="384048"/>
+          </a:xfrm>
+          <a:prstGeom prst="rect">
+            <a:avLst/>
+          </a:prstGeom>
+          <a:noFill/>
+          <a:ln>
+            <a:noFill/>
+          </a:ln>
+          <a:effectLst/>
+        </p:spPr>
+        <p:style>
+          <a:lnRef idx="1">
+            <a:schemeClr val="accent1"/>
+          </a:lnRef>
+          <a:fillRef idx="3">
+            <a:schemeClr val="accent1"/>
+          </a:fillRef>
+          <a:effectRef idx="2">
+            <a:schemeClr val="accent1"/>
+          </a:effectRef>
+          <a:fontRef idx="minor">
+            <a:schemeClr val="lt1"/>
+          </a:fontRef>
+        </p:style>
+        <p:txBody>
+          <a:bodyPr wrap="square" lIns="27432" tIns="22860" rIns="27432" bIns="22860" rtlCol="0" anchor="ctr"/>
+          <a:lstStyle/>
+          <a:p>
+            <a:pPr algn="ctr"/>
+            <a:r>
+              <a:rPr sz="2000" b="1" i="0" dirty="0">
+                <a:solidFill>
+                  <a:srgbClr val="5C4826"/>
+                </a:solidFill>
+              </a:rPr>
+              <a:t>Delivery is a state; deployment is an action</a:t>
+            </a:r>
+          </a:p>
+        </p:txBody>
+      </p:sp>
+      <p:sp>
+        <p:nvSpPr>
+          <p:cNvPr id="1006" name="Label"/>
+          <p:cNvSpPr/>
+          <p:nvPr/>
+        </p:nvSpPr>
+        <p:spPr>
+          <a:xfrm>
+            <a:off x="365760" y="4206240"/>
+            <a:ext cx="8412480" cy="658368"/>
+          </a:xfrm>
+          <a:prstGeom prst="rect">
+            <a:avLst/>
+          </a:prstGeom>
+          <a:noFill/>
+          <a:ln>
+            <a:noFill/>
+          </a:ln>
+          <a:effectLst/>
+        </p:spPr>
+        <p:style>
+          <a:lnRef idx="1">
+            <a:schemeClr val="accent1"/>
+          </a:lnRef>
+          <a:fillRef idx="3">
+            <a:schemeClr val="accent1"/>
+          </a:fillRef>
+          <a:effectRef idx="2">
+            <a:schemeClr val="accent1"/>
+          </a:effectRef>
+          <a:fontRef idx="minor">
+            <a:schemeClr val="lt1"/>
+          </a:fontRef>
+        </p:style>
+        <p:txBody>
+          <a:bodyPr wrap="square" lIns="27432" tIns="22860" rIns="27432" bIns="22860" rtlCol="0" anchor="ctr"/>
+          <a:lstStyle/>
+          <a:p>
+            <a:pPr algn="ctr"/>
+            <a:r>
+              <a:rPr sz="2000" b="0" i="1" dirty="0">
+                <a:solidFill>
+                  <a:srgbClr val="555960"/>
+                </a:solidFill>
+              </a:rPr>
+              <a:t>A team can practice continuous delivery and still choose when each deployment happens</a:t>
+            </a:r>
+          </a:p>
+        </p:txBody>
+      </p:sp>
+    </p:spTree>
+  </p:cSld>
+  <p:clrMapOvr>
+    <a:masterClrMapping/>
+  </p:clrMapOvr>
+</p:sld>
+</file>
+
+<file path=ppt/slides/slide12.xml><?xml version="1.0" encoding="utf-8"?>
+<p:sld xmlns:a="http://schemas.openxmlformats.org/drawingml/2006/main" xmlns:p="http://schemas.openxmlformats.org/presentationml/2006/main" xmlns:r="http://schemas.openxmlformats.org/officeDocument/2006/relationships">
+  <p:cSld>
+    <p:spTree>
+      <p:nvGrpSpPr>
+        <p:cNvPr id="1" name=""/>
+        <p:cNvGrpSpPr/>
+        <p:nvPr/>
+      </p:nvGrpSpPr>
+      <p:grpSpPr/>
+      <p:sp>
+        <p:nvSpPr>
+          <p:cNvPr id="3" name="Title 2"/>
+          <p:cNvSpPr>
+            <a:spLocks noGrp="1"/>
+          </p:cNvSpPr>
+          <p:nvPr>
+            <p:ph type="title"/>
+          </p:nvPr>
+        </p:nvSpPr>
+        <p:spPr/>
+        <p:txBody>
+          <a:bodyPr wrap="square"/>
+          <a:lstStyle/>
+          <a:p>
+            <a:pPr algn="l"/>
+            <a:r>
+              <a:rPr sz="2400" b="0" i="0" dirty="0">
+                <a:solidFill>
+                  <a:srgbClr val="000000"/>
+                </a:solidFill>
+              </a:rPr>
+              <a:t>A pipeline is an executable process model</a:t>
+            </a:r>
+          </a:p>
+        </p:txBody>
+      </p:sp>
+      <p:sp>
+        <p:nvSpPr>
+          <p:cNvPr id="1001" name="Slide Number Placeholder 900"/>
+          <p:cNvSpPr>
+            <a:spLocks noGrp="1"/>
+          </p:cNvSpPr>
+          <p:nvPr>
+            <p:ph type="sldNum" sz="quarter" idx="4"/>
+          </p:nvPr>
+        </p:nvSpPr>
+        <p:spPr/>
+        <p:txBody>
+          <a:bodyPr/>
+          <a:lstStyle/>
+          <a:p>
+            <a:fld id="{B3291E67-7172-4DCF-B35F-54404EBE6160}" type="slidenum">
+              <a:rPr lang="en-US" smtClean="0"/>
+              <a:t>1</a:t>
+            </a:fld>
+            <a:endParaRPr lang="en-US"/>
+          </a:p>
+        </p:txBody>
+      </p:sp>
+      <p:sp>
+        <p:nvSpPr>
+          <p:cNvPr id="1002" name="Block"/>
+          <p:cNvSpPr/>
+          <p:nvPr/>
+        </p:nvSpPr>
+        <p:spPr>
+          <a:xfrm>
+            <a:off x="411480" y="1188720"/>
+            <a:ext cx="1481328" cy="640080"/>
+          </a:xfrm>
+          <a:prstGeom prst="rect">
+            <a:avLst/>
+          </a:prstGeom>
+          <a:solidFill>
+            <a:srgbClr val="8E6F3E"/>
+          </a:solidFill>
+          <a:ln>
+            <a:noFill/>
+          </a:ln>
+          <a:effectLst/>
+        </p:spPr>
+        <p:style>
+          <a:lnRef idx="1">
+            <a:schemeClr val="accent1"/>
+          </a:lnRef>
+          <a:fillRef idx="3">
+            <a:schemeClr val="accent1"/>
+          </a:fillRef>
+          <a:effectRef idx="2">
+            <a:schemeClr val="accent1"/>
+          </a:effectRef>
+          <a:fontRef idx="minor">
+            <a:schemeClr val="lt1"/>
+          </a:fontRef>
+        </p:style>
+        <p:txBody>
+          <a:bodyPr wrap="square" lIns="27432" tIns="22860" rIns="27432" bIns="22860" rtlCol="0" anchor="ctr"/>
+          <a:lstStyle/>
+          <a:p>
+            <a:pPr algn="ctr"/>
+            <a:r>
+              <a:rPr sz="2000" b="1" i="0" dirty="0">
+                <a:solidFill>
+                  <a:srgbClr val="FFFFFF"/>
+                </a:solidFill>
+              </a:rPr>
+              <a:t>COMMIT</a:t>
+            </a:r>
+          </a:p>
+        </p:txBody>
+      </p:sp>
+      <p:sp>
+        <p:nvSpPr>
+          <p:cNvPr id="1003" name="Block"/>
+          <p:cNvSpPr/>
+          <p:nvPr/>
+        </p:nvSpPr>
+        <p:spPr>
+          <a:xfrm>
+            <a:off x="2130552" y="1188720"/>
+            <a:ext cx="1481328" cy="640080"/>
+          </a:xfrm>
+          <a:prstGeom prst="rect">
+            <a:avLst/>
+          </a:prstGeom>
+          <a:solidFill>
+            <a:srgbClr val="8E6F3E"/>
+          </a:solidFill>
+          <a:ln>
+            <a:noFill/>
+          </a:ln>
+          <a:effectLst/>
+        </p:spPr>
+        <p:style>
+          <a:lnRef idx="1">
+            <a:schemeClr val="accent1"/>
+          </a:lnRef>
+          <a:fillRef idx="3">
+            <a:schemeClr val="accent1"/>
+          </a:fillRef>
+          <a:effectRef idx="2">
+            <a:schemeClr val="accent1"/>
+          </a:effectRef>
+          <a:fontRef idx="minor">
+            <a:schemeClr val="lt1"/>
+          </a:fontRef>
+        </p:style>
+        <p:txBody>
+          <a:bodyPr wrap="square" lIns="27432" tIns="22860" rIns="27432" bIns="22860" rtlCol="0" anchor="ctr"/>
+          <a:lstStyle/>
+          <a:p>
+            <a:pPr algn="ctr"/>
+            <a:r>
+              <a:rPr sz="2000" b="1" i="0" dirty="0">
+                <a:solidFill>
+                  <a:srgbClr val="FFFFFF"/>
+                </a:solidFill>
+              </a:rPr>
+              <a:t>BUILD</a:t>
+            </a:r>
+          </a:p>
+        </p:txBody>
+      </p:sp>
+      <p:cxnSp>
+        <p:nvCxnSpPr>
+          <p:cNvPr id="1004" name="Connector"/>
+          <p:cNvCxnSpPr/>
+          <p:nvPr/>
+        </p:nvCxnSpPr>
+        <p:spPr>
+          <a:xfrm>
+            <a:off x="1911096" y="1508760"/>
+            <a:ext cx="201168" cy="0"/>
+          </a:xfrm>
+          <a:prstGeom prst="line">
+            <a:avLst/>
+          </a:prstGeom>
+          <a:ln w="19050">
+            <a:solidFill>
+              <a:srgbClr val="8E6F3E"/>
+            </a:solidFill>
+            <a:tailEnd type="triangle"/>
+          </a:ln>
+        </p:spPr>
+        <p:style>
+          <a:lnRef idx="2">
+            <a:schemeClr val="accent1"/>
+          </a:lnRef>
+          <a:fillRef idx="0">
+            <a:schemeClr val="accent1"/>
+          </a:fillRef>
+          <a:effectRef idx="1">
+            <a:schemeClr val="accent1"/>
+          </a:effectRef>
+          <a:fontRef idx="minor">
+            <a:schemeClr val="tx1"/>
+          </a:fontRef>
+        </p:style>
+      </p:cxnSp>
+      <p:sp>
+        <p:nvSpPr>
+          <p:cNvPr id="1005" name="Block"/>
+          <p:cNvSpPr/>
+          <p:nvPr/>
+        </p:nvSpPr>
+        <p:spPr>
+          <a:xfrm>
+            <a:off x="3849624" y="1188720"/>
+            <a:ext cx="1481328" cy="640080"/>
+          </a:xfrm>
+          <a:prstGeom prst="rect">
+            <a:avLst/>
+          </a:prstGeom>
+          <a:solidFill>
+            <a:srgbClr val="8E6F3E"/>
+          </a:solidFill>
+          <a:ln>
+            <a:noFill/>
+          </a:ln>
+          <a:effectLst/>
+        </p:spPr>
+        <p:style>
+          <a:lnRef idx="1">
+            <a:schemeClr val="accent1"/>
+          </a:lnRef>
+          <a:fillRef idx="3">
+            <a:schemeClr val="accent1"/>
+          </a:fillRef>
+          <a:effectRef idx="2">
+            <a:schemeClr val="accent1"/>
+          </a:effectRef>
+          <a:fontRef idx="minor">
+            <a:schemeClr val="lt1"/>
+          </a:fontRef>
+        </p:style>
+        <p:txBody>
+          <a:bodyPr wrap="square" lIns="27432" tIns="22860" rIns="27432" bIns="22860" rtlCol="0" anchor="ctr"/>
+          <a:lstStyle/>
+          <a:p>
+            <a:pPr algn="ctr"/>
+            <a:r>
+              <a:rPr sz="2000" b="1" i="0" dirty="0">
+                <a:solidFill>
+                  <a:srgbClr val="FFFFFF"/>
+                </a:solidFill>
+              </a:rPr>
+              <a:t>TEST</a:t>
+            </a:r>
+          </a:p>
+        </p:txBody>
+      </p:sp>
+      <p:cxnSp>
+        <p:nvCxnSpPr>
+          <p:cNvPr id="1006" name="Connector"/>
+          <p:cNvCxnSpPr/>
+          <p:nvPr/>
+        </p:nvCxnSpPr>
+        <p:spPr>
+          <a:xfrm>
+            <a:off x="3630168" y="1508760"/>
+            <a:ext cx="201168" cy="0"/>
+          </a:xfrm>
+          <a:prstGeom prst="line">
+            <a:avLst/>
+          </a:prstGeom>
+          <a:ln w="19050">
+            <a:solidFill>
+              <a:srgbClr val="8E6F3E"/>
+            </a:solidFill>
+            <a:tailEnd type="triangle"/>
+          </a:ln>
+        </p:spPr>
+        <p:style>
+          <a:lnRef idx="2">
+            <a:schemeClr val="accent1"/>
+          </a:lnRef>
+          <a:fillRef idx="0">
+            <a:schemeClr val="accent1"/>
+          </a:fillRef>
+          <a:effectRef idx="1">
+            <a:schemeClr val="accent1"/>
+          </a:effectRef>
+          <a:fontRef idx="minor">
+            <a:schemeClr val="tx1"/>
+          </a:fontRef>
+        </p:style>
+      </p:cxnSp>
+      <p:sp>
+        <p:nvSpPr>
+          <p:cNvPr id="1007" name="Block"/>
+          <p:cNvSpPr/>
+          <p:nvPr/>
+        </p:nvSpPr>
+        <p:spPr>
+          <a:xfrm>
+            <a:off x="5568696" y="1188720"/>
+            <a:ext cx="1481328" cy="640080"/>
+          </a:xfrm>
+          <a:prstGeom prst="rect">
+            <a:avLst/>
+          </a:prstGeom>
+          <a:solidFill>
+            <a:srgbClr val="8E6F3E"/>
+          </a:solidFill>
+          <a:ln>
+            <a:noFill/>
+          </a:ln>
+          <a:effectLst/>
+        </p:spPr>
+        <p:style>
+          <a:lnRef idx="1">
+            <a:schemeClr val="accent1"/>
+          </a:lnRef>
+          <a:fillRef idx="3">
+            <a:schemeClr val="accent1"/>
+          </a:fillRef>
+          <a:effectRef idx="2">
+            <a:schemeClr val="accent1"/>
+          </a:effectRef>
+          <a:fontRef idx="minor">
+            <a:schemeClr val="lt1"/>
+          </a:fontRef>
+        </p:style>
+        <p:txBody>
+          <a:bodyPr wrap="square" lIns="27432" tIns="22860" rIns="27432" bIns="22860" rtlCol="0" anchor="ctr"/>
+          <a:lstStyle/>
+          <a:p>
+            <a:pPr algn="ctr"/>
+            <a:r>
+              <a:rPr sz="2000" b="1" i="0" dirty="0">
+                <a:solidFill>
+                  <a:srgbClr val="FFFFFF"/>
+                </a:solidFill>
+              </a:rPr>
+              <a:t>PACKAGE</a:t>
+            </a:r>
+          </a:p>
+        </p:txBody>
+      </p:sp>
+      <p:cxnSp>
+        <p:nvCxnSpPr>
+          <p:cNvPr id="1008" name="Connector"/>
+          <p:cNvCxnSpPr/>
+          <p:nvPr/>
+        </p:nvCxnSpPr>
+        <p:spPr>
+          <a:xfrm>
+            <a:off x="5349240" y="1508760"/>
+            <a:ext cx="201168" cy="0"/>
+          </a:xfrm>
+          <a:prstGeom prst="line">
+            <a:avLst/>
+          </a:prstGeom>
+          <a:ln w="19050">
+            <a:solidFill>
+              <a:srgbClr val="8E6F3E"/>
+            </a:solidFill>
+            <a:tailEnd type="triangle"/>
+          </a:ln>
+        </p:spPr>
+        <p:style>
+          <a:lnRef idx="2">
+            <a:schemeClr val="accent1"/>
+          </a:lnRef>
+          <a:fillRef idx="0">
+            <a:schemeClr val="accent1"/>
+          </a:fillRef>
+          <a:effectRef idx="1">
+            <a:schemeClr val="accent1"/>
+          </a:effectRef>
+          <a:fontRef idx="minor">
+            <a:schemeClr val="tx1"/>
+          </a:fontRef>
+        </p:style>
+      </p:cxnSp>
+      <p:sp>
+        <p:nvSpPr>
+          <p:cNvPr id="1009" name="Block"/>
+          <p:cNvSpPr/>
+          <p:nvPr/>
+        </p:nvSpPr>
+        <p:spPr>
+          <a:xfrm>
+            <a:off x="7287768" y="1188720"/>
+            <a:ext cx="1481328" cy="640080"/>
+          </a:xfrm>
+          <a:prstGeom prst="rect">
+            <a:avLst/>
+          </a:prstGeom>
+          <a:solidFill>
+            <a:srgbClr val="8E6F3E"/>
+          </a:solidFill>
+          <a:ln>
+            <a:noFill/>
+          </a:ln>
+          <a:effectLst/>
+        </p:spPr>
+        <p:style>
+          <a:lnRef idx="1">
+            <a:schemeClr val="accent1"/>
+          </a:lnRef>
+          <a:fillRef idx="3">
+            <a:schemeClr val="accent1"/>
+          </a:fillRef>
+          <a:effectRef idx="2">
+            <a:schemeClr val="accent1"/>
+          </a:effectRef>
+          <a:fontRef idx="minor">
+            <a:schemeClr val="lt1"/>
+          </a:fontRef>
+        </p:style>
+        <p:txBody>
+          <a:bodyPr wrap="square" lIns="27432" tIns="22860" rIns="27432" bIns="22860" rtlCol="0" anchor="ctr"/>
+          <a:lstStyle/>
+          <a:p>
+            <a:pPr algn="ctr"/>
+            <a:r>
+              <a:rPr sz="2000" b="1" i="0" dirty="0">
+                <a:solidFill>
+                  <a:srgbClr val="FFFFFF"/>
+                </a:solidFill>
+              </a:rPr>
+              <a:t>DEPLOY</a:t>
+            </a:r>
+          </a:p>
+        </p:txBody>
+      </p:sp>
+      <p:cxnSp>
+        <p:nvCxnSpPr>
+          <p:cNvPr id="1010" name="Connector"/>
+          <p:cNvCxnSpPr/>
+          <p:nvPr/>
+        </p:nvCxnSpPr>
+        <p:spPr>
+          <a:xfrm>
+            <a:off x="7068312" y="1508760"/>
+            <a:ext cx="201168" cy="0"/>
+          </a:xfrm>
+          <a:prstGeom prst="line">
+            <a:avLst/>
+          </a:prstGeom>
+          <a:ln w="19050">
+            <a:solidFill>
+              <a:srgbClr val="8E6F3E"/>
+            </a:solidFill>
+            <a:tailEnd type="triangle"/>
+          </a:ln>
+        </p:spPr>
+        <p:style>
+          <a:lnRef idx="2">
+            <a:schemeClr val="accent1"/>
+          </a:lnRef>
+          <a:fillRef idx="0">
+            <a:schemeClr val="accent1"/>
+          </a:fillRef>
+          <a:effectRef idx="1">
+            <a:schemeClr val="accent1"/>
+          </a:effectRef>
+          <a:fontRef idx="minor">
+            <a:schemeClr val="tx1"/>
+          </a:fontRef>
+        </p:style>
+      </p:cxnSp>
+      <p:sp>
+        <p:nvSpPr>
+          <p:cNvPr id="1011" name="CodeCard"/>
+          <p:cNvSpPr/>
+          <p:nvPr/>
+        </p:nvSpPr>
+        <p:spPr>
+          <a:xfrm>
+            <a:off x="868680" y="2240280"/>
+            <a:ext cx="4297680" cy="2788920"/>
+          </a:xfrm>
+          <a:prstGeom prst="rect">
+            <a:avLst/>
+          </a:prstGeom>
+          <a:solidFill>
+            <a:srgbClr val="F5F1E8"/>
+          </a:solidFill>
+          <a:ln w="12700">
+            <a:solidFill>
+              <a:srgbClr val="C9B991"/>
+            </a:solidFill>
+          </a:ln>
+          <a:effectLst/>
+        </p:spPr>
+        <p:style>
+          <a:lnRef idx="1">
+            <a:schemeClr val="accent1"/>
+          </a:lnRef>
+          <a:fillRef idx="3">
+            <a:schemeClr val="accent1"/>
+          </a:fillRef>
+          <a:effectRef idx="2">
+            <a:schemeClr val="accent1"/>
+          </a:effectRef>
+          <a:fontRef idx="minor">
+            <a:schemeClr val="lt1"/>
+          </a:fontRef>
+        </p:style>
+        <p:txBody>
+          <a:bodyPr wrap="square" lIns="27432" tIns="22860" rIns="27432" bIns="22860" rtlCol="0" anchor="t"/>
+          <a:lstStyle/>
+          <a:p>
+            <a:pPr algn="l"/>
+            <a:r>
+              <a:rPr sz="2000" b="0" i="0" dirty="0">
+                <a:solidFill>
+                  <a:srgbClr val="5C4826"/>
+                </a:solidFill>
+                <a:latin typeface="Consolas"/>
+              </a:rPr>
+              <a:t>name: build-and-test</a:t>
+            </a:r>
+          </a:p>
+          <a:p>
+            <a:pPr algn="l">
+              <a:spcBef>
+                <a:spcPts val="200"/>
+              </a:spcBef>
+            </a:pPr>
+            <a:r>
+              <a:rPr sz="2000" b="0" i="0" dirty="0">
+                <a:solidFill>
+                  <a:srgbClr val="5C4826"/>
+                </a:solidFill>
+                <a:latin typeface="Consolas"/>
+              </a:rPr>
+              <a:t>on: pull_request</a:t>
+            </a:r>
+          </a:p>
+          <a:p>
+            <a:pPr algn="l">
+              <a:spcBef>
+                <a:spcPts val="200"/>
+              </a:spcBef>
+            </a:pPr>
+            <a:r>
+              <a:rPr sz="2000" b="0" i="0" dirty="0">
+                <a:solidFill>
+                  <a:srgbClr val="5C4826"/>
+                </a:solidFill>
+                <a:latin typeface="Consolas"/>
+              </a:rPr>
+              <a:t>jobs:</a:t>
+            </a:r>
+          </a:p>
+          <a:p>
+            <a:pPr algn="l">
+              <a:spcBef>
+                <a:spcPts val="200"/>
+              </a:spcBef>
+            </a:pPr>
+            <a:r>
+              <a:rPr sz="2000" b="0" i="0" dirty="0">
+                <a:solidFill>
+                  <a:srgbClr val="5C4826"/>
+                </a:solidFill>
+                <a:latin typeface="Consolas"/>
+              </a:rPr>
+              <a:t>  test:</a:t>
+            </a:r>
+          </a:p>
+          <a:p>
+            <a:pPr algn="l">
+              <a:spcBef>
+                <a:spcPts val="200"/>
+              </a:spcBef>
+            </a:pPr>
+            <a:r>
+              <a:rPr sz="2000" b="0" i="0" dirty="0">
+                <a:solidFill>
+                  <a:srgbClr val="5C4826"/>
+                </a:solidFill>
+                <a:latin typeface="Consolas"/>
+              </a:rPr>
+              <a:t>    steps:</a:t>
+            </a:r>
+          </a:p>
+          <a:p>
+            <a:pPr algn="l">
+              <a:spcBef>
+                <a:spcPts val="200"/>
+              </a:spcBef>
+            </a:pPr>
+            <a:r>
+              <a:rPr sz="2000" b="0" i="0" dirty="0">
+                <a:solidFill>
+                  <a:srgbClr val="5C4826"/>
+                </a:solidFill>
+                <a:latin typeface="Consolas"/>
+              </a:rPr>
+              <a:t>      - checkout</a:t>
+            </a:r>
+          </a:p>
+          <a:p>
+            <a:pPr algn="l">
+              <a:spcBef>
+                <a:spcPts val="200"/>
+              </a:spcBef>
+            </a:pPr>
+            <a:r>
+              <a:rPr sz="2000" b="0" i="0" dirty="0">
+                <a:solidFill>
+                  <a:srgbClr val="5C4826"/>
+                </a:solidFill>
+                <a:latin typeface="Consolas"/>
+              </a:rPr>
+              <a:t>      - build</a:t>
+            </a:r>
+          </a:p>
+          <a:p>
+            <a:pPr algn="l">
+              <a:spcBef>
+                <a:spcPts val="200"/>
+              </a:spcBef>
+            </a:pPr>
+            <a:r>
+              <a:rPr sz="2000" b="0" i="0" dirty="0">
+                <a:solidFill>
+                  <a:srgbClr val="5C4826"/>
+                </a:solidFill>
+                <a:latin typeface="Consolas"/>
+              </a:rPr>
+              <a:t>      - run tests</a:t>
+            </a:r>
+          </a:p>
+        </p:txBody>
+      </p:sp>
+      <p:sp>
+        <p:nvSpPr>
+          <p:cNvPr id="1012" name="Label"/>
+          <p:cNvSpPr/>
+          <p:nvPr/>
+        </p:nvSpPr>
+        <p:spPr>
+          <a:xfrm>
+            <a:off x="5486400" y="2468880"/>
+            <a:ext cx="3291840" cy="2103120"/>
+          </a:xfrm>
+          <a:prstGeom prst="rect">
+            <a:avLst/>
+          </a:prstGeom>
+          <a:noFill/>
+          <a:ln>
+            <a:noFill/>
+          </a:ln>
+          <a:effectLst/>
+        </p:spPr>
+        <p:style>
+          <a:lnRef idx="1">
+            <a:schemeClr val="accent1"/>
+          </a:lnRef>
+          <a:fillRef idx="3">
+            <a:schemeClr val="accent1"/>
+          </a:fillRef>
+          <a:effectRef idx="2">
+            <a:schemeClr val="accent1"/>
+          </a:effectRef>
+          <a:fontRef idx="minor">
+            <a:schemeClr val="lt1"/>
+          </a:fontRef>
+        </p:style>
+        <p:txBody>
+          <a:bodyPr wrap="square" lIns="27432" tIns="22860" rIns="27432" bIns="22860" rtlCol="0" anchor="ctr"/>
+          <a:lstStyle/>
+          <a:p>
+            <a:pPr algn="l"/>
+            <a:r>
+              <a:rPr sz="2000" b="0" i="0" dirty="0">
+                <a:solidFill>
+                  <a:srgbClr val="555960"/>
+                </a:solidFill>
+              </a:rPr>
+              <a:t>The workflow file declares the process.</a:t>
+            </a:r>
+          </a:p>
+          <a:p>
+            <a:pPr algn="l">
+              <a:spcBef>
+                <a:spcPts val="800"/>
+              </a:spcBef>
+            </a:pPr>
+            <a:r>
+              <a:rPr sz="2000" b="0" i="0" dirty="0">
+                <a:solidFill>
+                  <a:srgbClr val="555960"/>
+                </a:solidFill>
+              </a:rPr>
+              <a:t>The runner executes it, the same way, every time.</a:t>
+            </a:r>
+          </a:p>
+        </p:txBody>
+      </p:sp>
+    </p:spTree>
+  </p:cSld>
+  <p:clrMapOvr>
+    <a:masterClrMapping/>
+  </p:clrMapOvr>
+</p:sld>
+</file>
+
+<file path=ppt/slides/slide13.xml><?xml version="1.0" encoding="utf-8"?>
+<p:sld xmlns:a="http://schemas.openxmlformats.org/drawingml/2006/main" xmlns:p="http://schemas.openxmlformats.org/presentationml/2006/main" xmlns:r="http://schemas.openxmlformats.org/officeDocument/2006/relationships">
+  <p:cSld>
+    <p:spTree>
+      <p:nvGrpSpPr>
+        <p:cNvPr id="1" name=""/>
+        <p:cNvGrpSpPr/>
+        <p:nvPr/>
+      </p:nvGrpSpPr>
+      <p:grpSpPr/>
+      <p:sp>
+        <p:nvSpPr>
+          <p:cNvPr id="3" name="Title 2"/>
+          <p:cNvSpPr>
+            <a:spLocks noGrp="1"/>
+          </p:cNvSpPr>
+          <p:nvPr>
+            <p:ph type="title"/>
+          </p:nvPr>
+        </p:nvSpPr>
+        <p:spPr/>
+        <p:txBody>
+          <a:bodyPr wrap="square"/>
+          <a:lstStyle/>
+          <a:p>
+            <a:pPr algn="l"/>
+            <a:r>
+              <a:rPr sz="2400" b="0" i="0" dirty="0">
+                <a:solidFill>
+                  <a:srgbClr val="000000"/>
+                </a:solidFill>
+              </a:rPr>
+              <a:t>CI checks a proposed change before admission</a:t>
+            </a:r>
+          </a:p>
+        </p:txBody>
+      </p:sp>
+      <p:sp>
+        <p:nvSpPr>
+          <p:cNvPr id="1001" name="Slide Number Placeholder 900"/>
+          <p:cNvSpPr>
+            <a:spLocks noGrp="1"/>
+          </p:cNvSpPr>
+          <p:nvPr>
+            <p:ph type="sldNum" sz="quarter" idx="4"/>
+          </p:nvPr>
+        </p:nvSpPr>
+        <p:spPr/>
+        <p:txBody>
+          <a:bodyPr/>
+          <a:lstStyle/>
+          <a:p>
+            <a:fld id="{B3291E67-7172-4DCF-B35F-54404EBE6160}" type="slidenum">
+              <a:rPr lang="en-US" smtClean="0"/>
+              <a:t>1</a:t>
+            </a:fld>
+            <a:endParaRPr lang="en-US"/>
+          </a:p>
+        </p:txBody>
+      </p:sp>
+      <p:sp>
+        <p:nvSpPr>
+          <p:cNvPr id="1002" name="Block"/>
+          <p:cNvSpPr/>
+          <p:nvPr/>
+        </p:nvSpPr>
+        <p:spPr>
+          <a:xfrm>
+            <a:off x="411480" y="1828800"/>
+            <a:ext cx="2011680" cy="822960"/>
+          </a:xfrm>
+          <a:prstGeom prst="rect">
+            <a:avLst/>
+          </a:prstGeom>
+          <a:solidFill>
+            <a:srgbClr val="8E6F3E"/>
+          </a:solidFill>
+          <a:ln>
+            <a:noFill/>
+          </a:ln>
+          <a:effectLst/>
+        </p:spPr>
+        <p:style>
+          <a:lnRef idx="1">
+            <a:schemeClr val="accent1"/>
+          </a:lnRef>
+          <a:fillRef idx="3">
+            <a:schemeClr val="accent1"/>
+          </a:fillRef>
+          <a:effectRef idx="2">
+            <a:schemeClr val="accent1"/>
+          </a:effectRef>
+          <a:fontRef idx="minor">
+            <a:schemeClr val="lt1"/>
+          </a:fontRef>
+        </p:style>
+        <p:txBody>
+          <a:bodyPr wrap="square" lIns="27432" tIns="22860" rIns="27432" bIns="22860" rtlCol="0" anchor="ctr"/>
+          <a:lstStyle/>
+          <a:p>
+            <a:pPr algn="ctr"/>
+            <a:r>
+              <a:rPr sz="2000" b="1" i="0" dirty="0">
+                <a:solidFill>
+                  <a:srgbClr val="FFFFFF"/>
+                </a:solidFill>
+              </a:rPr>
+              <a:t>PROPOSED</a:t>
+            </a:r>
+          </a:p>
+          <a:p>
+            <a:pPr algn="ctr"/>
+            <a:r>
+              <a:rPr sz="2000" b="1" i="0" dirty="0">
+                <a:solidFill>
+                  <a:srgbClr val="FFFFFF"/>
+                </a:solidFill>
+              </a:rPr>
+              <a:t>CHANGE</a:t>
+            </a:r>
+          </a:p>
+        </p:txBody>
+      </p:sp>
+      <p:sp>
+        <p:nvSpPr>
+          <p:cNvPr id="1003" name="Block"/>
+          <p:cNvSpPr/>
+          <p:nvPr/>
+        </p:nvSpPr>
+        <p:spPr>
+          <a:xfrm>
+            <a:off x="3154680" y="1828800"/>
+            <a:ext cx="2011680" cy="822960"/>
+          </a:xfrm>
+          <a:prstGeom prst="rect">
+            <a:avLst/>
+          </a:prstGeom>
+          <a:solidFill>
+            <a:srgbClr val="8E6F3E"/>
+          </a:solidFill>
+          <a:ln>
+            <a:noFill/>
+          </a:ln>
+          <a:effectLst/>
+        </p:spPr>
+        <p:style>
+          <a:lnRef idx="1">
+            <a:schemeClr val="accent1"/>
+          </a:lnRef>
+          <a:fillRef idx="3">
+            <a:schemeClr val="accent1"/>
+          </a:fillRef>
+          <a:effectRef idx="2">
+            <a:schemeClr val="accent1"/>
+          </a:effectRef>
+          <a:fontRef idx="minor">
+            <a:schemeClr val="lt1"/>
+          </a:fontRef>
+        </p:style>
+        <p:txBody>
+          <a:bodyPr wrap="square" lIns="27432" tIns="22860" rIns="27432" bIns="22860" rtlCol="0" anchor="ctr"/>
+          <a:lstStyle/>
+          <a:p>
+            <a:pPr algn="ctr"/>
+            <a:r>
+              <a:rPr sz="2000" b="1" i="0" dirty="0">
+                <a:solidFill>
+                  <a:srgbClr val="FFFFFF"/>
+                </a:solidFill>
+              </a:rPr>
+              <a:t>AUTOMATED</a:t>
+            </a:r>
+          </a:p>
+          <a:p>
+            <a:pPr algn="ctr"/>
+            <a:r>
+              <a:rPr sz="2000" b="1" i="0" dirty="0">
+                <a:solidFill>
+                  <a:srgbClr val="FFFFFF"/>
+                </a:solidFill>
+              </a:rPr>
+              <a:t>CHECKS</a:t>
+            </a:r>
+          </a:p>
+        </p:txBody>
+      </p:sp>
+      <p:sp>
+        <p:nvSpPr>
+          <p:cNvPr id="1004" name="Card"/>
+          <p:cNvSpPr/>
+          <p:nvPr/>
+        </p:nvSpPr>
+        <p:spPr>
+          <a:xfrm>
+            <a:off x="5897880" y="1828800"/>
+            <a:ext cx="1280160" cy="822960"/>
+          </a:xfrm>
+          <a:prstGeom prst="rect">
+            <a:avLst/>
+          </a:prstGeom>
+          <a:solidFill>
+            <a:srgbClr val="F5F1E8"/>
+          </a:solidFill>
+          <a:ln w="12700">
+            <a:solidFill>
+              <a:srgbClr val="C9B991"/>
+            </a:solidFill>
+          </a:ln>
+          <a:effectLst/>
+        </p:spPr>
+        <p:style>
+          <a:lnRef idx="1">
+            <a:schemeClr val="accent1"/>
+          </a:lnRef>
+          <a:fillRef idx="3">
+            <a:schemeClr val="accent1"/>
+          </a:fillRef>
+          <a:effectRef idx="2">
+            <a:schemeClr val="accent1"/>
+          </a:effectRef>
+          <a:fontRef idx="minor">
+            <a:schemeClr val="lt1"/>
+          </a:fontRef>
+        </p:style>
+        <p:txBody>
+          <a:bodyPr wrap="square" lIns="27432" tIns="22860" rIns="27432" bIns="22860" rtlCol="0" anchor="ctr"/>
+          <a:lstStyle/>
+          <a:p>
+            <a:pPr algn="ctr"/>
+            <a:r>
+              <a:rPr sz="2000" b="1" i="0" dirty="0">
+                <a:solidFill>
+                  <a:srgbClr val="5C4826"/>
+                </a:solidFill>
+              </a:rPr>
+              <a:t>pass?</a:t>
+            </a:r>
+          </a:p>
+        </p:txBody>
+      </p:sp>
+      <p:sp>
+        <p:nvSpPr>
+          <p:cNvPr id="1005" name="Block"/>
+          <p:cNvSpPr/>
+          <p:nvPr/>
+        </p:nvSpPr>
+        <p:spPr>
+          <a:xfrm>
+            <a:off x="7635240" y="1828800"/>
+            <a:ext cx="1188720" cy="822960"/>
+          </a:xfrm>
+          <a:prstGeom prst="rect">
+            <a:avLst/>
+          </a:prstGeom>
+          <a:solidFill>
+            <a:srgbClr val="8E6F3E"/>
+          </a:solidFill>
+          <a:ln>
+            <a:noFill/>
+          </a:ln>
+          <a:effectLst/>
+        </p:spPr>
+        <p:style>
+          <a:lnRef idx="1">
+            <a:schemeClr val="accent1"/>
+          </a:lnRef>
+          <a:fillRef idx="3">
+            <a:schemeClr val="accent1"/>
+          </a:fillRef>
+          <a:effectRef idx="2">
+            <a:schemeClr val="accent1"/>
+          </a:effectRef>
+          <a:fontRef idx="minor">
+            <a:schemeClr val="lt1"/>
+          </a:fontRef>
+        </p:style>
+        <p:txBody>
+          <a:bodyPr wrap="square" lIns="27432" tIns="22860" rIns="27432" bIns="22860" rtlCol="0" anchor="ctr"/>
+          <a:lstStyle/>
+          <a:p>
+            <a:pPr algn="ctr"/>
+            <a:r>
+              <a:rPr sz="2000" b="1" i="0" dirty="0">
+                <a:solidFill>
+                  <a:srgbClr val="FFFFFF"/>
+                </a:solidFill>
+              </a:rPr>
+              <a:t>MERGE</a:t>
+            </a:r>
+          </a:p>
+        </p:txBody>
+      </p:sp>
+      <p:cxnSp>
+        <p:nvCxnSpPr>
+          <p:cNvPr id="1006" name="Connector"/>
+          <p:cNvCxnSpPr/>
+          <p:nvPr/>
+        </p:nvCxnSpPr>
+        <p:spPr>
+          <a:xfrm>
+            <a:off x="2441448" y="2240280"/>
+            <a:ext cx="694944" cy="0"/>
+          </a:xfrm>
+          <a:prstGeom prst="line">
+            <a:avLst/>
+          </a:prstGeom>
+          <a:ln w="19050">
+            <a:solidFill>
+              <a:srgbClr val="8E6F3E"/>
+            </a:solidFill>
+            <a:tailEnd type="triangle"/>
+          </a:ln>
+        </p:spPr>
+        <p:style>
+          <a:lnRef idx="2">
+            <a:schemeClr val="accent1"/>
+          </a:lnRef>
+          <a:fillRef idx="0">
+            <a:schemeClr val="accent1"/>
+          </a:fillRef>
+          <a:effectRef idx="1">
+            <a:schemeClr val="accent1"/>
+          </a:effectRef>
+          <a:fontRef idx="minor">
+            <a:schemeClr val="tx1"/>
+          </a:fontRef>
+        </p:style>
+      </p:cxnSp>
+      <p:cxnSp>
+        <p:nvCxnSpPr>
+          <p:cNvPr id="1007" name="Connector"/>
+          <p:cNvCxnSpPr/>
+          <p:nvPr/>
+        </p:nvCxnSpPr>
+        <p:spPr>
+          <a:xfrm>
+            <a:off x="5184648" y="2240280"/>
+            <a:ext cx="694944" cy="0"/>
+          </a:xfrm>
+          <a:prstGeom prst="line">
+            <a:avLst/>
+          </a:prstGeom>
+          <a:ln w="19050">
+            <a:solidFill>
+              <a:srgbClr val="8E6F3E"/>
+            </a:solidFill>
+            <a:tailEnd type="triangle"/>
+          </a:ln>
+        </p:spPr>
+        <p:style>
+          <a:lnRef idx="2">
+            <a:schemeClr val="accent1"/>
+          </a:lnRef>
+          <a:fillRef idx="0">
+            <a:schemeClr val="accent1"/>
+          </a:fillRef>
+          <a:effectRef idx="1">
+            <a:schemeClr val="accent1"/>
+          </a:effectRef>
+          <a:fontRef idx="minor">
+            <a:schemeClr val="tx1"/>
+          </a:fontRef>
+        </p:style>
+      </p:cxnSp>
+      <p:cxnSp>
+        <p:nvCxnSpPr>
+          <p:cNvPr id="1008" name="Connector"/>
+          <p:cNvCxnSpPr/>
+          <p:nvPr/>
+        </p:nvCxnSpPr>
+        <p:spPr>
+          <a:xfrm>
+            <a:off x="7196328" y="2240280"/>
+            <a:ext cx="420624" cy="0"/>
+          </a:xfrm>
+          <a:prstGeom prst="line">
+            <a:avLst/>
+          </a:prstGeom>
+          <a:ln w="19050">
+            <a:solidFill>
+              <a:srgbClr val="8E6F3E"/>
+            </a:solidFill>
+            <a:tailEnd type="triangle"/>
+          </a:ln>
+        </p:spPr>
+        <p:style>
+          <a:lnRef idx="2">
+            <a:schemeClr val="accent1"/>
+          </a:lnRef>
+          <a:fillRef idx="0">
+            <a:schemeClr val="accent1"/>
+          </a:fillRef>
+          <a:effectRef idx="1">
+            <a:schemeClr val="accent1"/>
+          </a:effectRef>
+          <a:fontRef idx="minor">
+            <a:schemeClr val="tx1"/>
+          </a:fontRef>
+        </p:style>
+      </p:cxnSp>
+      <p:sp>
+        <p:nvSpPr>
+          <p:cNvPr id="1009" name="Label"/>
+          <p:cNvSpPr/>
+          <p:nvPr/>
+        </p:nvSpPr>
+        <p:spPr>
+          <a:xfrm>
+            <a:off x="7059168" y="1389888"/>
+            <a:ext cx="731520" cy="365760"/>
+          </a:xfrm>
+          <a:prstGeom prst="rect">
+            <a:avLst/>
+          </a:prstGeom>
+          <a:noFill/>
+          <a:ln>
+            <a:noFill/>
+          </a:ln>
+          <a:effectLst/>
+        </p:spPr>
+        <p:style>
+          <a:lnRef idx="1">
+            <a:schemeClr val="accent1"/>
+          </a:lnRef>
+          <a:fillRef idx="3">
+            <a:schemeClr val="accent1"/>
+          </a:fillRef>
+          <a:effectRef idx="2">
+            <a:schemeClr val="accent1"/>
+          </a:effectRef>
+          <a:fontRef idx="minor">
+            <a:schemeClr val="lt1"/>
+          </a:fontRef>
+        </p:style>
+        <p:txBody>
+          <a:bodyPr wrap="square" lIns="27432" tIns="22860" rIns="27432" bIns="22860" rtlCol="0" anchor="ctr"/>
+          <a:lstStyle/>
+          <a:p>
+            <a:pPr algn="ctr"/>
+            <a:r>
+              <a:rPr sz="2000" b="0" i="0" dirty="0">
+                <a:solidFill>
+                  <a:srgbClr val="555960"/>
+                </a:solidFill>
+              </a:rPr>
+              <a:t>yes</a:t>
+            </a:r>
+          </a:p>
+        </p:txBody>
+      </p:sp>
+      <p:sp>
+        <p:nvSpPr>
+          <p:cNvPr id="1010" name="Card"/>
+          <p:cNvSpPr/>
+          <p:nvPr/>
+        </p:nvSpPr>
+        <p:spPr>
+          <a:xfrm>
+            <a:off x="3154680" y="3657600"/>
+            <a:ext cx="2011680" cy="731520"/>
+          </a:xfrm>
+          <a:prstGeom prst="rect">
+            <a:avLst/>
+          </a:prstGeom>
+          <a:solidFill>
+            <a:srgbClr val="F5F1E8"/>
+          </a:solidFill>
+          <a:ln w="12700">
+            <a:solidFill>
+              <a:srgbClr val="C9B991"/>
+            </a:solidFill>
+          </a:ln>
+          <a:effectLst/>
+        </p:spPr>
+        <p:style>
+          <a:lnRef idx="1">
+            <a:schemeClr val="accent1"/>
+          </a:lnRef>
+          <a:fillRef idx="3">
+            <a:schemeClr val="accent1"/>
+          </a:fillRef>
+          <a:effectRef idx="2">
+            <a:schemeClr val="accent1"/>
+          </a:effectRef>
+          <a:fontRef idx="minor">
+            <a:schemeClr val="lt1"/>
+          </a:fontRef>
+        </p:style>
+        <p:txBody>
+          <a:bodyPr wrap="square" lIns="27432" tIns="22860" rIns="27432" bIns="22860" rtlCol="0" anchor="ctr"/>
+          <a:lstStyle/>
+          <a:p>
+            <a:pPr algn="ctr"/>
+            <a:r>
+              <a:rPr sz="2000" b="1" i="0" dirty="0">
+                <a:solidFill>
+                  <a:srgbClr val="5C4826"/>
+                </a:solidFill>
+              </a:rPr>
+              <a:t>REVISE</a:t>
+            </a:r>
+          </a:p>
+        </p:txBody>
+      </p:sp>
+      <p:cxnSp>
+        <p:nvCxnSpPr>
+          <p:cNvPr id="1011" name="Connector"/>
+          <p:cNvCxnSpPr/>
+          <p:nvPr/>
+        </p:nvCxnSpPr>
+        <p:spPr>
+          <a:xfrm>
+            <a:off x="6537960" y="2670048"/>
+            <a:ext cx="0" cy="1353312"/>
+          </a:xfrm>
+          <a:prstGeom prst="line">
+            <a:avLst/>
+          </a:prstGeom>
+          <a:ln w="19050">
+            <a:solidFill>
+              <a:srgbClr val="8E6F3E"/>
+            </a:solidFill>
+          </a:ln>
+        </p:spPr>
+        <p:style>
+          <a:lnRef idx="2">
+            <a:schemeClr val="accent1"/>
+          </a:lnRef>
+          <a:fillRef idx="0">
+            <a:schemeClr val="accent1"/>
+          </a:fillRef>
+          <a:effectRef idx="1">
+            <a:schemeClr val="accent1"/>
+          </a:effectRef>
+          <a:fontRef idx="minor">
+            <a:schemeClr val="tx1"/>
+          </a:fontRef>
+        </p:style>
+      </p:cxnSp>
+      <p:cxnSp>
+        <p:nvCxnSpPr>
+          <p:cNvPr id="1012" name="Connector"/>
+          <p:cNvCxnSpPr/>
+          <p:nvPr/>
+        </p:nvCxnSpPr>
+        <p:spPr>
+          <a:xfrm flipH="1">
+            <a:off x="5184648" y="4023360"/>
+            <a:ext cx="1353312" cy="0"/>
+          </a:xfrm>
+          <a:prstGeom prst="line">
+            <a:avLst/>
+          </a:prstGeom>
+          <a:ln w="19050">
+            <a:solidFill>
+              <a:srgbClr val="8E6F3E"/>
+            </a:solidFill>
+            <a:tailEnd type="triangle"/>
+          </a:ln>
+        </p:spPr>
+        <p:style>
+          <a:lnRef idx="2">
+            <a:schemeClr val="accent1"/>
+          </a:lnRef>
+          <a:fillRef idx="0">
+            <a:schemeClr val="accent1"/>
+          </a:fillRef>
+          <a:effectRef idx="1">
+            <a:schemeClr val="accent1"/>
+          </a:effectRef>
+          <a:fontRef idx="minor">
+            <a:schemeClr val="tx1"/>
+          </a:fontRef>
+        </p:style>
+      </p:cxnSp>
+      <p:sp>
+        <p:nvSpPr>
+          <p:cNvPr id="1013" name="Label"/>
+          <p:cNvSpPr/>
+          <p:nvPr/>
+        </p:nvSpPr>
+        <p:spPr>
+          <a:xfrm>
+            <a:off x="6675120" y="2788920"/>
+            <a:ext cx="822960" cy="365760"/>
+          </a:xfrm>
+          <a:prstGeom prst="rect">
+            <a:avLst/>
+          </a:prstGeom>
+          <a:noFill/>
+          <a:ln>
+            <a:noFill/>
+          </a:ln>
+          <a:effectLst/>
+        </p:spPr>
+        <p:style>
+          <a:lnRef idx="1">
+            <a:schemeClr val="accent1"/>
+          </a:lnRef>
+          <a:fillRef idx="3">
+            <a:schemeClr val="accent1"/>
+          </a:fillRef>
+          <a:effectRef idx="2">
+            <a:schemeClr val="accent1"/>
+          </a:effectRef>
+          <a:fontRef idx="minor">
+            <a:schemeClr val="lt1"/>
+          </a:fontRef>
+        </p:style>
+        <p:txBody>
+          <a:bodyPr wrap="square" lIns="27432" tIns="22860" rIns="27432" bIns="22860" rtlCol="0" anchor="ctr"/>
+          <a:lstStyle/>
+          <a:p>
+            <a:pPr algn="l"/>
+            <a:r>
+              <a:rPr sz="2000" b="0" i="0" dirty="0">
+                <a:solidFill>
+                  <a:srgbClr val="555960"/>
+                </a:solidFill>
+              </a:rPr>
+              <a:t>no</a:t>
+            </a:r>
+          </a:p>
+        </p:txBody>
+      </p:sp>
+      <p:cxnSp>
+        <p:nvCxnSpPr>
+          <p:cNvPr id="1014" name="Connector"/>
+          <p:cNvCxnSpPr/>
+          <p:nvPr/>
+        </p:nvCxnSpPr>
+        <p:spPr>
+          <a:xfrm flipV="1">
+            <a:off x="4160520" y="2670048"/>
+            <a:ext cx="0" cy="969264"/>
+          </a:xfrm>
+          <a:prstGeom prst="line">
+            <a:avLst/>
+          </a:prstGeom>
+          <a:ln w="19050">
+            <a:solidFill>
+              <a:srgbClr val="8E6F3E"/>
+            </a:solidFill>
+            <a:tailEnd type="triangle"/>
+          </a:ln>
+        </p:spPr>
+        <p:style>
+          <a:lnRef idx="2">
+            <a:schemeClr val="accent1"/>
+          </a:lnRef>
+          <a:fillRef idx="0">
+            <a:schemeClr val="accent1"/>
+          </a:fillRef>
+          <a:effectRef idx="1">
+            <a:schemeClr val="accent1"/>
+          </a:effectRef>
+          <a:fontRef idx="minor">
+            <a:schemeClr val="tx1"/>
+          </a:fontRef>
+        </p:style>
+      </p:cxnSp>
+    </p:spTree>
+  </p:cSld>
+  <p:clrMapOvr>
+    <a:masterClrMapping/>
+  </p:clrMapOvr>
+</p:sld>
+</file>
+
+<file path=ppt/slides/slide14.xml><?xml version="1.0" encoding="utf-8"?>
+<p:sld xmlns:a="http://schemas.openxmlformats.org/drawingml/2006/main" xmlns:p="http://schemas.openxmlformats.org/presentationml/2006/main" xmlns:r="http://schemas.openxmlformats.org/officeDocument/2006/relationships">
+  <p:cSld>
+    <p:spTree>
+      <p:nvGrpSpPr>
+        <p:cNvPr id="1" name=""/>
+        <p:cNvGrpSpPr/>
+        <p:nvPr/>
+      </p:nvGrpSpPr>
+      <p:grpSpPr/>
+      <p:sp>
+        <p:nvSpPr>
+          <p:cNvPr id="3" name="Title 2"/>
+          <p:cNvSpPr>
+            <a:spLocks noGrp="1"/>
+          </p:cNvSpPr>
+          <p:nvPr>
+            <p:ph type="title"/>
+          </p:nvPr>
+        </p:nvSpPr>
+        <p:spPr/>
+        <p:txBody>
+          <a:bodyPr wrap="square"/>
+          <a:lstStyle/>
+          <a:p>
+            <a:pPr algn="l"/>
+            <a:r>
+              <a:rPr sz="2400" b="0" i="0" dirty="0">
+                <a:solidFill>
+                  <a:srgbClr val="000000"/>
+                </a:solidFill>
+              </a:rPr>
+              <a:t>CI/CD provides evidence before changes are admitted</a:t>
+            </a:r>
+          </a:p>
+        </p:txBody>
+      </p:sp>
+      <p:sp>
+        <p:nvSpPr>
+          <p:cNvPr id="1001" name="Slide Number Placeholder 900"/>
+          <p:cNvSpPr>
+            <a:spLocks noGrp="1"/>
+          </p:cNvSpPr>
+          <p:nvPr>
+            <p:ph type="sldNum" sz="quarter" idx="4"/>
+          </p:nvPr>
+        </p:nvSpPr>
+        <p:spPr/>
+        <p:txBody>
+          <a:bodyPr/>
+          <a:lstStyle/>
+          <a:p>
+            <a:fld id="{B3291E67-7172-4DCF-B35F-54404EBE6160}" type="slidenum">
+              <a:rPr lang="en-US" smtClean="0"/>
+              <a:t>1</a:t>
+            </a:fld>
+            <a:endParaRPr lang="en-US"/>
+          </a:p>
+        </p:txBody>
+      </p:sp>
+      <p:sp>
+        <p:nvSpPr>
+          <p:cNvPr id="1002" name="ChecksPanel"/>
+          <p:cNvSpPr/>
+          <p:nvPr/>
+        </p:nvSpPr>
+        <p:spPr>
+          <a:xfrm>
+            <a:off x="411480" y="1188720"/>
+            <a:ext cx="4206240" cy="3566160"/>
+          </a:xfrm>
+          <a:prstGeom prst="rect">
+            <a:avLst/>
+          </a:prstGeom>
+          <a:solidFill>
+            <a:srgbClr val="F5F1E8"/>
+          </a:solidFill>
+          <a:ln w="12700">
+            <a:solidFill>
+              <a:srgbClr val="C9B991"/>
+            </a:solidFill>
+          </a:ln>
+          <a:effectLst/>
+        </p:spPr>
+        <p:style>
+          <a:lnRef idx="1">
+            <a:schemeClr val="accent1"/>
+          </a:lnRef>
+          <a:fillRef idx="3">
+            <a:schemeClr val="accent1"/>
+          </a:fillRef>
+          <a:effectRef idx="2">
+            <a:schemeClr val="accent1"/>
+          </a:effectRef>
+          <a:fontRef idx="minor">
+            <a:schemeClr val="lt1"/>
+          </a:fontRef>
+        </p:style>
+        <p:txBody>
+          <a:bodyPr wrap="square" lIns="27432" tIns="22860" rIns="27432" bIns="22860" rtlCol="0" anchor="t"/>
+          <a:lstStyle/>
+          <a:p>
+            <a:pPr algn="l"/>
+            <a:r>
+              <a:rPr sz="2000" b="1" i="0" dirty="0">
+                <a:solidFill>
+                  <a:srgbClr val="5C4826"/>
+                </a:solidFill>
+              </a:rPr>
+              <a:t>checks, pull request #214</a:t>
+            </a:r>
+          </a:p>
+          <a:p>
+            <a:pPr algn="l">
+              <a:spcBef>
+                <a:spcPts val="800"/>
+              </a:spcBef>
+            </a:pPr>
+            <a:r>
+              <a:rPr sz="2000" b="0" i="0" dirty="0">
+                <a:solidFill>
+                  <a:srgbClr val="5C4826"/>
+                </a:solidFill>
+              </a:rPr>
+              <a:t>build</a:t>
+            </a:r>
+            <a:r>
+              <a:rPr sz="2000" b="1" i="0" dirty="0">
+                <a:solidFill>
+                  <a:srgbClr val="5C4826"/>
+                </a:solidFill>
+              </a:rPr>
+              <a:t>   pass</a:t>
+            </a:r>
+          </a:p>
+          <a:p>
+            <a:pPr algn="l">
+              <a:spcBef>
+                <a:spcPts val="400"/>
+              </a:spcBef>
+            </a:pPr>
+            <a:r>
+              <a:rPr sz="2000" b="0" i="0" dirty="0">
+                <a:solidFill>
+                  <a:srgbClr val="5C4826"/>
+                </a:solidFill>
+              </a:rPr>
+              <a:t>unit tests</a:t>
+            </a:r>
+            <a:r>
+              <a:rPr sz="2000" b="1" i="0" dirty="0">
+                <a:solidFill>
+                  <a:srgbClr val="5C4826"/>
+                </a:solidFill>
+              </a:rPr>
+              <a:t>   pass</a:t>
+            </a:r>
+          </a:p>
+          <a:p>
+            <a:pPr algn="l">
+              <a:spcBef>
+                <a:spcPts val="400"/>
+              </a:spcBef>
+            </a:pPr>
+            <a:r>
+              <a:rPr sz="2000" b="0" i="0" dirty="0">
+                <a:solidFill>
+                  <a:srgbClr val="5C4826"/>
+                </a:solidFill>
+              </a:rPr>
+              <a:t>lint</a:t>
+            </a:r>
+            <a:r>
+              <a:rPr sz="2000" b="1" i="0" dirty="0">
+                <a:solidFill>
+                  <a:srgbClr val="5C4826"/>
+                </a:solidFill>
+              </a:rPr>
+              <a:t>   pass</a:t>
+            </a:r>
+          </a:p>
+          <a:p>
+            <a:pPr algn="l">
+              <a:spcBef>
+                <a:spcPts val="400"/>
+              </a:spcBef>
+            </a:pPr>
+            <a:r>
+              <a:rPr sz="2000" b="0" i="0" dirty="0">
+                <a:solidFill>
+                  <a:srgbClr val="5C4826"/>
+                </a:solidFill>
+              </a:rPr>
+              <a:t>integration</a:t>
+            </a:r>
+            <a:r>
+              <a:rPr sz="2000" b="1" i="0" dirty="0">
+                <a:solidFill>
+                  <a:srgbClr val="C01B1B"/>
+                </a:solidFill>
+              </a:rPr>
+              <a:t>   FAIL</a:t>
+            </a:r>
+          </a:p>
+          <a:p>
+            <a:pPr algn="l">
+              <a:spcBef>
+                <a:spcPts val="400"/>
+              </a:spcBef>
+            </a:pPr>
+            <a:r>
+              <a:rPr sz="2000" b="0" i="0" dirty="0">
+                <a:solidFill>
+                  <a:srgbClr val="5C4826"/>
+                </a:solidFill>
+              </a:rPr>
+              <a:t>coverage</a:t>
+            </a:r>
+            <a:r>
+              <a:rPr sz="2000" b="1" i="0" dirty="0">
+                <a:solidFill>
+                  <a:srgbClr val="5C4826"/>
+                </a:solidFill>
+              </a:rPr>
+              <a:t>   pass</a:t>
+            </a:r>
+          </a:p>
+          <a:p>
+            <a:pPr algn="l">
+              <a:spcBef>
+                <a:spcPts val="1000"/>
+              </a:spcBef>
+            </a:pPr>
+            <a:r>
+              <a:rPr sz="2000" b="0" i="1" dirty="0">
+                <a:solidFill>
+                  <a:srgbClr val="C01B1B"/>
+                </a:solidFill>
+              </a:rPr>
+              <a:t>merging is blocked</a:t>
+            </a:r>
+          </a:p>
+        </p:txBody>
+      </p:sp>
+      <p:sp>
+        <p:nvSpPr>
+          <p:cNvPr id="1003" name="Label"/>
+          <p:cNvSpPr/>
+          <p:nvPr/>
+        </p:nvSpPr>
+        <p:spPr>
+          <a:xfrm>
+            <a:off x="5029200" y="1371600"/>
+            <a:ext cx="3749040" cy="3108960"/>
+          </a:xfrm>
+          <a:prstGeom prst="rect">
+            <a:avLst/>
+          </a:prstGeom>
+          <a:noFill/>
+          <a:ln>
+            <a:noFill/>
+          </a:ln>
+          <a:effectLst/>
+        </p:spPr>
+        <p:style>
+          <a:lnRef idx="1">
+            <a:schemeClr val="accent1"/>
+          </a:lnRef>
+          <a:fillRef idx="3">
+            <a:schemeClr val="accent1"/>
+          </a:fillRef>
+          <a:effectRef idx="2">
+            <a:schemeClr val="accent1"/>
+          </a:effectRef>
+          <a:fontRef idx="minor">
+            <a:schemeClr val="lt1"/>
+          </a:fontRef>
+        </p:style>
+        <p:txBody>
+          <a:bodyPr wrap="square" lIns="27432" tIns="22860" rIns="27432" bIns="22860" rtlCol="0" anchor="ctr"/>
+          <a:lstStyle/>
+          <a:p>
+            <a:pPr algn="l"/>
+            <a:r>
+              <a:rPr sz="2000" b="0" i="0" dirty="0">
+                <a:solidFill>
+                  <a:srgbClr val="555960"/>
+                </a:solidFill>
+              </a:rPr>
+              <a:t>Every stage emits evidence.</a:t>
+            </a:r>
+          </a:p>
+          <a:p>
+            <a:pPr algn="l">
+              <a:spcBef>
+                <a:spcPts val="1000"/>
+              </a:spcBef>
+            </a:pPr>
+            <a:r>
+              <a:rPr sz="2000" b="0" i="0" dirty="0">
+                <a:solidFill>
+                  <a:srgbClr val="555960"/>
+                </a:solidFill>
+              </a:rPr>
+              <a:t>One red check stops admission.</a:t>
+            </a:r>
+          </a:p>
+          <a:p>
+            <a:pPr algn="l">
+              <a:spcBef>
+                <a:spcPts val="1000"/>
+              </a:spcBef>
+            </a:pPr>
+            <a:r>
+              <a:rPr sz="2000" b="0" i="0" dirty="0">
+                <a:solidFill>
+                  <a:srgbClr val="555960"/>
+                </a:solidFill>
+              </a:rPr>
+              <a:t>Speed is a side effect; the goal is confidence in each change.</a:t>
+            </a:r>
+          </a:p>
+        </p:txBody>
+      </p:sp>
+    </p:spTree>
+  </p:cSld>
+  <p:clrMapOvr>
+    <a:masterClrMapping/>
+  </p:clrMapOvr>
+</p:sld>
+</file>
+
+<file path=ppt/slides/slide15.xml><?xml version="1.0" encoding="utf-8"?>
+<p:sld xmlns:a="http://schemas.openxmlformats.org/drawingml/2006/main" xmlns:p="http://schemas.openxmlformats.org/presentationml/2006/main" xmlns:r="http://schemas.openxmlformats.org/officeDocument/2006/relationships">
+  <p:cSld>
+    <p:spTree>
+      <p:nvGrpSpPr>
+        <p:cNvPr id="1" name=""/>
+        <p:cNvGrpSpPr/>
+        <p:nvPr/>
+      </p:nvGrpSpPr>
+      <p:grpSpPr/>
+      <p:sp>
+        <p:nvSpPr>
+          <p:cNvPr id="3" name="Title 2"/>
+          <p:cNvSpPr>
+            <a:spLocks noGrp="1"/>
+          </p:cNvSpPr>
+          <p:nvPr>
+            <p:ph type="title"/>
+          </p:nvPr>
+        </p:nvSpPr>
+        <p:spPr/>
+        <p:txBody>
+          <a:bodyPr wrap="square"/>
+          <a:lstStyle/>
+          <a:p>
+            <a:pPr algn="l"/>
+            <a:r>
+              <a:rPr sz="2400" b="0" i="0" dirty="0">
+                <a:solidFill>
+                  <a:srgbClr val="000000"/>
+                </a:solidFill>
+              </a:rPr>
+              <a:t>What can go wrong with CI/CD?</a:t>
+            </a:r>
+          </a:p>
+        </p:txBody>
+      </p:sp>
+      <p:sp>
+        <p:nvSpPr>
+          <p:cNvPr id="1001" name="Slide Number Placeholder 900"/>
+          <p:cNvSpPr>
+            <a:spLocks noGrp="1"/>
+          </p:cNvSpPr>
+          <p:nvPr>
+            <p:ph type="sldNum" sz="quarter" idx="4"/>
+          </p:nvPr>
+        </p:nvSpPr>
+        <p:spPr/>
+        <p:txBody>
+          <a:bodyPr/>
+          <a:lstStyle/>
+          <a:p>
+            <a:fld id="{B3291E67-7172-4DCF-B35F-54404EBE6160}" type="slidenum">
+              <a:rPr lang="en-US" smtClean="0"/>
+              <a:t>1</a:t>
+            </a:fld>
+            <a:endParaRPr lang="en-US"/>
+          </a:p>
+        </p:txBody>
+      </p:sp>
+      <p:sp>
+        <p:nvSpPr>
+          <p:cNvPr id="1002" name="Card"/>
+          <p:cNvSpPr/>
+          <p:nvPr/>
+        </p:nvSpPr>
+        <p:spPr>
+          <a:xfrm>
+            <a:off x="365760" y="1280160"/>
+            <a:ext cx="2651760" cy="2103120"/>
+          </a:xfrm>
+          <a:prstGeom prst="rect">
+            <a:avLst/>
+          </a:prstGeom>
+          <a:solidFill>
+            <a:srgbClr val="F5F1E8"/>
+          </a:solidFill>
+          <a:ln w="12700">
+            <a:solidFill>
+              <a:srgbClr val="C9B991"/>
+            </a:solidFill>
+          </a:ln>
+          <a:effectLst/>
+        </p:spPr>
+        <p:style>
+          <a:lnRef idx="1">
+            <a:schemeClr val="accent1"/>
+          </a:lnRef>
+          <a:fillRef idx="3">
+            <a:schemeClr val="accent1"/>
+          </a:fillRef>
+          <a:effectRef idx="2">
+            <a:schemeClr val="accent1"/>
+          </a:effectRef>
+          <a:fontRef idx="minor">
+            <a:schemeClr val="lt1"/>
+          </a:fontRef>
+        </p:style>
+        <p:txBody>
+          <a:bodyPr wrap="square" lIns="27432" tIns="22860" rIns="27432" bIns="22860" rtlCol="0" anchor="t"/>
+          <a:lstStyle/>
+          <a:p>
+            <a:pPr algn="ctr"/>
+            <a:r>
+              <a:rPr sz="2000" b="1" i="0" dirty="0">
+                <a:solidFill>
+                  <a:srgbClr val="5C4826"/>
+                </a:solidFill>
+              </a:rPr>
+              <a:t>FLAKY TESTS</a:t>
+            </a:r>
+          </a:p>
+          <a:p>
+            <a:pPr algn="ctr">
+              <a:spcBef>
+                <a:spcPts val="800"/>
+              </a:spcBef>
+            </a:pPr>
+            <a:r>
+              <a:rPr sz="2000" b="0" i="0" dirty="0">
+                <a:solidFill>
+                  <a:srgbClr val="5C4826"/>
+                </a:solidFill>
+              </a:rPr>
+              <a:t>same code, different verdicts; trust erodes</a:t>
+            </a:r>
+          </a:p>
+        </p:txBody>
+      </p:sp>
+      <p:sp>
+        <p:nvSpPr>
+          <p:cNvPr id="1003" name="Card"/>
+          <p:cNvSpPr/>
+          <p:nvPr/>
+        </p:nvSpPr>
+        <p:spPr>
+          <a:xfrm>
+            <a:off x="3246120" y="1280160"/>
+            <a:ext cx="2651760" cy="2103120"/>
+          </a:xfrm>
+          <a:prstGeom prst="rect">
+            <a:avLst/>
+          </a:prstGeom>
+          <a:solidFill>
+            <a:srgbClr val="F5F1E8"/>
+          </a:solidFill>
+          <a:ln w="12700">
+            <a:solidFill>
+              <a:srgbClr val="C9B991"/>
+            </a:solidFill>
+          </a:ln>
+          <a:effectLst/>
+        </p:spPr>
+        <p:style>
+          <a:lnRef idx="1">
+            <a:schemeClr val="accent1"/>
+          </a:lnRef>
+          <a:fillRef idx="3">
+            <a:schemeClr val="accent1"/>
+          </a:fillRef>
+          <a:effectRef idx="2">
+            <a:schemeClr val="accent1"/>
+          </a:effectRef>
+          <a:fontRef idx="minor">
+            <a:schemeClr val="lt1"/>
+          </a:fontRef>
+        </p:style>
+        <p:txBody>
+          <a:bodyPr wrap="square" lIns="27432" tIns="22860" rIns="27432" bIns="22860" rtlCol="0" anchor="t"/>
+          <a:lstStyle/>
+          <a:p>
+            <a:pPr algn="ctr"/>
+            <a:r>
+              <a:rPr sz="2000" b="1" i="0" dirty="0">
+                <a:solidFill>
+                  <a:srgbClr val="5C4826"/>
+                </a:solidFill>
+              </a:rPr>
+              <a:t>ENVIRONMENT DRIFT</a:t>
+            </a:r>
+          </a:p>
+          <a:p>
+            <a:pPr algn="ctr">
+              <a:spcBef>
+                <a:spcPts val="800"/>
+              </a:spcBef>
+            </a:pPr>
+            <a:r>
+              <a:rPr sz="2000" b="0" i="0" dirty="0">
+                <a:solidFill>
+                  <a:srgbClr val="5C4826"/>
+                </a:solidFill>
+              </a:rPr>
+              <a:t>the runner slowly stops matching production</a:t>
+            </a:r>
+          </a:p>
+        </p:txBody>
+      </p:sp>
+      <p:sp>
+        <p:nvSpPr>
+          <p:cNvPr id="1004" name="Card"/>
+          <p:cNvSpPr/>
+          <p:nvPr/>
+        </p:nvSpPr>
+        <p:spPr>
+          <a:xfrm>
+            <a:off x="6126480" y="1280160"/>
+            <a:ext cx="2651760" cy="2103120"/>
+          </a:xfrm>
+          <a:prstGeom prst="rect">
+            <a:avLst/>
+          </a:prstGeom>
+          <a:solidFill>
+            <a:srgbClr val="F5F1E8"/>
+          </a:solidFill>
+          <a:ln w="12700">
+            <a:solidFill>
+              <a:srgbClr val="C9B991"/>
+            </a:solidFill>
+          </a:ln>
+          <a:effectLst/>
+        </p:spPr>
+        <p:style>
+          <a:lnRef idx="1">
+            <a:schemeClr val="accent1"/>
+          </a:lnRef>
+          <a:fillRef idx="3">
+            <a:schemeClr val="accent1"/>
+          </a:fillRef>
+          <a:effectRef idx="2">
+            <a:schemeClr val="accent1"/>
+          </a:effectRef>
+          <a:fontRef idx="minor">
+            <a:schemeClr val="lt1"/>
+          </a:fontRef>
+        </p:style>
+        <p:txBody>
+          <a:bodyPr wrap="square" lIns="27432" tIns="22860" rIns="27432" bIns="22860" rtlCol="0" anchor="t"/>
+          <a:lstStyle/>
+          <a:p>
+            <a:pPr algn="ctr"/>
+            <a:r>
+              <a:rPr sz="2000" b="1" i="0" dirty="0">
+                <a:solidFill>
+                  <a:srgbClr val="5C4826"/>
+                </a:solidFill>
+              </a:rPr>
+              <a:t>UNRELIABLE DEPENDENCIES</a:t>
+            </a:r>
+          </a:p>
+          <a:p>
+            <a:pPr algn="ctr">
+              <a:spcBef>
+                <a:spcPts val="800"/>
+              </a:spcBef>
+            </a:pPr>
+            <a:r>
+              <a:rPr sz="2000" b="0" i="0" dirty="0">
+                <a:solidFill>
+                  <a:srgbClr val="5C4826"/>
+                </a:solidFill>
+              </a:rPr>
+              <a:t>the network is part of your pipeline</a:t>
+            </a:r>
+          </a:p>
+        </p:txBody>
+      </p:sp>
+      <p:sp>
+        <p:nvSpPr>
+          <p:cNvPr id="1005" name="Label"/>
+          <p:cNvSpPr/>
+          <p:nvPr/>
+        </p:nvSpPr>
+        <p:spPr>
+          <a:xfrm>
+            <a:off x="365760" y="3657600"/>
+            <a:ext cx="8412480" cy="384048"/>
+          </a:xfrm>
+          <a:prstGeom prst="rect">
+            <a:avLst/>
+          </a:prstGeom>
+          <a:noFill/>
+          <a:ln>
+            <a:noFill/>
+          </a:ln>
+          <a:effectLst/>
+        </p:spPr>
+        <p:style>
+          <a:lnRef idx="1">
+            <a:schemeClr val="accent1"/>
+          </a:lnRef>
+          <a:fillRef idx="3">
+            <a:schemeClr val="accent1"/>
+          </a:fillRef>
+          <a:effectRef idx="2">
+            <a:schemeClr val="accent1"/>
+          </a:effectRef>
+          <a:fontRef idx="minor">
+            <a:schemeClr val="lt1"/>
+          </a:fontRef>
+        </p:style>
+        <p:txBody>
+          <a:bodyPr wrap="square" lIns="27432" tIns="22860" rIns="27432" bIns="22860" rtlCol="0" anchor="ctr"/>
+          <a:lstStyle/>
+          <a:p>
+            <a:pPr algn="ctr"/>
+            <a:r>
+              <a:rPr sz="2000" b="1" i="0" dirty="0">
+                <a:solidFill>
+                  <a:srgbClr val="5C4826"/>
+                </a:solidFill>
+              </a:rPr>
+              <a:t>The pipeline is software too, and it fails like software</a:t>
             </a:r>
           </a:p>
         </p:txBody>

</xml_diff>

<commit_message>
deck 3-1: release management — slides 16-21
Section 4 from the release-management source deck (v4 numbering):
passing-build-is-not-permission with the startup/medical-device
contrast; the exposure-dimension table; blue-green, canary, and feature
flags each redrawn in house style with their honest caveats (shared
state defeats the instant-rollback story; exposure grows only with
evidence; a flag is not safety); cadence rebuilt around the author's
five comparison axes instead of the original's too-categorical
human-engagement row, with DORA named and deferred to Operations & SRE.
TIMING now 57 of 65 minutes.

Co-Authored-By: Claude Opus 5 <noreply@anthropic.com>
</commit_message>
<xml_diff>
--- a/course/lectures/act-3-software-in-the-world/02-compute-environments-and-data-management/3-1-Compute-Environments-and-Deployment.pptx
+++ b/course/lectures/act-3-software-in-the-world/02-compute-environments-and-data-management/3-1-Compute-Environments-and-Deployment.pptx
@@ -23,6 +23,12 @@
     <p:sldId id="268" r:id="rId20"/>
     <p:sldId id="269" r:id="rId21"/>
     <p:sldId id="270" r:id="rId22"/>
+    <p:sldId id="271" r:id="rId23"/>
+    <p:sldId id="272" r:id="rId24"/>
+    <p:sldId id="273" r:id="rId25"/>
+    <p:sldId id="274" r:id="rId26"/>
+    <p:sldId id="275" r:id="rId27"/>
+    <p:sldId id="276" r:id="rId28"/>
   </p:sldIdLst>
   <p:sldSz cx="9144000" cy="6858000" type="screen4x3"/>
   <p:notesSz cx="6858000" cy="9144000"/>
@@ -1676,6 +1682,386 @@
 </p:notes>
 </file>
 
+<file path=ppt/notesSlides/notesSlide16.xml><?xml version="1.0" encoding="utf-8"?>
+<p:notes xmlns:a="http://schemas.openxmlformats.org/drawingml/2006/main" xmlns:p="http://schemas.openxmlformats.org/presentationml/2006/main" xmlns:r="http://schemas.openxmlformats.org/officeDocument/2006/relationships">
+  <p:cSld>
+    <p:spTree>
+      <p:nvGrpSpPr>
+        <p:cNvPr id="1" name=""/>
+        <p:cNvGrpSpPr/>
+        <p:nvPr/>
+      </p:nvGrpSpPr>
+      <p:grpSpPr>
+        <a:xfrm>
+          <a:off x="0" y="0"/>
+          <a:ext cx="0" cy="0"/>
+          <a:chOff x="0" y="0"/>
+          <a:chExt cx="0" cy="0"/>
+        </a:xfrm>
+      </p:grpSpPr>
+      <p:sp>
+        <p:nvSpPr>
+          <p:cNvPr id="2" name="Slide Image Placeholder 1"/>
+          <p:cNvSpPr>
+            <a:spLocks noGrp="1"/>
+          </p:cNvSpPr>
+          <p:nvPr>
+            <p:ph type="sldImg" idx="2"/>
+          </p:nvPr>
+        </p:nvSpPr>
+        <p:spPr/>
+      </p:sp>
+      <p:sp>
+        <p:nvSpPr>
+          <p:cNvPr id="3" name="Notes Placeholder 2"/>
+          <p:cNvSpPr>
+            <a:spLocks noGrp="1"/>
+          </p:cNvSpPr>
+          <p:nvPr>
+            <p:ph type="body" idx="3" sz="quarter"/>
+          </p:nvPr>
+        </p:nvSpPr>
+        <p:spPr/>
+        <p:txBody>
+          <a:bodyPr/>
+          <a:lstStyle/>
+          <a:p>
+            <a:r>
+              <a:t>TIMING: 3 minutes. THE SECTION'S OPENING CLAIM, adapted from the release-management source deck's opening question and definition slides.</a:t>
+            </a:r>
+          </a:p>
+          <a:p>
+            <a:r>
+              <a:t>ASK FIRST (the footer): the pipeline is green; should you ship? Let the room split before explaining.</a:t>
+            </a:r>
+          </a:p>
+          <a:p>
+            <a:r>
+              <a:t>THEN THE DISTINCTION: a successful CI run establishes selected properties of the candidate artifact, in the pipeline's environment. It does not establish that every production condition is appropriate for deployment: traffic, timing, support staffing, regulatory state, concurrent incidents.</a:t>
+            </a:r>
+          </a:p>
+          <a:p>
+            <a:r>
+              <a:t>THE TWO CARDS make both answers right: the startup ships twenty times a day because each change is small and reversible; the medical-device team releases quarterly under review because its failures are not reversible. Same green build, different release decisions, both correct for their requirements.</a:t>
+            </a:r>
+          </a:p>
+          <a:p>
+            <a:r>
+              <a:t>DEFINITION (the grey line): release management decides what is released, when, to whom, and under which safeguards. It sits on top of CI/CD; it consumes the pipeline's evidence.</a:t>
+            </a:r>
+          </a:p>
+          <a:p>
+            <a:r>
+              <a:t>NON-CLAIM (the author checks this): a passing CI run is not authorization to release. Authorization is a policy decision the next slides give mechanisms for.</a:t>
+            </a:r>
+          </a:p>
+          <a:p>
+            <a:r>
+              <a:t>TRANSITION: the mechanisms share one idea: control how much of the world sees the change.</a:t>
+            </a:r>
+          </a:p>
+        </p:txBody>
+      </p:sp>
+      <p:sp>
+        <p:nvSpPr>
+          <p:cNvPr id="4" name="Slide Number Placeholder 3"/>
+          <p:cNvSpPr>
+            <a:spLocks noGrp="1"/>
+          </p:cNvSpPr>
+          <p:nvPr>
+            <p:ph type="sldNum" idx="5" sz="quarter"/>
+          </p:nvPr>
+        </p:nvSpPr>
+        <p:spPr/>
+      </p:sp>
+    </p:spTree>
+  </p:cSld>
+  <p:clrMapOvr>
+    <a:masterClrMapping/>
+  </p:clrMapOvr>
+</p:notes>
+</file>
+
+<file path=ppt/notesSlides/notesSlide17.xml><?xml version="1.0" encoding="utf-8"?>
+<p:notes xmlns:a="http://schemas.openxmlformats.org/drawingml/2006/main" xmlns:p="http://schemas.openxmlformats.org/presentationml/2006/main" xmlns:r="http://schemas.openxmlformats.org/officeDocument/2006/relationships">
+  <p:cSld>
+    <p:spTree>
+      <p:nvGrpSpPr>
+        <p:cNvPr id="1" name=""/>
+        <p:cNvGrpSpPr/>
+        <p:nvPr/>
+      </p:nvGrpSpPr>
+      <p:grpSpPr>
+        <a:xfrm>
+          <a:off x="0" y="0"/>
+          <a:ext cx="0" cy="0"/>
+          <a:chOff x="0" y="0"/>
+          <a:chExt cx="0" cy="0"/>
+        </a:xfrm>
+      </p:grpSpPr>
+      <p:sp>
+        <p:nvSpPr>
+          <p:cNvPr id="2" name="Slide Image Placeholder 1"/>
+          <p:cNvSpPr>
+            <a:spLocks noGrp="1"/>
+          </p:cNvSpPr>
+          <p:nvPr>
+            <p:ph type="sldImg" idx="2"/>
+          </p:nvPr>
+        </p:nvSpPr>
+        <p:spPr/>
+      </p:sp>
+      <p:sp>
+        <p:nvSpPr>
+          <p:cNvPr id="3" name="Notes Placeholder 2"/>
+          <p:cNvSpPr>
+            <a:spLocks noGrp="1"/>
+          </p:cNvSpPr>
+          <p:nvPr>
+            <p:ph type="body" idx="3" sz="quarter"/>
+          </p:nvPr>
+        </p:nvSpPr>
+        <p:spPr/>
+        <p:txBody>
+          <a:bodyPr/>
+          <a:lstStyle/>
+          <a:p>
+            <a:r>
+              <a:t>TIMING: 3 minutes. THE COMPARISON TABLE, retained from the source deck's summary slide; the three detail slides follow.</a:t>
+            </a:r>
+          </a:p>
+          <a:p>
+            <a:r>
+              <a:t>WALK THE ROWS: blue-green controls WHICH ENVIRONMENT serves production traffic; canary controls WHICH FRACTION of traffic sees the new version; feature flags control WHICH FUNCTIONALITY is enabled inside a deployed artifact.</a:t>
+            </a:r>
+          </a:p>
+          <a:p>
+            <a:r>
+              <a:t>THE INSIGHT: these are different DIMENSIONS of exposure, not competing brands of the same trick. Real systems combine them: a canary rollout of an artifact whose new feature is still flagged off.</a:t>
+            </a:r>
+          </a:p>
+          <a:p>
+            <a:r>
+              <a:t>ASK: which dimension would you want for your bank's API? For a game's season launch? EXPECTED: the bank wants environment-level control and instant rollback (blue-green); the game wants fraction and feature control for a timed, partial reveal. There is no single right strategy.</a:t>
+            </a:r>
+          </a:p>
+          <a:p>
+            <a:r>
+              <a:t>TRANSITION: one slide on each, starting with blue-green.</a:t>
+            </a:r>
+          </a:p>
+        </p:txBody>
+      </p:sp>
+      <p:sp>
+        <p:nvSpPr>
+          <p:cNvPr id="4" name="Slide Number Placeholder 3"/>
+          <p:cNvSpPr>
+            <a:spLocks noGrp="1"/>
+          </p:cNvSpPr>
+          <p:nvPr>
+            <p:ph type="sldNum" idx="5" sz="quarter"/>
+          </p:nvPr>
+        </p:nvSpPr>
+        <p:spPr/>
+      </p:sp>
+    </p:spTree>
+  </p:cSld>
+  <p:clrMapOvr>
+    <a:masterClrMapping/>
+  </p:clrMapOvr>
+</p:notes>
+</file>
+
+<file path=ppt/notesSlides/notesSlide18.xml><?xml version="1.0" encoding="utf-8"?>
+<p:notes xmlns:a="http://schemas.openxmlformats.org/drawingml/2006/main" xmlns:p="http://schemas.openxmlformats.org/presentationml/2006/main" xmlns:r="http://schemas.openxmlformats.org/officeDocument/2006/relationships">
+  <p:cSld>
+    <p:spTree>
+      <p:nvGrpSpPr>
+        <p:cNvPr id="1" name=""/>
+        <p:cNvGrpSpPr/>
+        <p:nvPr/>
+      </p:nvGrpSpPr>
+      <p:grpSpPr>
+        <a:xfrm>
+          <a:off x="0" y="0"/>
+          <a:ext cx="0" cy="0"/>
+          <a:chOff x="0" y="0"/>
+          <a:chExt cx="0" cy="0"/>
+        </a:xfrm>
+      </p:grpSpPr>
+      <p:sp>
+        <p:nvSpPr>
+          <p:cNvPr id="2" name="Slide Image Placeholder 1"/>
+          <p:cNvSpPr>
+            <a:spLocks noGrp="1"/>
+          </p:cNvSpPr>
+          <p:nvPr>
+            <p:ph type="sldImg" idx="2"/>
+          </p:nvPr>
+        </p:nvSpPr>
+        <p:spPr/>
+      </p:sp>
+      <p:sp>
+        <p:nvSpPr>
+          <p:cNvPr id="3" name="Notes Placeholder 2"/>
+          <p:cNvSpPr>
+            <a:spLocks noGrp="1"/>
+          </p:cNvSpPr>
+          <p:nvPr>
+            <p:ph type="body" idx="3" sz="quarter"/>
+          </p:nvPr>
+        </p:nvSpPr>
+        <p:spPr/>
+        <p:txBody>
+          <a:bodyPr/>
+          <a:lstStyle/>
+          <a:p>
+            <a:r>
+              <a:t>TIMING: 2 minutes. REDRAWN from the source deck's blue-green illustration in the current style.</a:t>
+            </a:r>
+          </a:p>
+          <a:p>
+            <a:r>
+              <a:t>THE MECHANISM: two production-grade environments. Blue serves all traffic; the new version deploys to Green, is smoke-tested in place, and the router switches traffic when Green looks healthy. Rollback is the same switch, reversed.</a:t>
+            </a:r>
+          </a:p>
+          <a:p>
+            <a:r>
+              <a:t>THE TRADEOFFS (the bottom card): you pay for two environments, and the switch is only as clean as the state the two versions share. A schema migration that only version 2 understands makes the 'instant rollback' story false.</a:t>
+            </a:r>
+          </a:p>
+          <a:p>
+            <a:r>
+              <a:t>NON-CLAIM (the author checks this): blue-green does not make database rollback trivial. The router switch is instant; shared persistent state is the part that is not, and the Data Management lecture picks up schema migration.</a:t>
+            </a:r>
+          </a:p>
+          <a:p>
+            <a:r>
+              <a:t>ASK: you switch traffic in one second. Did the database switch with you? EXPECTED: silence, then the realization that there is only ONE database. That is the slide's lesson.</a:t>
+            </a:r>
+          </a:p>
+          <a:p>
+            <a:r>
+              <a:t>TRANSITION: blue-green moves everyone at once. The next strategy moves a fraction.</a:t>
+            </a:r>
+          </a:p>
+        </p:txBody>
+      </p:sp>
+      <p:sp>
+        <p:nvSpPr>
+          <p:cNvPr id="4" name="Slide Number Placeholder 3"/>
+          <p:cNvSpPr>
+            <a:spLocks noGrp="1"/>
+          </p:cNvSpPr>
+          <p:nvPr>
+            <p:ph type="sldNum" idx="5" sz="quarter"/>
+          </p:nvPr>
+        </p:nvSpPr>
+        <p:spPr/>
+      </p:sp>
+    </p:spTree>
+  </p:cSld>
+  <p:clrMapOvr>
+    <a:masterClrMapping/>
+  </p:clrMapOvr>
+</p:notes>
+</file>
+
+<file path=ppt/notesSlides/notesSlide19.xml><?xml version="1.0" encoding="utf-8"?>
+<p:notes xmlns:a="http://schemas.openxmlformats.org/drawingml/2006/main" xmlns:p="http://schemas.openxmlformats.org/presentationml/2006/main" xmlns:r="http://schemas.openxmlformats.org/officeDocument/2006/relationships">
+  <p:cSld>
+    <p:spTree>
+      <p:nvGrpSpPr>
+        <p:cNvPr id="1" name=""/>
+        <p:cNvGrpSpPr/>
+        <p:nvPr/>
+      </p:nvGrpSpPr>
+      <p:grpSpPr>
+        <a:xfrm>
+          <a:off x="0" y="0"/>
+          <a:ext cx="0" cy="0"/>
+          <a:chOff x="0" y="0"/>
+          <a:chExt cx="0" cy="0"/>
+        </a:xfrm>
+      </p:grpSpPr>
+      <p:sp>
+        <p:nvSpPr>
+          <p:cNvPr id="2" name="Slide Image Placeholder 1"/>
+          <p:cNvSpPr>
+            <a:spLocks noGrp="1"/>
+          </p:cNvSpPr>
+          <p:nvPr>
+            <p:ph type="sldImg" idx="2"/>
+          </p:nvPr>
+        </p:nvSpPr>
+        <p:spPr/>
+      </p:sp>
+      <p:sp>
+        <p:nvSpPr>
+          <p:cNvPr id="3" name="Notes Placeholder 2"/>
+          <p:cNvSpPr>
+            <a:spLocks noGrp="1"/>
+          </p:cNvSpPr>
+          <p:nvPr>
+            <p:ph type="body" idx="3" sz="quarter"/>
+          </p:nvPr>
+        </p:nvSpPr>
+        <p:spPr/>
+        <p:txBody>
+          <a:bodyPr/>
+          <a:lstStyle/>
+          <a:p>
+            <a:r>
+              <a:t>TIMING: 2 minutes. REDRAWN from the source deck's canary illustration.</a:t>
+            </a:r>
+          </a:p>
+          <a:p>
+            <a:r>
+              <a:t>THE MECHANISM: both versions run in production; the router sends a small fraction, say 5%, to the new version. The canary population experiences the change under real conditions while 95% of users stay on the known version.</a:t>
+            </a:r>
+          </a:p>
+          <a:p>
+            <a:r>
+              <a:t>THE ENGINEERING QUESTION, and the reason this slide exists: what evidence justifies increasing exposure? The bottom card names the measurements consulted between steps: error rates, latency, user reports. Each widening of the fraction is an admission decision backed by that evidence, the kickoff loop again at release granularity.</a:t>
+            </a:r>
+          </a:p>
+          <a:p>
+            <a:r>
+              <a:t>ASK: what would send you from 5% back to 0%? EXPECTED: an error-rate delta against version 1, a latency regression, a support spike. Note the comparison is against the CONTROL population running version 1 at the same time, which is what makes canary evidence strong.</a:t>
+            </a:r>
+          </a:p>
+          <a:p>
+            <a:r>
+              <a:t>SCOPE NOTE: the measurement machinery itself (dashboards, alerting, SLOs) belongs to Operations &amp; SRE; today we only need that the evidence exists.</a:t>
+            </a:r>
+          </a:p>
+          <a:p>
+            <a:r>
+              <a:t>TRANSITION: both strategies so far switch artifacts. The third switches behavior inside one artifact.</a:t>
+            </a:r>
+          </a:p>
+        </p:txBody>
+      </p:sp>
+      <p:sp>
+        <p:nvSpPr>
+          <p:cNvPr id="4" name="Slide Number Placeholder 3"/>
+          <p:cNvSpPr>
+            <a:spLocks noGrp="1"/>
+          </p:cNvSpPr>
+          <p:nvPr>
+            <p:ph type="sldNum" idx="5" sz="quarter"/>
+          </p:nvPr>
+        </p:nvSpPr>
+        <p:spPr/>
+      </p:sp>
+    </p:spTree>
+  </p:cSld>
+  <p:clrMapOvr>
+    <a:masterClrMapping/>
+  </p:clrMapOvr>
+</p:notes>
+</file>
+
 <file path=ppt/notesSlides/notesSlide2.xml><?xml version="1.0" encoding="utf-8"?>
 <p:notes xmlns:a="http://schemas.openxmlformats.org/drawingml/2006/main" xmlns:p="http://schemas.openxmlformats.org/presentationml/2006/main" xmlns:r="http://schemas.openxmlformats.org/officeDocument/2006/relationships">
   <p:cSld>
@@ -1747,6 +2133,196 @@
           <a:p>
             <a:r>
               <a:t>TRANSITION: environments differ in what they supply — and in what they impose.</a:t>
+            </a:r>
+          </a:p>
+        </p:txBody>
+      </p:sp>
+      <p:sp>
+        <p:nvSpPr>
+          <p:cNvPr id="4" name="Slide Number Placeholder 3"/>
+          <p:cNvSpPr>
+            <a:spLocks noGrp="1"/>
+          </p:cNvSpPr>
+          <p:nvPr>
+            <p:ph type="sldNum" idx="5" sz="quarter"/>
+          </p:nvPr>
+        </p:nvSpPr>
+        <p:spPr/>
+      </p:sp>
+    </p:spTree>
+  </p:cSld>
+  <p:clrMapOvr>
+    <a:masterClrMapping/>
+  </p:clrMapOvr>
+</p:notes>
+</file>
+
+<file path=ppt/notesSlides/notesSlide20.xml><?xml version="1.0" encoding="utf-8"?>
+<p:notes xmlns:a="http://schemas.openxmlformats.org/drawingml/2006/main" xmlns:p="http://schemas.openxmlformats.org/presentationml/2006/main" xmlns:r="http://schemas.openxmlformats.org/officeDocument/2006/relationships">
+  <p:cSld>
+    <p:spTree>
+      <p:nvGrpSpPr>
+        <p:cNvPr id="1" name=""/>
+        <p:cNvGrpSpPr/>
+        <p:nvPr/>
+      </p:nvGrpSpPr>
+      <p:grpSpPr>
+        <a:xfrm>
+          <a:off x="0" y="0"/>
+          <a:ext cx="0" cy="0"/>
+          <a:chOff x="0" y="0"/>
+          <a:chExt cx="0" cy="0"/>
+        </a:xfrm>
+      </p:grpSpPr>
+      <p:sp>
+        <p:nvSpPr>
+          <p:cNvPr id="2" name="Slide Image Placeholder 1"/>
+          <p:cNvSpPr>
+            <a:spLocks noGrp="1"/>
+          </p:cNvSpPr>
+          <p:nvPr>
+            <p:ph type="sldImg" idx="2"/>
+          </p:nvPr>
+        </p:nvSpPr>
+        <p:spPr/>
+      </p:sp>
+      <p:sp>
+        <p:nvSpPr>
+          <p:cNvPr id="3" name="Notes Placeholder 2"/>
+          <p:cNvSpPr>
+            <a:spLocks noGrp="1"/>
+          </p:cNvSpPr>
+          <p:nvPr>
+            <p:ph type="body" idx="3" sz="quarter"/>
+          </p:nvPr>
+        </p:nvSpPr>
+        <p:spPr/>
+        <p:txBody>
+          <a:bodyPr/>
+          <a:lstStyle/>
+          <a:p>
+            <a:r>
+              <a:t>TIMING: 2 minutes. SIMPLIFIED from the source deck's feature-flag slide; its three C implementations (compile-time flag, environment variable, flag service) are more detail than this lecture needs and live in the notes instead.</a:t>
+            </a:r>
+          </a:p>
+          <a:p>
+            <a:r>
+              <a:t>THE MECHANISM: one artifact is deployed; a flag selects between behaviors at runtime. Deploying code and exposing functionality become separate decisions, so code can reach production dark and light up later, per user group if wanted.</a:t>
+            </a:r>
+          </a:p>
+          <a:p>
+            <a:r>
+              <a:t>IMPLEMENTATION SPECTRUM, if asked: compile-time flags (cheap, need a rebuild to change), environment variables (change at restart), and flag services (change live, per cohort). The further right, the more operational machinery you are trusting.</a:t>
+            </a:r>
+          </a:p>
+          <a:p>
+            <a:r>
+              <a:t>NON-CLAIM (the author checks this): feature flags do not automatically make changes safe. The flagged code is in production whether or not it runs; flag interactions multiply test states; and a flag whose two sides touch shared state differently is not safe to flip at runtime at all (the bottom card).</a:t>
+            </a:r>
+          </a:p>
+          <a:p>
+            <a:r>
+              <a:t>ASK: the code is in production and no user can reach it. Is that deployed, or released? EXPECTED: deployed, not released, which is precisely the delivery/deployment distinction from the CI/CD section.</a:t>
+            </a:r>
+          </a:p>
+          <a:p>
+            <a:r>
+              <a:t>TRANSITION: strategies control one release. Cadence is the pattern across releases.</a:t>
+            </a:r>
+          </a:p>
+        </p:txBody>
+      </p:sp>
+      <p:sp>
+        <p:nvSpPr>
+          <p:cNvPr id="4" name="Slide Number Placeholder 3"/>
+          <p:cNvSpPr>
+            <a:spLocks noGrp="1"/>
+          </p:cNvSpPr>
+          <p:nvPr>
+            <p:ph type="sldNum" idx="5" sz="quarter"/>
+          </p:nvPr>
+        </p:nvSpPr>
+        <p:spPr/>
+      </p:sp>
+    </p:spTree>
+  </p:cSld>
+  <p:clrMapOvr>
+    <a:masterClrMapping/>
+  </p:clrMapOvr>
+</p:notes>
+</file>
+
+<file path=ppt/notesSlides/notesSlide21.xml><?xml version="1.0" encoding="utf-8"?>
+<p:notes xmlns:a="http://schemas.openxmlformats.org/drawingml/2006/main" xmlns:p="http://schemas.openxmlformats.org/presentationml/2006/main" xmlns:r="http://schemas.openxmlformats.org/officeDocument/2006/relationships">
+  <p:cSld>
+    <p:spTree>
+      <p:nvGrpSpPr>
+        <p:cNvPr id="1" name=""/>
+        <p:cNvGrpSpPr/>
+        <p:nvPr/>
+      </p:nvGrpSpPr>
+      <p:grpSpPr>
+        <a:xfrm>
+          <a:off x="0" y="0"/>
+          <a:ext cx="0" cy="0"/>
+          <a:chOff x="0" y="0"/>
+          <a:chExt cx="0" cy="0"/>
+        </a:xfrm>
+      </p:grpSpPr>
+      <p:sp>
+        <p:nvSpPr>
+          <p:cNvPr id="2" name="Slide Image Placeholder 1"/>
+          <p:cNvSpPr>
+            <a:spLocks noGrp="1"/>
+          </p:cNvSpPr>
+          <p:nvPr>
+            <p:ph type="sldImg" idx="2"/>
+          </p:nvPr>
+        </p:nvSpPr>
+        <p:spPr/>
+      </p:sp>
+      <p:sp>
+        <p:nvSpPr>
+          <p:cNvPr id="3" name="Notes Placeholder 2"/>
+          <p:cNvSpPr>
+            <a:spLocks noGrp="1"/>
+          </p:cNvSpPr>
+          <p:nvPr>
+            <p:ph type="body" idx="3" sz="quarter"/>
+          </p:nvPr>
+        </p:nvSpPr>
+        <p:spPr/>
+        <p:txBody>
+          <a:bodyPr/>
+          <a:lstStyle/>
+          <a:p>
+            <a:r>
+              <a:t>TIMING: 3 minutes. ADAPTED from the source deck's cadence table, revised on the author's instruction: the original suggested frequent releases require less human engagement, which is too categorical. The honest comparison is along the five rows shown.</a:t>
+            </a:r>
+          </a:p>
+          <a:p>
+            <a:r>
+              <a:t>WALK A ROW OR TWO: few large releases concentrate months of change, so verification is long and a failure is hard to attribute to a cause; many small releases spread the change, so gates can be automated and the suspect set for a failure is small. Reversal differs the same way: rolling back a quarter is surgery, rolling back a day is routine.</a:t>
+            </a:r>
+          </a:p>
+          <a:p>
+            <a:r>
+              <a:t>THE JUDGMENT: cadence is chosen by requirements, exactly like the execution environment was. Regulated and safety-critical contexts legitimately choose slow cadences with heavy human coordination; that is engineering, not backwardness.</a:t>
+            </a:r>
+          </a:p>
+          <a:p>
+            <a:r>
+              <a:t>DORA, briefly and by name only (the italic line): deployment frequency, lead time for changes, time to restore, change failure rate. Industry uses them as cadence-and-recovery baselines; their proper treatment belongs to Operations &amp; SRE and is deliberately not given here.</a:t>
+            </a:r>
+          </a:p>
+          <a:p>
+            <a:r>
+              <a:t>ASK: what makes a release risky, its size or how fast you can undo it? EXPECTED: both views surface; the table says they trade against each other.</a:t>
+            </a:r>
+          </a:p>
+          <a:p>
+            <a:r>
+              <a:t>TRANSITION: everything in the lecture now lands on one concrete decision for our service.</a:t>
             </a:r>
           </a:p>
         </p:txBody>
@@ -8996,6 +9572,2591 @@
 </p:sld>
 </file>
 
+<file path=ppt/slides/slide16.xml><?xml version="1.0" encoding="utf-8"?>
+<p:sld xmlns:a="http://schemas.openxmlformats.org/drawingml/2006/main" xmlns:p="http://schemas.openxmlformats.org/presentationml/2006/main" xmlns:r="http://schemas.openxmlformats.org/officeDocument/2006/relationships">
+  <p:cSld>
+    <p:spTree>
+      <p:nvGrpSpPr>
+        <p:cNvPr id="1" name=""/>
+        <p:cNvGrpSpPr/>
+        <p:nvPr/>
+      </p:nvGrpSpPr>
+      <p:grpSpPr/>
+      <p:sp>
+        <p:nvSpPr>
+          <p:cNvPr id="3" name="Title 2"/>
+          <p:cNvSpPr>
+            <a:spLocks noGrp="1"/>
+          </p:cNvSpPr>
+          <p:nvPr>
+            <p:ph type="title"/>
+          </p:nvPr>
+        </p:nvSpPr>
+        <p:spPr/>
+        <p:txBody>
+          <a:bodyPr wrap="square"/>
+          <a:lstStyle/>
+          <a:p>
+            <a:pPr algn="l"/>
+            <a:r>
+              <a:rPr sz="2400" b="0" i="0" dirty="0">
+                <a:solidFill>
+                  <a:srgbClr val="000000"/>
+                </a:solidFill>
+              </a:rPr>
+              <a:t>A passing build is not permission to deploy</a:t>
+            </a:r>
+          </a:p>
+        </p:txBody>
+      </p:sp>
+      <p:sp>
+        <p:nvSpPr>
+          <p:cNvPr id="1001" name="Slide Number Placeholder 900"/>
+          <p:cNvSpPr>
+            <a:spLocks noGrp="1"/>
+          </p:cNvSpPr>
+          <p:nvPr>
+            <p:ph type="sldNum" sz="quarter" idx="4"/>
+          </p:nvPr>
+        </p:nvSpPr>
+        <p:spPr/>
+        <p:txBody>
+          <a:bodyPr/>
+          <a:lstStyle/>
+          <a:p>
+            <a:fld id="{B3291E67-7172-4DCF-B35F-54404EBE6160}" type="slidenum">
+              <a:rPr lang="en-US" smtClean="0"/>
+              <a:t>1</a:t>
+            </a:fld>
+            <a:endParaRPr lang="en-US"/>
+          </a:p>
+        </p:txBody>
+      </p:sp>
+      <p:sp>
+        <p:nvSpPr>
+          <p:cNvPr id="1002" name="Block"/>
+          <p:cNvSpPr/>
+          <p:nvPr/>
+        </p:nvSpPr>
+        <p:spPr>
+          <a:xfrm>
+            <a:off x="411480" y="1325880"/>
+            <a:ext cx="2103120" cy="777240"/>
+          </a:xfrm>
+          <a:prstGeom prst="rect">
+            <a:avLst/>
+          </a:prstGeom>
+          <a:solidFill>
+            <a:srgbClr val="8E6F3E"/>
+          </a:solidFill>
+          <a:ln>
+            <a:noFill/>
+          </a:ln>
+          <a:effectLst/>
+        </p:spPr>
+        <p:style>
+          <a:lnRef idx="1">
+            <a:schemeClr val="accent1"/>
+          </a:lnRef>
+          <a:fillRef idx="3">
+            <a:schemeClr val="accent1"/>
+          </a:fillRef>
+          <a:effectRef idx="2">
+            <a:schemeClr val="accent1"/>
+          </a:effectRef>
+          <a:fontRef idx="minor">
+            <a:schemeClr val="lt1"/>
+          </a:fontRef>
+        </p:style>
+        <p:txBody>
+          <a:bodyPr wrap="square" lIns="27432" tIns="22860" rIns="27432" bIns="22860" rtlCol="0" anchor="ctr"/>
+          <a:lstStyle/>
+          <a:p>
+            <a:pPr algn="ctr"/>
+            <a:r>
+              <a:rPr sz="2000" b="1" i="0" dirty="0">
+                <a:solidFill>
+                  <a:srgbClr val="FFFFFF"/>
+                </a:solidFill>
+              </a:rPr>
+              <a:t>GREEN BUILD</a:t>
+            </a:r>
+          </a:p>
+        </p:txBody>
+      </p:sp>
+      <p:sp>
+        <p:nvSpPr>
+          <p:cNvPr id="1003" name="GroupLabel"/>
+          <p:cNvSpPr/>
+          <p:nvPr/>
+        </p:nvSpPr>
+        <p:spPr>
+          <a:xfrm>
+            <a:off x="3246120" y="1188720"/>
+            <a:ext cx="2651760" cy="1051560"/>
+          </a:xfrm>
+          <a:prstGeom prst="rect">
+            <a:avLst/>
+          </a:prstGeom>
+          <a:solidFill>
+            <a:srgbClr val="3E5C6F"/>
+          </a:solidFill>
+          <a:ln>
+            <a:noFill/>
+          </a:ln>
+          <a:effectLst/>
+        </p:spPr>
+        <p:style>
+          <a:lnRef idx="1">
+            <a:schemeClr val="accent1"/>
+          </a:lnRef>
+          <a:fillRef idx="3">
+            <a:schemeClr val="accent1"/>
+          </a:fillRef>
+          <a:effectRef idx="2">
+            <a:schemeClr val="accent1"/>
+          </a:effectRef>
+          <a:fontRef idx="minor">
+            <a:schemeClr val="lt1"/>
+          </a:fontRef>
+        </p:style>
+        <p:txBody>
+          <a:bodyPr wrap="square" lIns="27432" tIns="22860" rIns="27432" bIns="22860" rtlCol="0" anchor="ctr"/>
+          <a:lstStyle/>
+          <a:p>
+            <a:pPr algn="ctr"/>
+            <a:r>
+              <a:rPr sz="2000" b="1" i="0" dirty="0">
+                <a:solidFill>
+                  <a:srgbClr val="FFFFFF"/>
+                </a:solidFill>
+              </a:rPr>
+              <a:t>RELEASE</a:t>
+            </a:r>
+          </a:p>
+          <a:p>
+            <a:pPr algn="ctr"/>
+            <a:r>
+              <a:rPr sz="2000" b="1" i="0" dirty="0">
+                <a:solidFill>
+                  <a:srgbClr val="FFFFFF"/>
+                </a:solidFill>
+              </a:rPr>
+              <a:t>DECISION</a:t>
+            </a:r>
+          </a:p>
+        </p:txBody>
+      </p:sp>
+      <p:sp>
+        <p:nvSpPr>
+          <p:cNvPr id="1004" name="Block"/>
+          <p:cNvSpPr/>
+          <p:nvPr/>
+        </p:nvSpPr>
+        <p:spPr>
+          <a:xfrm>
+            <a:off x="6629400" y="1325880"/>
+            <a:ext cx="2103120" cy="777240"/>
+          </a:xfrm>
+          <a:prstGeom prst="rect">
+            <a:avLst/>
+          </a:prstGeom>
+          <a:solidFill>
+            <a:srgbClr val="8E6F3E"/>
+          </a:solidFill>
+          <a:ln>
+            <a:noFill/>
+          </a:ln>
+          <a:effectLst/>
+        </p:spPr>
+        <p:style>
+          <a:lnRef idx="1">
+            <a:schemeClr val="accent1"/>
+          </a:lnRef>
+          <a:fillRef idx="3">
+            <a:schemeClr val="accent1"/>
+          </a:fillRef>
+          <a:effectRef idx="2">
+            <a:schemeClr val="accent1"/>
+          </a:effectRef>
+          <a:fontRef idx="minor">
+            <a:schemeClr val="lt1"/>
+          </a:fontRef>
+        </p:style>
+        <p:txBody>
+          <a:bodyPr wrap="square" lIns="27432" tIns="22860" rIns="27432" bIns="22860" rtlCol="0" anchor="ctr"/>
+          <a:lstStyle/>
+          <a:p>
+            <a:pPr algn="ctr"/>
+            <a:r>
+              <a:rPr sz="2000" b="1" i="0" dirty="0">
+                <a:solidFill>
+                  <a:srgbClr val="FFFFFF"/>
+                </a:solidFill>
+              </a:rPr>
+              <a:t>PRODUCTION</a:t>
+            </a:r>
+          </a:p>
+        </p:txBody>
+      </p:sp>
+      <p:cxnSp>
+        <p:nvCxnSpPr>
+          <p:cNvPr id="1005" name="Connector"/>
+          <p:cNvCxnSpPr/>
+          <p:nvPr/>
+        </p:nvCxnSpPr>
+        <p:spPr>
+          <a:xfrm>
+            <a:off x="2532888" y="1714500"/>
+            <a:ext cx="694944" cy="0"/>
+          </a:xfrm>
+          <a:prstGeom prst="line">
+            <a:avLst/>
+          </a:prstGeom>
+          <a:ln w="19050">
+            <a:solidFill>
+              <a:srgbClr val="8E6F3E"/>
+            </a:solidFill>
+            <a:tailEnd type="triangle"/>
+          </a:ln>
+        </p:spPr>
+        <p:style>
+          <a:lnRef idx="2">
+            <a:schemeClr val="accent1"/>
+          </a:lnRef>
+          <a:fillRef idx="0">
+            <a:schemeClr val="accent1"/>
+          </a:fillRef>
+          <a:effectRef idx="1">
+            <a:schemeClr val="accent1"/>
+          </a:effectRef>
+          <a:fontRef idx="minor">
+            <a:schemeClr val="tx1"/>
+          </a:fontRef>
+        </p:style>
+      </p:cxnSp>
+      <p:cxnSp>
+        <p:nvCxnSpPr>
+          <p:cNvPr id="1006" name="Connector"/>
+          <p:cNvCxnSpPr/>
+          <p:nvPr/>
+        </p:nvCxnSpPr>
+        <p:spPr>
+          <a:xfrm>
+            <a:off x="5916168" y="1714500"/>
+            <a:ext cx="694944" cy="0"/>
+          </a:xfrm>
+          <a:prstGeom prst="line">
+            <a:avLst/>
+          </a:prstGeom>
+          <a:ln w="19050">
+            <a:solidFill>
+              <a:srgbClr val="8E6F3E"/>
+            </a:solidFill>
+            <a:tailEnd type="triangle"/>
+          </a:ln>
+        </p:spPr>
+        <p:style>
+          <a:lnRef idx="2">
+            <a:schemeClr val="accent1"/>
+          </a:lnRef>
+          <a:fillRef idx="0">
+            <a:schemeClr val="accent1"/>
+          </a:fillRef>
+          <a:effectRef idx="1">
+            <a:schemeClr val="accent1"/>
+          </a:effectRef>
+          <a:fontRef idx="minor">
+            <a:schemeClr val="tx1"/>
+          </a:fontRef>
+        </p:style>
+      </p:cxnSp>
+      <p:sp>
+        <p:nvSpPr>
+          <p:cNvPr id="1007" name="Label"/>
+          <p:cNvSpPr/>
+          <p:nvPr/>
+        </p:nvSpPr>
+        <p:spPr>
+          <a:xfrm>
+            <a:off x="411480" y="2560320"/>
+            <a:ext cx="8412480" cy="658368"/>
+          </a:xfrm>
+          <a:prstGeom prst="rect">
+            <a:avLst/>
+          </a:prstGeom>
+          <a:noFill/>
+          <a:ln>
+            <a:noFill/>
+          </a:ln>
+          <a:effectLst/>
+        </p:spPr>
+        <p:style>
+          <a:lnRef idx="1">
+            <a:schemeClr val="accent1"/>
+          </a:lnRef>
+          <a:fillRef idx="3">
+            <a:schemeClr val="accent1"/>
+          </a:fillRef>
+          <a:effectRef idx="2">
+            <a:schemeClr val="accent1"/>
+          </a:effectRef>
+          <a:fontRef idx="minor">
+            <a:schemeClr val="lt1"/>
+          </a:fontRef>
+        </p:style>
+        <p:txBody>
+          <a:bodyPr wrap="square" lIns="27432" tIns="22860" rIns="27432" bIns="22860" rtlCol="0" anchor="ctr"/>
+          <a:lstStyle/>
+          <a:p>
+            <a:pPr algn="ctr"/>
+            <a:r>
+              <a:rPr sz="2000" b="0" i="0" dirty="0">
+                <a:solidFill>
+                  <a:srgbClr val="555960"/>
+                </a:solidFill>
+              </a:rPr>
+              <a:t>Release management decides what is released, when, to whom, and under which safeguards</a:t>
+            </a:r>
+          </a:p>
+        </p:txBody>
+      </p:sp>
+      <p:sp>
+        <p:nvSpPr>
+          <p:cNvPr id="1008" name="Card"/>
+          <p:cNvSpPr/>
+          <p:nvPr/>
+        </p:nvSpPr>
+        <p:spPr>
+          <a:xfrm>
+            <a:off x="640080" y="3429000"/>
+            <a:ext cx="3840480" cy="1554480"/>
+          </a:xfrm>
+          <a:prstGeom prst="rect">
+            <a:avLst/>
+          </a:prstGeom>
+          <a:solidFill>
+            <a:srgbClr val="F5F1E8"/>
+          </a:solidFill>
+          <a:ln w="12700">
+            <a:solidFill>
+              <a:srgbClr val="C9B991"/>
+            </a:solidFill>
+          </a:ln>
+          <a:effectLst/>
+        </p:spPr>
+        <p:style>
+          <a:lnRef idx="1">
+            <a:schemeClr val="accent1"/>
+          </a:lnRef>
+          <a:fillRef idx="3">
+            <a:schemeClr val="accent1"/>
+          </a:fillRef>
+          <a:effectRef idx="2">
+            <a:schemeClr val="accent1"/>
+          </a:effectRef>
+          <a:fontRef idx="minor">
+            <a:schemeClr val="lt1"/>
+          </a:fontRef>
+        </p:style>
+        <p:txBody>
+          <a:bodyPr wrap="square" lIns="27432" tIns="22860" rIns="27432" bIns="22860" rtlCol="0" anchor="ctr"/>
+          <a:lstStyle/>
+          <a:p>
+            <a:pPr algn="ctr"/>
+            <a:r>
+              <a:rPr sz="2000" b="1" i="0" dirty="0">
+                <a:solidFill>
+                  <a:srgbClr val="5C4826"/>
+                </a:solidFill>
+              </a:rPr>
+              <a:t>A web startup</a:t>
+            </a:r>
+          </a:p>
+          <a:p>
+            <a:pPr algn="ctr">
+              <a:spcBef>
+                <a:spcPts val="600"/>
+              </a:spcBef>
+            </a:pPr>
+            <a:r>
+              <a:rPr sz="2000" b="0" i="0" dirty="0">
+                <a:solidFill>
+                  <a:srgbClr val="5C4826"/>
+                </a:solidFill>
+              </a:rPr>
+              <a:t>twenty deploys a day,</a:t>
+            </a:r>
+          </a:p>
+          <a:p>
+            <a:pPr algn="ctr">
+              <a:spcBef>
+                <a:spcPts val="200"/>
+              </a:spcBef>
+            </a:pPr>
+            <a:r>
+              <a:rPr sz="2000" b="0" i="0" dirty="0">
+                <a:solidFill>
+                  <a:srgbClr val="5C4826"/>
+                </a:solidFill>
+              </a:rPr>
+              <a:t>each small and reversible</a:t>
+            </a:r>
+          </a:p>
+        </p:txBody>
+      </p:sp>
+      <p:sp>
+        <p:nvSpPr>
+          <p:cNvPr id="1009" name="Card"/>
+          <p:cNvSpPr/>
+          <p:nvPr/>
+        </p:nvSpPr>
+        <p:spPr>
+          <a:xfrm>
+            <a:off x="4800600" y="3429000"/>
+            <a:ext cx="3840480" cy="1554480"/>
+          </a:xfrm>
+          <a:prstGeom prst="rect">
+            <a:avLst/>
+          </a:prstGeom>
+          <a:solidFill>
+            <a:srgbClr val="F5F1E8"/>
+          </a:solidFill>
+          <a:ln w="12700">
+            <a:solidFill>
+              <a:srgbClr val="C9B991"/>
+            </a:solidFill>
+          </a:ln>
+          <a:effectLst/>
+        </p:spPr>
+        <p:style>
+          <a:lnRef idx="1">
+            <a:schemeClr val="accent1"/>
+          </a:lnRef>
+          <a:fillRef idx="3">
+            <a:schemeClr val="accent1"/>
+          </a:fillRef>
+          <a:effectRef idx="2">
+            <a:schemeClr val="accent1"/>
+          </a:effectRef>
+          <a:fontRef idx="minor">
+            <a:schemeClr val="lt1"/>
+          </a:fontRef>
+        </p:style>
+        <p:txBody>
+          <a:bodyPr wrap="square" lIns="27432" tIns="22860" rIns="27432" bIns="22860" rtlCol="0" anchor="ctr"/>
+          <a:lstStyle/>
+          <a:p>
+            <a:pPr algn="ctr"/>
+            <a:r>
+              <a:rPr sz="2000" b="1" i="0" dirty="0">
+                <a:solidFill>
+                  <a:srgbClr val="5C4826"/>
+                </a:solidFill>
+              </a:rPr>
+              <a:t>A medical-device team</a:t>
+            </a:r>
+          </a:p>
+          <a:p>
+            <a:pPr algn="ctr">
+              <a:spcBef>
+                <a:spcPts val="600"/>
+              </a:spcBef>
+            </a:pPr>
+            <a:r>
+              <a:rPr sz="2000" b="0" i="0" dirty="0">
+                <a:solidFill>
+                  <a:srgbClr val="5C4826"/>
+                </a:solidFill>
+              </a:rPr>
+              <a:t>one release a quarter,</a:t>
+            </a:r>
+          </a:p>
+          <a:p>
+            <a:pPr algn="ctr">
+              <a:spcBef>
+                <a:spcPts val="200"/>
+              </a:spcBef>
+            </a:pPr>
+            <a:r>
+              <a:rPr sz="2000" b="0" i="0" dirty="0">
+                <a:solidFill>
+                  <a:srgbClr val="5C4826"/>
+                </a:solidFill>
+              </a:rPr>
+              <a:t>under regulatory review</a:t>
+            </a:r>
+          </a:p>
+        </p:txBody>
+      </p:sp>
+      <p:sp>
+        <p:nvSpPr>
+          <p:cNvPr id="1010" name="FooterBand"/>
+          <p:cNvSpPr/>
+          <p:nvPr/>
+        </p:nvSpPr>
+        <p:spPr>
+          <a:xfrm>
+            <a:off x="274320" y="5512918"/>
+            <a:ext cx="8595360" cy="905256"/>
+          </a:xfrm>
+          <a:prstGeom prst="rect">
+            <a:avLst/>
+          </a:prstGeom>
+          <a:solidFill>
+            <a:srgbClr val="8E6F3E"/>
+          </a:solidFill>
+          <a:ln>
+            <a:noFill/>
+          </a:ln>
+          <a:effectLst/>
+        </p:spPr>
+        <p:style>
+          <a:lnRef idx="1">
+            <a:schemeClr val="accent1"/>
+          </a:lnRef>
+          <a:fillRef idx="3">
+            <a:schemeClr val="accent1"/>
+          </a:fillRef>
+          <a:effectRef idx="2">
+            <a:schemeClr val="accent1"/>
+          </a:effectRef>
+          <a:fontRef idx="minor">
+            <a:schemeClr val="lt1"/>
+          </a:fontRef>
+        </p:style>
+        <p:txBody>
+          <a:bodyPr wrap="square" lIns="27432" tIns="22860" rIns="27432" bIns="22860" rtlCol="0" anchor="ctr"/>
+          <a:lstStyle/>
+          <a:p>
+            <a:pPr algn="ctr"/>
+            <a:r>
+              <a:rPr sz="2000" b="1" i="0" dirty="0">
+                <a:solidFill>
+                  <a:srgbClr val="FFFFFF"/>
+                </a:solidFill>
+              </a:rPr>
+              <a:t>The pipeline is green. Should you ship?</a:t>
+            </a:r>
+          </a:p>
+        </p:txBody>
+      </p:sp>
+    </p:spTree>
+  </p:cSld>
+  <p:clrMapOvr>
+    <a:masterClrMapping/>
+  </p:clrMapOvr>
+</p:sld>
+</file>
+
+<file path=ppt/slides/slide17.xml><?xml version="1.0" encoding="utf-8"?>
+<p:sld xmlns:a="http://schemas.openxmlformats.org/drawingml/2006/main" xmlns:p="http://schemas.openxmlformats.org/presentationml/2006/main" xmlns:r="http://schemas.openxmlformats.org/officeDocument/2006/relationships">
+  <p:cSld>
+    <p:spTree>
+      <p:nvGrpSpPr>
+        <p:cNvPr id="1" name=""/>
+        <p:cNvGrpSpPr/>
+        <p:nvPr/>
+      </p:nvGrpSpPr>
+      <p:grpSpPr/>
+      <p:sp>
+        <p:nvSpPr>
+          <p:cNvPr id="3" name="Title 2"/>
+          <p:cNvSpPr>
+            <a:spLocks noGrp="1"/>
+          </p:cNvSpPr>
+          <p:nvPr>
+            <p:ph type="title"/>
+          </p:nvPr>
+        </p:nvSpPr>
+        <p:spPr/>
+        <p:txBody>
+          <a:bodyPr wrap="square"/>
+          <a:lstStyle/>
+          <a:p>
+            <a:pPr algn="l"/>
+            <a:r>
+              <a:rPr sz="2400" b="0" i="0" dirty="0">
+                <a:solidFill>
+                  <a:srgbClr val="000000"/>
+                </a:solidFill>
+              </a:rPr>
+              <a:t>Release strategies control exposure</a:t>
+            </a:r>
+          </a:p>
+        </p:txBody>
+      </p:sp>
+      <p:sp>
+        <p:nvSpPr>
+          <p:cNvPr id="1001" name="Slide Number Placeholder 900"/>
+          <p:cNvSpPr>
+            <a:spLocks noGrp="1"/>
+          </p:cNvSpPr>
+          <p:nvPr>
+            <p:ph type="sldNum" sz="quarter" idx="4"/>
+          </p:nvPr>
+        </p:nvSpPr>
+        <p:spPr/>
+        <p:txBody>
+          <a:bodyPr/>
+          <a:lstStyle/>
+          <a:p>
+            <a:fld id="{B3291E67-7172-4DCF-B35F-54404EBE6160}" type="slidenum">
+              <a:rPr lang="en-US" smtClean="0"/>
+              <a:t>1</a:t>
+            </a:fld>
+            <a:endParaRPr lang="en-US"/>
+          </a:p>
+        </p:txBody>
+      </p:sp>
+      <p:sp>
+        <p:nvSpPr>
+          <p:cNvPr id="1002" name="Label"/>
+          <p:cNvSpPr/>
+          <p:nvPr/>
+        </p:nvSpPr>
+        <p:spPr>
+          <a:xfrm>
+            <a:off x="411480" y="1051560"/>
+            <a:ext cx="2194560" cy="365760"/>
+          </a:xfrm>
+          <a:prstGeom prst="rect">
+            <a:avLst/>
+          </a:prstGeom>
+          <a:noFill/>
+          <a:ln>
+            <a:noFill/>
+          </a:ln>
+          <a:effectLst/>
+        </p:spPr>
+        <p:style>
+          <a:lnRef idx="1">
+            <a:schemeClr val="accent1"/>
+          </a:lnRef>
+          <a:fillRef idx="3">
+            <a:schemeClr val="accent1"/>
+          </a:fillRef>
+          <a:effectRef idx="2">
+            <a:schemeClr val="accent1"/>
+          </a:effectRef>
+          <a:fontRef idx="minor">
+            <a:schemeClr val="lt1"/>
+          </a:fontRef>
+        </p:style>
+        <p:txBody>
+          <a:bodyPr wrap="square" lIns="27432" tIns="22860" rIns="27432" bIns="22860" rtlCol="0" anchor="ctr"/>
+          <a:lstStyle/>
+          <a:p>
+            <a:pPr algn="l"/>
+            <a:r>
+              <a:rPr sz="2000" b="1" i="0" dirty="0">
+                <a:solidFill>
+                  <a:srgbClr val="5C4826"/>
+                </a:solidFill>
+              </a:rPr>
+              <a:t>STRATEGY</a:t>
+            </a:r>
+          </a:p>
+        </p:txBody>
+      </p:sp>
+      <p:sp>
+        <p:nvSpPr>
+          <p:cNvPr id="1003" name="Label"/>
+          <p:cNvSpPr/>
+          <p:nvPr/>
+        </p:nvSpPr>
+        <p:spPr>
+          <a:xfrm>
+            <a:off x="2880360" y="1051560"/>
+            <a:ext cx="5852160" cy="365760"/>
+          </a:xfrm>
+          <a:prstGeom prst="rect">
+            <a:avLst/>
+          </a:prstGeom>
+          <a:noFill/>
+          <a:ln>
+            <a:noFill/>
+          </a:ln>
+          <a:effectLst/>
+        </p:spPr>
+        <p:style>
+          <a:lnRef idx="1">
+            <a:schemeClr val="accent1"/>
+          </a:lnRef>
+          <a:fillRef idx="3">
+            <a:schemeClr val="accent1"/>
+          </a:fillRef>
+          <a:effectRef idx="2">
+            <a:schemeClr val="accent1"/>
+          </a:effectRef>
+          <a:fontRef idx="minor">
+            <a:schemeClr val="lt1"/>
+          </a:fontRef>
+        </p:style>
+        <p:txBody>
+          <a:bodyPr wrap="square" lIns="27432" tIns="22860" rIns="27432" bIns="22860" rtlCol="0" anchor="ctr"/>
+          <a:lstStyle/>
+          <a:p>
+            <a:pPr algn="l"/>
+            <a:r>
+              <a:rPr sz="2000" b="1" i="0" dirty="0">
+                <a:solidFill>
+                  <a:srgbClr val="5C4826"/>
+                </a:solidFill>
+              </a:rPr>
+              <a:t>WHAT THE ENGINEER CONTROLS</a:t>
+            </a:r>
+          </a:p>
+        </p:txBody>
+      </p:sp>
+      <p:sp>
+        <p:nvSpPr>
+          <p:cNvPr id="1004" name="Block"/>
+          <p:cNvSpPr/>
+          <p:nvPr/>
+        </p:nvSpPr>
+        <p:spPr>
+          <a:xfrm>
+            <a:off x="411480" y="1554480"/>
+            <a:ext cx="2194560" cy="685800"/>
+          </a:xfrm>
+          <a:prstGeom prst="rect">
+            <a:avLst/>
+          </a:prstGeom>
+          <a:solidFill>
+            <a:srgbClr val="8E6F3E"/>
+          </a:solidFill>
+          <a:ln>
+            <a:noFill/>
+          </a:ln>
+          <a:effectLst/>
+        </p:spPr>
+        <p:style>
+          <a:lnRef idx="1">
+            <a:schemeClr val="accent1"/>
+          </a:lnRef>
+          <a:fillRef idx="3">
+            <a:schemeClr val="accent1"/>
+          </a:fillRef>
+          <a:effectRef idx="2">
+            <a:schemeClr val="accent1"/>
+          </a:effectRef>
+          <a:fontRef idx="minor">
+            <a:schemeClr val="lt1"/>
+          </a:fontRef>
+        </p:style>
+        <p:txBody>
+          <a:bodyPr wrap="square" lIns="27432" tIns="22860" rIns="27432" bIns="22860" rtlCol="0" anchor="ctr"/>
+          <a:lstStyle/>
+          <a:p>
+            <a:pPr algn="ctr"/>
+            <a:r>
+              <a:rPr sz="2000" b="1" i="0" dirty="0">
+                <a:solidFill>
+                  <a:srgbClr val="FFFFFF"/>
+                </a:solidFill>
+              </a:rPr>
+              <a:t>BLUE-GREEN</a:t>
+            </a:r>
+          </a:p>
+        </p:txBody>
+      </p:sp>
+      <p:sp>
+        <p:nvSpPr>
+          <p:cNvPr id="1005" name="Label"/>
+          <p:cNvSpPr/>
+          <p:nvPr/>
+        </p:nvSpPr>
+        <p:spPr>
+          <a:xfrm>
+            <a:off x="2880360" y="1572768"/>
+            <a:ext cx="5852160" cy="658368"/>
+          </a:xfrm>
+          <a:prstGeom prst="rect">
+            <a:avLst/>
+          </a:prstGeom>
+          <a:noFill/>
+          <a:ln>
+            <a:noFill/>
+          </a:ln>
+          <a:effectLst/>
+        </p:spPr>
+        <p:style>
+          <a:lnRef idx="1">
+            <a:schemeClr val="accent1"/>
+          </a:lnRef>
+          <a:fillRef idx="3">
+            <a:schemeClr val="accent1"/>
+          </a:fillRef>
+          <a:effectRef idx="2">
+            <a:schemeClr val="accent1"/>
+          </a:effectRef>
+          <a:fontRef idx="minor">
+            <a:schemeClr val="lt1"/>
+          </a:fontRef>
+        </p:style>
+        <p:txBody>
+          <a:bodyPr wrap="square" lIns="27432" tIns="22860" rIns="27432" bIns="22860" rtlCol="0" anchor="ctr"/>
+          <a:lstStyle/>
+          <a:p>
+            <a:pPr algn="l"/>
+            <a:r>
+              <a:rPr sz="2000" b="0" i="0" dirty="0">
+                <a:solidFill>
+                  <a:srgbClr val="555960"/>
+                </a:solidFill>
+              </a:rPr>
+              <a:t>which environment serves production traffic</a:t>
+            </a:r>
+          </a:p>
+        </p:txBody>
+      </p:sp>
+      <p:sp>
+        <p:nvSpPr>
+          <p:cNvPr id="1006" name="Block"/>
+          <p:cNvSpPr/>
+          <p:nvPr/>
+        </p:nvSpPr>
+        <p:spPr>
+          <a:xfrm>
+            <a:off x="411480" y="2423160"/>
+            <a:ext cx="2194560" cy="685800"/>
+          </a:xfrm>
+          <a:prstGeom prst="rect">
+            <a:avLst/>
+          </a:prstGeom>
+          <a:solidFill>
+            <a:srgbClr val="8E6F3E"/>
+          </a:solidFill>
+          <a:ln>
+            <a:noFill/>
+          </a:ln>
+          <a:effectLst/>
+        </p:spPr>
+        <p:style>
+          <a:lnRef idx="1">
+            <a:schemeClr val="accent1"/>
+          </a:lnRef>
+          <a:fillRef idx="3">
+            <a:schemeClr val="accent1"/>
+          </a:fillRef>
+          <a:effectRef idx="2">
+            <a:schemeClr val="accent1"/>
+          </a:effectRef>
+          <a:fontRef idx="minor">
+            <a:schemeClr val="lt1"/>
+          </a:fontRef>
+        </p:style>
+        <p:txBody>
+          <a:bodyPr wrap="square" lIns="27432" tIns="22860" rIns="27432" bIns="22860" rtlCol="0" anchor="ctr"/>
+          <a:lstStyle/>
+          <a:p>
+            <a:pPr algn="ctr"/>
+            <a:r>
+              <a:rPr sz="2000" b="1" i="0" dirty="0">
+                <a:solidFill>
+                  <a:srgbClr val="FFFFFF"/>
+                </a:solidFill>
+              </a:rPr>
+              <a:t>CANARY</a:t>
+            </a:r>
+          </a:p>
+        </p:txBody>
+      </p:sp>
+      <p:sp>
+        <p:nvSpPr>
+          <p:cNvPr id="1007" name="Label"/>
+          <p:cNvSpPr/>
+          <p:nvPr/>
+        </p:nvSpPr>
+        <p:spPr>
+          <a:xfrm>
+            <a:off x="2880360" y="2441448"/>
+            <a:ext cx="5852160" cy="658368"/>
+          </a:xfrm>
+          <a:prstGeom prst="rect">
+            <a:avLst/>
+          </a:prstGeom>
+          <a:noFill/>
+          <a:ln>
+            <a:noFill/>
+          </a:ln>
+          <a:effectLst/>
+        </p:spPr>
+        <p:style>
+          <a:lnRef idx="1">
+            <a:schemeClr val="accent1"/>
+          </a:lnRef>
+          <a:fillRef idx="3">
+            <a:schemeClr val="accent1"/>
+          </a:fillRef>
+          <a:effectRef idx="2">
+            <a:schemeClr val="accent1"/>
+          </a:effectRef>
+          <a:fontRef idx="minor">
+            <a:schemeClr val="lt1"/>
+          </a:fontRef>
+        </p:style>
+        <p:txBody>
+          <a:bodyPr wrap="square" lIns="27432" tIns="22860" rIns="27432" bIns="22860" rtlCol="0" anchor="ctr"/>
+          <a:lstStyle/>
+          <a:p>
+            <a:pPr algn="l"/>
+            <a:r>
+              <a:rPr sz="2000" b="0" i="0" dirty="0">
+                <a:solidFill>
+                  <a:srgbClr val="555960"/>
+                </a:solidFill>
+              </a:rPr>
+              <a:t>which fraction of traffic sees the new version</a:t>
+            </a:r>
+          </a:p>
+        </p:txBody>
+      </p:sp>
+      <p:sp>
+        <p:nvSpPr>
+          <p:cNvPr id="1008" name="Block"/>
+          <p:cNvSpPr/>
+          <p:nvPr/>
+        </p:nvSpPr>
+        <p:spPr>
+          <a:xfrm>
+            <a:off x="411480" y="3291840"/>
+            <a:ext cx="2194560" cy="685800"/>
+          </a:xfrm>
+          <a:prstGeom prst="rect">
+            <a:avLst/>
+          </a:prstGeom>
+          <a:solidFill>
+            <a:srgbClr val="8E6F3E"/>
+          </a:solidFill>
+          <a:ln>
+            <a:noFill/>
+          </a:ln>
+          <a:effectLst/>
+        </p:spPr>
+        <p:style>
+          <a:lnRef idx="1">
+            <a:schemeClr val="accent1"/>
+          </a:lnRef>
+          <a:fillRef idx="3">
+            <a:schemeClr val="accent1"/>
+          </a:fillRef>
+          <a:effectRef idx="2">
+            <a:schemeClr val="accent1"/>
+          </a:effectRef>
+          <a:fontRef idx="minor">
+            <a:schemeClr val="lt1"/>
+          </a:fontRef>
+        </p:style>
+        <p:txBody>
+          <a:bodyPr wrap="square" lIns="27432" tIns="22860" rIns="27432" bIns="22860" rtlCol="0" anchor="ctr"/>
+          <a:lstStyle/>
+          <a:p>
+            <a:pPr algn="ctr"/>
+            <a:r>
+              <a:rPr sz="2000" b="1" i="0" dirty="0">
+                <a:solidFill>
+                  <a:srgbClr val="FFFFFF"/>
+                </a:solidFill>
+              </a:rPr>
+              <a:t>FEATURE FLAGS</a:t>
+            </a:r>
+          </a:p>
+        </p:txBody>
+      </p:sp>
+      <p:sp>
+        <p:nvSpPr>
+          <p:cNvPr id="1009" name="Label"/>
+          <p:cNvSpPr/>
+          <p:nvPr/>
+        </p:nvSpPr>
+        <p:spPr>
+          <a:xfrm>
+            <a:off x="2880360" y="3310128"/>
+            <a:ext cx="5852160" cy="658368"/>
+          </a:xfrm>
+          <a:prstGeom prst="rect">
+            <a:avLst/>
+          </a:prstGeom>
+          <a:noFill/>
+          <a:ln>
+            <a:noFill/>
+          </a:ln>
+          <a:effectLst/>
+        </p:spPr>
+        <p:style>
+          <a:lnRef idx="1">
+            <a:schemeClr val="accent1"/>
+          </a:lnRef>
+          <a:fillRef idx="3">
+            <a:schemeClr val="accent1"/>
+          </a:fillRef>
+          <a:effectRef idx="2">
+            <a:schemeClr val="accent1"/>
+          </a:effectRef>
+          <a:fontRef idx="minor">
+            <a:schemeClr val="lt1"/>
+          </a:fontRef>
+        </p:style>
+        <p:txBody>
+          <a:bodyPr wrap="square" lIns="27432" tIns="22860" rIns="27432" bIns="22860" rtlCol="0" anchor="ctr"/>
+          <a:lstStyle/>
+          <a:p>
+            <a:pPr algn="l"/>
+            <a:r>
+              <a:rPr sz="2000" b="0" i="0" dirty="0">
+                <a:solidFill>
+                  <a:srgbClr val="555960"/>
+                </a:solidFill>
+              </a:rPr>
+              <a:t>which functionality is enabled</a:t>
+            </a:r>
+          </a:p>
+        </p:txBody>
+      </p:sp>
+      <p:sp>
+        <p:nvSpPr>
+          <p:cNvPr id="1010" name="Label"/>
+          <p:cNvSpPr/>
+          <p:nvPr/>
+        </p:nvSpPr>
+        <p:spPr>
+          <a:xfrm>
+            <a:off x="411480" y="4389120"/>
+            <a:ext cx="8412480" cy="658368"/>
+          </a:xfrm>
+          <a:prstGeom prst="rect">
+            <a:avLst/>
+          </a:prstGeom>
+          <a:noFill/>
+          <a:ln>
+            <a:noFill/>
+          </a:ln>
+          <a:effectLst/>
+        </p:spPr>
+        <p:style>
+          <a:lnRef idx="1">
+            <a:schemeClr val="accent1"/>
+          </a:lnRef>
+          <a:fillRef idx="3">
+            <a:schemeClr val="accent1"/>
+          </a:fillRef>
+          <a:effectRef idx="2">
+            <a:schemeClr val="accent1"/>
+          </a:effectRef>
+          <a:fontRef idx="minor">
+            <a:schemeClr val="lt1"/>
+          </a:fontRef>
+        </p:style>
+        <p:txBody>
+          <a:bodyPr wrap="square" lIns="27432" tIns="22860" rIns="27432" bIns="22860" rtlCol="0" anchor="ctr"/>
+          <a:lstStyle/>
+          <a:p>
+            <a:pPr algn="ctr"/>
+            <a:r>
+              <a:rPr sz="2000" b="1" i="0" dirty="0">
+                <a:solidFill>
+                  <a:srgbClr val="5C4826"/>
+                </a:solidFill>
+              </a:rPr>
+              <a:t>Three strategies, three dimensions of exposure. None removes the risk; each puts a dial on it.</a:t>
+            </a:r>
+          </a:p>
+        </p:txBody>
+      </p:sp>
+    </p:spTree>
+  </p:cSld>
+  <p:clrMapOvr>
+    <a:masterClrMapping/>
+  </p:clrMapOvr>
+</p:sld>
+</file>
+
+<file path=ppt/slides/slide18.xml><?xml version="1.0" encoding="utf-8"?>
+<p:sld xmlns:a="http://schemas.openxmlformats.org/drawingml/2006/main" xmlns:p="http://schemas.openxmlformats.org/presentationml/2006/main" xmlns:r="http://schemas.openxmlformats.org/officeDocument/2006/relationships">
+  <p:cSld>
+    <p:spTree>
+      <p:nvGrpSpPr>
+        <p:cNvPr id="1" name=""/>
+        <p:cNvGrpSpPr/>
+        <p:nvPr/>
+      </p:nvGrpSpPr>
+      <p:grpSpPr/>
+      <p:sp>
+        <p:nvSpPr>
+          <p:cNvPr id="3" name="Title 2"/>
+          <p:cNvSpPr>
+            <a:spLocks noGrp="1"/>
+          </p:cNvSpPr>
+          <p:nvPr>
+            <p:ph type="title"/>
+          </p:nvPr>
+        </p:nvSpPr>
+        <p:spPr/>
+        <p:txBody>
+          <a:bodyPr wrap="square"/>
+          <a:lstStyle/>
+          <a:p>
+            <a:pPr algn="l"/>
+            <a:r>
+              <a:rPr sz="2400" b="0" i="0" dirty="0">
+                <a:solidFill>
+                  <a:srgbClr val="000000"/>
+                </a:solidFill>
+              </a:rPr>
+              <a:t>Blue-green deployment</a:t>
+            </a:r>
+          </a:p>
+        </p:txBody>
+      </p:sp>
+      <p:sp>
+        <p:nvSpPr>
+          <p:cNvPr id="1001" name="Slide Number Placeholder 900"/>
+          <p:cNvSpPr>
+            <a:spLocks noGrp="1"/>
+          </p:cNvSpPr>
+          <p:nvPr>
+            <p:ph type="sldNum" sz="quarter" idx="4"/>
+          </p:nvPr>
+        </p:nvSpPr>
+        <p:spPr/>
+        <p:txBody>
+          <a:bodyPr/>
+          <a:lstStyle/>
+          <a:p>
+            <a:fld id="{B3291E67-7172-4DCF-B35F-54404EBE6160}" type="slidenum">
+              <a:rPr lang="en-US" smtClean="0"/>
+              <a:t>1</a:t>
+            </a:fld>
+            <a:endParaRPr lang="en-US"/>
+          </a:p>
+        </p:txBody>
+      </p:sp>
+      <p:sp>
+        <p:nvSpPr>
+          <p:cNvPr id="1002" name="Block"/>
+          <p:cNvSpPr/>
+          <p:nvPr/>
+        </p:nvSpPr>
+        <p:spPr>
+          <a:xfrm>
+            <a:off x="3703320" y="1097280"/>
+            <a:ext cx="1737360" cy="731520"/>
+          </a:xfrm>
+          <a:prstGeom prst="rect">
+            <a:avLst/>
+          </a:prstGeom>
+          <a:solidFill>
+            <a:srgbClr val="8E6F3E"/>
+          </a:solidFill>
+          <a:ln>
+            <a:noFill/>
+          </a:ln>
+          <a:effectLst/>
+        </p:spPr>
+        <p:style>
+          <a:lnRef idx="1">
+            <a:schemeClr val="accent1"/>
+          </a:lnRef>
+          <a:fillRef idx="3">
+            <a:schemeClr val="accent1"/>
+          </a:fillRef>
+          <a:effectRef idx="2">
+            <a:schemeClr val="accent1"/>
+          </a:effectRef>
+          <a:fontRef idx="minor">
+            <a:schemeClr val="lt1"/>
+          </a:fontRef>
+        </p:style>
+        <p:txBody>
+          <a:bodyPr wrap="square" lIns="27432" tIns="22860" rIns="27432" bIns="22860" rtlCol="0" anchor="ctr"/>
+          <a:lstStyle/>
+          <a:p>
+            <a:pPr algn="ctr"/>
+            <a:r>
+              <a:rPr sz="2000" b="1" i="0" dirty="0">
+                <a:solidFill>
+                  <a:srgbClr val="FFFFFF"/>
+                </a:solidFill>
+              </a:rPr>
+              <a:t>ROUTER</a:t>
+            </a:r>
+          </a:p>
+        </p:txBody>
+      </p:sp>
+      <p:sp>
+        <p:nvSpPr>
+          <p:cNvPr id="1003" name="Slab"/>
+          <p:cNvSpPr/>
+          <p:nvPr/>
+        </p:nvSpPr>
+        <p:spPr>
+          <a:xfrm>
+            <a:off x="960120" y="2651760"/>
+            <a:ext cx="2834640" cy="1645920"/>
+          </a:xfrm>
+          <a:prstGeom prst="rect">
+            <a:avLst/>
+          </a:prstGeom>
+          <a:solidFill>
+            <a:srgbClr val="F5F1E8"/>
+          </a:solidFill>
+          <a:ln w="12700">
+            <a:solidFill>
+              <a:srgbClr val="C9B991"/>
+            </a:solidFill>
+          </a:ln>
+          <a:effectLst/>
+        </p:spPr>
+        <p:style>
+          <a:lnRef idx="1">
+            <a:schemeClr val="accent1"/>
+          </a:lnRef>
+          <a:fillRef idx="3">
+            <a:schemeClr val="accent1"/>
+          </a:fillRef>
+          <a:effectRef idx="2">
+            <a:schemeClr val="accent1"/>
+          </a:effectRef>
+          <a:fontRef idx="minor">
+            <a:schemeClr val="lt1"/>
+          </a:fontRef>
+        </p:style>
+        <p:txBody>
+          <a:bodyPr wrap="square" lIns="27432" tIns="22860" rIns="27432" bIns="22860" rtlCol="0" anchor="ctr"/>
+          <a:lstStyle/>
+          <a:p/>
+        </p:txBody>
+      </p:sp>
+      <p:sp>
+        <p:nvSpPr>
+          <p:cNvPr id="1004" name="Label"/>
+          <p:cNvSpPr/>
+          <p:nvPr/>
+        </p:nvSpPr>
+        <p:spPr>
+          <a:xfrm>
+            <a:off x="1143000" y="2743200"/>
+            <a:ext cx="2468880" cy="365760"/>
+          </a:xfrm>
+          <a:prstGeom prst="rect">
+            <a:avLst/>
+          </a:prstGeom>
+          <a:noFill/>
+          <a:ln>
+            <a:noFill/>
+          </a:ln>
+          <a:effectLst/>
+        </p:spPr>
+        <p:style>
+          <a:lnRef idx="1">
+            <a:schemeClr val="accent1"/>
+          </a:lnRef>
+          <a:fillRef idx="3">
+            <a:schemeClr val="accent1"/>
+          </a:fillRef>
+          <a:effectRef idx="2">
+            <a:schemeClr val="accent1"/>
+          </a:effectRef>
+          <a:fontRef idx="minor">
+            <a:schemeClr val="lt1"/>
+          </a:fontRef>
+        </p:style>
+        <p:txBody>
+          <a:bodyPr wrap="square" lIns="27432" tIns="22860" rIns="27432" bIns="22860" rtlCol="0" anchor="ctr"/>
+          <a:lstStyle/>
+          <a:p>
+            <a:pPr algn="ctr"/>
+            <a:r>
+              <a:rPr sz="2000" b="1" i="0" dirty="0">
+                <a:solidFill>
+                  <a:srgbClr val="5C4826"/>
+                </a:solidFill>
+              </a:rPr>
+              <a:t>BLUE</a:t>
+            </a:r>
+          </a:p>
+        </p:txBody>
+      </p:sp>
+      <p:sp>
+        <p:nvSpPr>
+          <p:cNvPr id="1005" name="Block"/>
+          <p:cNvSpPr/>
+          <p:nvPr/>
+        </p:nvSpPr>
+        <p:spPr>
+          <a:xfrm>
+            <a:off x="1325880" y="3246120"/>
+            <a:ext cx="2103120" cy="777240"/>
+          </a:xfrm>
+          <a:prstGeom prst="rect">
+            <a:avLst/>
+          </a:prstGeom>
+          <a:solidFill>
+            <a:srgbClr val="8E6F3E"/>
+          </a:solidFill>
+          <a:ln>
+            <a:noFill/>
+          </a:ln>
+          <a:effectLst/>
+        </p:spPr>
+        <p:style>
+          <a:lnRef idx="1">
+            <a:schemeClr val="accent1"/>
+          </a:lnRef>
+          <a:fillRef idx="3">
+            <a:schemeClr val="accent1"/>
+          </a:fillRef>
+          <a:effectRef idx="2">
+            <a:schemeClr val="accent1"/>
+          </a:effectRef>
+          <a:fontRef idx="minor">
+            <a:schemeClr val="lt1"/>
+          </a:fontRef>
+        </p:style>
+        <p:txBody>
+          <a:bodyPr wrap="square" lIns="27432" tIns="22860" rIns="27432" bIns="22860" rtlCol="0" anchor="ctr"/>
+          <a:lstStyle/>
+          <a:p>
+            <a:pPr algn="ctr"/>
+            <a:r>
+              <a:rPr sz="2000" b="1" i="0" dirty="0">
+                <a:solidFill>
+                  <a:srgbClr val="FFFFFF"/>
+                </a:solidFill>
+              </a:rPr>
+              <a:t>version 1</a:t>
+            </a:r>
+          </a:p>
+          <a:p>
+            <a:pPr algn="ctr"/>
+            <a:r>
+              <a:rPr sz="2000" b="0" i="1" dirty="0">
+                <a:solidFill>
+                  <a:srgbClr val="FFFFFF"/>
+                </a:solidFill>
+              </a:rPr>
+              <a:t>live</a:t>
+            </a:r>
+          </a:p>
+        </p:txBody>
+      </p:sp>
+      <p:sp>
+        <p:nvSpPr>
+          <p:cNvPr id="1006" name="Slab"/>
+          <p:cNvSpPr/>
+          <p:nvPr/>
+        </p:nvSpPr>
+        <p:spPr>
+          <a:xfrm>
+            <a:off x="5349240" y="2651760"/>
+            <a:ext cx="2834640" cy="1645920"/>
+          </a:xfrm>
+          <a:prstGeom prst="rect">
+            <a:avLst/>
+          </a:prstGeom>
+          <a:solidFill>
+            <a:srgbClr val="F5F1E8"/>
+          </a:solidFill>
+          <a:ln w="12700">
+            <a:solidFill>
+              <a:srgbClr val="C9B991"/>
+            </a:solidFill>
+            <a:prstDash val="dash"/>
+          </a:ln>
+          <a:effectLst/>
+        </p:spPr>
+        <p:style>
+          <a:lnRef idx="1">
+            <a:schemeClr val="accent1"/>
+          </a:lnRef>
+          <a:fillRef idx="3">
+            <a:schemeClr val="accent1"/>
+          </a:fillRef>
+          <a:effectRef idx="2">
+            <a:schemeClr val="accent1"/>
+          </a:effectRef>
+          <a:fontRef idx="minor">
+            <a:schemeClr val="lt1"/>
+          </a:fontRef>
+        </p:style>
+        <p:txBody>
+          <a:bodyPr wrap="square" lIns="27432" tIns="22860" rIns="27432" bIns="22860" rtlCol="0" anchor="ctr"/>
+          <a:lstStyle/>
+          <a:p/>
+        </p:txBody>
+      </p:sp>
+      <p:sp>
+        <p:nvSpPr>
+          <p:cNvPr id="1007" name="Label"/>
+          <p:cNvSpPr/>
+          <p:nvPr/>
+        </p:nvSpPr>
+        <p:spPr>
+          <a:xfrm>
+            <a:off x="5532120" y="2743200"/>
+            <a:ext cx="2468880" cy="365760"/>
+          </a:xfrm>
+          <a:prstGeom prst="rect">
+            <a:avLst/>
+          </a:prstGeom>
+          <a:noFill/>
+          <a:ln>
+            <a:noFill/>
+          </a:ln>
+          <a:effectLst/>
+        </p:spPr>
+        <p:style>
+          <a:lnRef idx="1">
+            <a:schemeClr val="accent1"/>
+          </a:lnRef>
+          <a:fillRef idx="3">
+            <a:schemeClr val="accent1"/>
+          </a:fillRef>
+          <a:effectRef idx="2">
+            <a:schemeClr val="accent1"/>
+          </a:effectRef>
+          <a:fontRef idx="minor">
+            <a:schemeClr val="lt1"/>
+          </a:fontRef>
+        </p:style>
+        <p:txBody>
+          <a:bodyPr wrap="square" lIns="27432" tIns="22860" rIns="27432" bIns="22860" rtlCol="0" anchor="ctr"/>
+          <a:lstStyle/>
+          <a:p>
+            <a:pPr algn="ctr"/>
+            <a:r>
+              <a:rPr sz="2000" b="1" i="0" dirty="0">
+                <a:solidFill>
+                  <a:srgbClr val="5C4826"/>
+                </a:solidFill>
+              </a:rPr>
+              <a:t>GREEN</a:t>
+            </a:r>
+          </a:p>
+        </p:txBody>
+      </p:sp>
+      <p:sp>
+        <p:nvSpPr>
+          <p:cNvPr id="1008" name="Block"/>
+          <p:cNvSpPr/>
+          <p:nvPr/>
+        </p:nvSpPr>
+        <p:spPr>
+          <a:xfrm>
+            <a:off x="5715000" y="3246120"/>
+            <a:ext cx="2103120" cy="777240"/>
+          </a:xfrm>
+          <a:prstGeom prst="rect">
+            <a:avLst/>
+          </a:prstGeom>
+          <a:solidFill>
+            <a:srgbClr val="8E6F3E"/>
+          </a:solidFill>
+          <a:ln>
+            <a:noFill/>
+          </a:ln>
+          <a:effectLst/>
+        </p:spPr>
+        <p:style>
+          <a:lnRef idx="1">
+            <a:schemeClr val="accent1"/>
+          </a:lnRef>
+          <a:fillRef idx="3">
+            <a:schemeClr val="accent1"/>
+          </a:fillRef>
+          <a:effectRef idx="2">
+            <a:schemeClr val="accent1"/>
+          </a:effectRef>
+          <a:fontRef idx="minor">
+            <a:schemeClr val="lt1"/>
+          </a:fontRef>
+        </p:style>
+        <p:txBody>
+          <a:bodyPr wrap="square" lIns="27432" tIns="22860" rIns="27432" bIns="22860" rtlCol="0" anchor="ctr"/>
+          <a:lstStyle/>
+          <a:p>
+            <a:pPr algn="ctr"/>
+            <a:r>
+              <a:rPr sz="2000" b="1" i="0" dirty="0">
+                <a:solidFill>
+                  <a:srgbClr val="FFFFFF"/>
+                </a:solidFill>
+              </a:rPr>
+              <a:t>version 2</a:t>
+            </a:r>
+          </a:p>
+          <a:p>
+            <a:pPr algn="ctr"/>
+            <a:r>
+              <a:rPr sz="2000" b="0" i="1" dirty="0">
+                <a:solidFill>
+                  <a:srgbClr val="FFFFFF"/>
+                </a:solidFill>
+              </a:rPr>
+              <a:t>idle, ready</a:t>
+            </a:r>
+          </a:p>
+        </p:txBody>
+      </p:sp>
+      <p:cxnSp>
+        <p:nvCxnSpPr>
+          <p:cNvPr id="1009" name="Connector"/>
+          <p:cNvCxnSpPr/>
+          <p:nvPr/>
+        </p:nvCxnSpPr>
+        <p:spPr>
+          <a:xfrm>
+            <a:off x="2377440" y="1847088"/>
+            <a:ext cx="0" cy="786384"/>
+          </a:xfrm>
+          <a:prstGeom prst="line">
+            <a:avLst/>
+          </a:prstGeom>
+          <a:ln w="19050">
+            <a:solidFill>
+              <a:srgbClr val="8E6F3E"/>
+            </a:solidFill>
+            <a:tailEnd type="triangle"/>
+          </a:ln>
+        </p:spPr>
+        <p:style>
+          <a:lnRef idx="2">
+            <a:schemeClr val="accent1"/>
+          </a:lnRef>
+          <a:fillRef idx="0">
+            <a:schemeClr val="accent1"/>
+          </a:fillRef>
+          <a:effectRef idx="1">
+            <a:schemeClr val="accent1"/>
+          </a:effectRef>
+          <a:fontRef idx="minor">
+            <a:schemeClr val="tx1"/>
+          </a:fontRef>
+        </p:style>
+      </p:cxnSp>
+      <p:cxnSp>
+        <p:nvCxnSpPr>
+          <p:cNvPr id="1010" name="Connector"/>
+          <p:cNvCxnSpPr/>
+          <p:nvPr/>
+        </p:nvCxnSpPr>
+        <p:spPr>
+          <a:xfrm>
+            <a:off x="2377440" y="1463040"/>
+            <a:ext cx="1307592" cy="0"/>
+          </a:xfrm>
+          <a:prstGeom prst="line">
+            <a:avLst/>
+          </a:prstGeom>
+          <a:ln w="19050">
+            <a:solidFill>
+              <a:srgbClr val="8E6F3E"/>
+            </a:solidFill>
+          </a:ln>
+        </p:spPr>
+        <p:style>
+          <a:lnRef idx="2">
+            <a:schemeClr val="accent1"/>
+          </a:lnRef>
+          <a:fillRef idx="0">
+            <a:schemeClr val="accent1"/>
+          </a:fillRef>
+          <a:effectRef idx="1">
+            <a:schemeClr val="accent1"/>
+          </a:effectRef>
+          <a:fontRef idx="minor">
+            <a:schemeClr val="tx1"/>
+          </a:fontRef>
+        </p:style>
+      </p:cxnSp>
+      <p:cxnSp>
+        <p:nvCxnSpPr>
+          <p:cNvPr id="1011" name="Connector"/>
+          <p:cNvCxnSpPr/>
+          <p:nvPr/>
+        </p:nvCxnSpPr>
+        <p:spPr>
+          <a:xfrm>
+            <a:off x="6766560" y="1847088"/>
+            <a:ext cx="0" cy="786384"/>
+          </a:xfrm>
+          <a:prstGeom prst="line">
+            <a:avLst/>
+          </a:prstGeom>
+          <a:ln w="19050">
+            <a:solidFill>
+              <a:srgbClr val="8E6F3E"/>
+            </a:solidFill>
+            <a:prstDash val="dash"/>
+            <a:tailEnd type="triangle"/>
+          </a:ln>
+        </p:spPr>
+        <p:style>
+          <a:lnRef idx="2">
+            <a:schemeClr val="accent1"/>
+          </a:lnRef>
+          <a:fillRef idx="0">
+            <a:schemeClr val="accent1"/>
+          </a:fillRef>
+          <a:effectRef idx="1">
+            <a:schemeClr val="accent1"/>
+          </a:effectRef>
+          <a:fontRef idx="minor">
+            <a:schemeClr val="tx1"/>
+          </a:fontRef>
+        </p:style>
+      </p:cxnSp>
+      <p:cxnSp>
+        <p:nvCxnSpPr>
+          <p:cNvPr id="1012" name="Connector"/>
+          <p:cNvCxnSpPr/>
+          <p:nvPr/>
+        </p:nvCxnSpPr>
+        <p:spPr>
+          <a:xfrm>
+            <a:off x="5458968" y="1463040"/>
+            <a:ext cx="1307592" cy="0"/>
+          </a:xfrm>
+          <a:prstGeom prst="line">
+            <a:avLst/>
+          </a:prstGeom>
+          <a:ln w="19050">
+            <a:solidFill>
+              <a:srgbClr val="8E6F3E"/>
+            </a:solidFill>
+            <a:prstDash val="dash"/>
+          </a:ln>
+        </p:spPr>
+        <p:style>
+          <a:lnRef idx="2">
+            <a:schemeClr val="accent1"/>
+          </a:lnRef>
+          <a:fillRef idx="0">
+            <a:schemeClr val="accent1"/>
+          </a:fillRef>
+          <a:effectRef idx="1">
+            <a:schemeClr val="accent1"/>
+          </a:effectRef>
+          <a:fontRef idx="minor">
+            <a:schemeClr val="tx1"/>
+          </a:fontRef>
+        </p:style>
+      </p:cxnSp>
+      <p:sp>
+        <p:nvSpPr>
+          <p:cNvPr id="1013" name="Label"/>
+          <p:cNvSpPr/>
+          <p:nvPr/>
+        </p:nvSpPr>
+        <p:spPr>
+          <a:xfrm>
+            <a:off x="548640" y="1920240"/>
+            <a:ext cx="1554480" cy="365760"/>
+          </a:xfrm>
+          <a:prstGeom prst="rect">
+            <a:avLst/>
+          </a:prstGeom>
+          <a:noFill/>
+          <a:ln>
+            <a:noFill/>
+          </a:ln>
+          <a:effectLst/>
+        </p:spPr>
+        <p:style>
+          <a:lnRef idx="1">
+            <a:schemeClr val="accent1"/>
+          </a:lnRef>
+          <a:fillRef idx="3">
+            <a:schemeClr val="accent1"/>
+          </a:fillRef>
+          <a:effectRef idx="2">
+            <a:schemeClr val="accent1"/>
+          </a:effectRef>
+          <a:fontRef idx="minor">
+            <a:schemeClr val="lt1"/>
+          </a:fontRef>
+        </p:style>
+        <p:txBody>
+          <a:bodyPr wrap="square" lIns="27432" tIns="22860" rIns="27432" bIns="22860" rtlCol="0" anchor="ctr"/>
+          <a:lstStyle/>
+          <a:p>
+            <a:pPr algn="l"/>
+            <a:r>
+              <a:rPr sz="2000" b="0" i="0" dirty="0">
+                <a:solidFill>
+                  <a:srgbClr val="555960"/>
+                </a:solidFill>
+              </a:rPr>
+              <a:t>100% now</a:t>
+            </a:r>
+          </a:p>
+        </p:txBody>
+      </p:sp>
+      <p:sp>
+        <p:nvSpPr>
+          <p:cNvPr id="1014" name="Label"/>
+          <p:cNvSpPr/>
+          <p:nvPr/>
+        </p:nvSpPr>
+        <p:spPr>
+          <a:xfrm>
+            <a:off x="6949440" y="1920240"/>
+            <a:ext cx="1828800" cy="365760"/>
+          </a:xfrm>
+          <a:prstGeom prst="rect">
+            <a:avLst/>
+          </a:prstGeom>
+          <a:noFill/>
+          <a:ln>
+            <a:noFill/>
+          </a:ln>
+          <a:effectLst/>
+        </p:spPr>
+        <p:style>
+          <a:lnRef idx="1">
+            <a:schemeClr val="accent1"/>
+          </a:lnRef>
+          <a:fillRef idx="3">
+            <a:schemeClr val="accent1"/>
+          </a:fillRef>
+          <a:effectRef idx="2">
+            <a:schemeClr val="accent1"/>
+          </a:effectRef>
+          <a:fontRef idx="minor">
+            <a:schemeClr val="lt1"/>
+          </a:fontRef>
+        </p:style>
+        <p:txBody>
+          <a:bodyPr wrap="square" lIns="27432" tIns="22860" rIns="27432" bIns="22860" rtlCol="0" anchor="ctr"/>
+          <a:lstStyle/>
+          <a:p>
+            <a:pPr algn="l"/>
+            <a:r>
+              <a:rPr sz="2000" b="0" i="0" dirty="0">
+                <a:solidFill>
+                  <a:srgbClr val="555960"/>
+                </a:solidFill>
+              </a:rPr>
+              <a:t>after the switch</a:t>
+            </a:r>
+          </a:p>
+        </p:txBody>
+      </p:sp>
+      <p:sp>
+        <p:nvSpPr>
+          <p:cNvPr id="1015" name="Card"/>
+          <p:cNvSpPr/>
+          <p:nvPr/>
+        </p:nvSpPr>
+        <p:spPr>
+          <a:xfrm>
+            <a:off x="960120" y="4572000"/>
+            <a:ext cx="7223760" cy="868680"/>
+          </a:xfrm>
+          <a:prstGeom prst="rect">
+            <a:avLst/>
+          </a:prstGeom>
+          <a:solidFill>
+            <a:srgbClr val="F5F1E8"/>
+          </a:solidFill>
+          <a:ln w="12700">
+            <a:solidFill>
+              <a:srgbClr val="C9B991"/>
+            </a:solidFill>
+          </a:ln>
+          <a:effectLst/>
+        </p:spPr>
+        <p:style>
+          <a:lnRef idx="1">
+            <a:schemeClr val="accent1"/>
+          </a:lnRef>
+          <a:fillRef idx="3">
+            <a:schemeClr val="accent1"/>
+          </a:fillRef>
+          <a:effectRef idx="2">
+            <a:schemeClr val="accent1"/>
+          </a:effectRef>
+          <a:fontRef idx="minor">
+            <a:schemeClr val="lt1"/>
+          </a:fontRef>
+        </p:style>
+        <p:txBody>
+          <a:bodyPr wrap="square" lIns="27432" tIns="22860" rIns="27432" bIns="22860" rtlCol="0" anchor="ctr"/>
+          <a:lstStyle/>
+          <a:p>
+            <a:pPr algn="ctr"/>
+            <a:r>
+              <a:rPr sz="2000" b="0" i="0" dirty="0">
+                <a:solidFill>
+                  <a:srgbClr val="5C4826"/>
+                </a:solidFill>
+              </a:rPr>
+              <a:t>Cost: two environments. Hazard: state the two versions share, such as the database schema.</a:t>
+            </a:r>
+          </a:p>
+        </p:txBody>
+      </p:sp>
+    </p:spTree>
+  </p:cSld>
+  <p:clrMapOvr>
+    <a:masterClrMapping/>
+  </p:clrMapOvr>
+</p:sld>
+</file>
+
+<file path=ppt/slides/slide19.xml><?xml version="1.0" encoding="utf-8"?>
+<p:sld xmlns:a="http://schemas.openxmlformats.org/drawingml/2006/main" xmlns:p="http://schemas.openxmlformats.org/presentationml/2006/main" xmlns:r="http://schemas.openxmlformats.org/officeDocument/2006/relationships">
+  <p:cSld>
+    <p:spTree>
+      <p:nvGrpSpPr>
+        <p:cNvPr id="1" name=""/>
+        <p:cNvGrpSpPr/>
+        <p:nvPr/>
+      </p:nvGrpSpPr>
+      <p:grpSpPr/>
+      <p:sp>
+        <p:nvSpPr>
+          <p:cNvPr id="3" name="Title 2"/>
+          <p:cNvSpPr>
+            <a:spLocks noGrp="1"/>
+          </p:cNvSpPr>
+          <p:nvPr>
+            <p:ph type="title"/>
+          </p:nvPr>
+        </p:nvSpPr>
+        <p:spPr/>
+        <p:txBody>
+          <a:bodyPr wrap="square"/>
+          <a:lstStyle/>
+          <a:p>
+            <a:pPr algn="l"/>
+            <a:r>
+              <a:rPr sz="2400" b="0" i="0" dirty="0">
+                <a:solidFill>
+                  <a:srgbClr val="000000"/>
+                </a:solidFill>
+              </a:rPr>
+              <a:t>Canary deployment</a:t>
+            </a:r>
+          </a:p>
+        </p:txBody>
+      </p:sp>
+      <p:sp>
+        <p:nvSpPr>
+          <p:cNvPr id="1001" name="Slide Number Placeholder 900"/>
+          <p:cNvSpPr>
+            <a:spLocks noGrp="1"/>
+          </p:cNvSpPr>
+          <p:nvPr>
+            <p:ph type="sldNum" sz="quarter" idx="4"/>
+          </p:nvPr>
+        </p:nvSpPr>
+        <p:spPr/>
+        <p:txBody>
+          <a:bodyPr/>
+          <a:lstStyle/>
+          <a:p>
+            <a:fld id="{B3291E67-7172-4DCF-B35F-54404EBE6160}" type="slidenum">
+              <a:rPr lang="en-US" smtClean="0"/>
+              <a:t>1</a:t>
+            </a:fld>
+            <a:endParaRPr lang="en-US"/>
+          </a:p>
+        </p:txBody>
+      </p:sp>
+      <p:sp>
+        <p:nvSpPr>
+          <p:cNvPr id="1002" name="Block"/>
+          <p:cNvSpPr/>
+          <p:nvPr/>
+        </p:nvSpPr>
+        <p:spPr>
+          <a:xfrm>
+            <a:off x="411480" y="1234440"/>
+            <a:ext cx="1828800" cy="777240"/>
+          </a:xfrm>
+          <a:prstGeom prst="rect">
+            <a:avLst/>
+          </a:prstGeom>
+          <a:solidFill>
+            <a:srgbClr val="8E6F3E"/>
+          </a:solidFill>
+          <a:ln>
+            <a:noFill/>
+          </a:ln>
+          <a:effectLst/>
+        </p:spPr>
+        <p:style>
+          <a:lnRef idx="1">
+            <a:schemeClr val="accent1"/>
+          </a:lnRef>
+          <a:fillRef idx="3">
+            <a:schemeClr val="accent1"/>
+          </a:fillRef>
+          <a:effectRef idx="2">
+            <a:schemeClr val="accent1"/>
+          </a:effectRef>
+          <a:fontRef idx="minor">
+            <a:schemeClr val="lt1"/>
+          </a:fontRef>
+        </p:style>
+        <p:txBody>
+          <a:bodyPr wrap="square" lIns="27432" tIns="22860" rIns="27432" bIns="22860" rtlCol="0" anchor="ctr"/>
+          <a:lstStyle/>
+          <a:p>
+            <a:pPr algn="ctr"/>
+            <a:r>
+              <a:rPr sz="2000" b="1" i="0" dirty="0">
+                <a:solidFill>
+                  <a:srgbClr val="FFFFFF"/>
+                </a:solidFill>
+              </a:rPr>
+              <a:t>TRAFFIC</a:t>
+            </a:r>
+          </a:p>
+        </p:txBody>
+      </p:sp>
+      <p:sp>
+        <p:nvSpPr>
+          <p:cNvPr id="1003" name="Card"/>
+          <p:cNvSpPr/>
+          <p:nvPr/>
+        </p:nvSpPr>
+        <p:spPr>
+          <a:xfrm>
+            <a:off x="3657600" y="914400"/>
+            <a:ext cx="2377440" cy="777240"/>
+          </a:xfrm>
+          <a:prstGeom prst="rect">
+            <a:avLst/>
+          </a:prstGeom>
+          <a:solidFill>
+            <a:srgbClr val="F5F1E8"/>
+          </a:solidFill>
+          <a:ln w="12700">
+            <a:solidFill>
+              <a:srgbClr val="C9B991"/>
+            </a:solidFill>
+          </a:ln>
+          <a:effectLst/>
+        </p:spPr>
+        <p:style>
+          <a:lnRef idx="1">
+            <a:schemeClr val="accent1"/>
+          </a:lnRef>
+          <a:fillRef idx="3">
+            <a:schemeClr val="accent1"/>
+          </a:fillRef>
+          <a:effectRef idx="2">
+            <a:schemeClr val="accent1"/>
+          </a:effectRef>
+          <a:fontRef idx="minor">
+            <a:schemeClr val="lt1"/>
+          </a:fontRef>
+        </p:style>
+        <p:txBody>
+          <a:bodyPr wrap="square" lIns="27432" tIns="22860" rIns="27432" bIns="22860" rtlCol="0" anchor="ctr"/>
+          <a:lstStyle/>
+          <a:p>
+            <a:pPr algn="ctr"/>
+            <a:r>
+              <a:rPr sz="2000" b="1" i="0" dirty="0">
+                <a:solidFill>
+                  <a:srgbClr val="5C4826"/>
+                </a:solidFill>
+              </a:rPr>
+              <a:t>version 1</a:t>
+            </a:r>
+            <a:r>
+              <a:rPr sz="2000" b="0" i="0" dirty="0">
+                <a:solidFill>
+                  <a:srgbClr val="5C4826"/>
+                </a:solidFill>
+              </a:rPr>
+              <a:t>   95%</a:t>
+            </a:r>
+          </a:p>
+        </p:txBody>
+      </p:sp>
+      <p:sp>
+        <p:nvSpPr>
+          <p:cNvPr id="1004" name="Block"/>
+          <p:cNvSpPr/>
+          <p:nvPr/>
+        </p:nvSpPr>
+        <p:spPr>
+          <a:xfrm>
+            <a:off x="3657600" y="2057400"/>
+            <a:ext cx="2377440" cy="777240"/>
+          </a:xfrm>
+          <a:prstGeom prst="rect">
+            <a:avLst/>
+          </a:prstGeom>
+          <a:solidFill>
+            <a:srgbClr val="8E6F3E"/>
+          </a:solidFill>
+          <a:ln>
+            <a:noFill/>
+          </a:ln>
+          <a:effectLst/>
+        </p:spPr>
+        <p:style>
+          <a:lnRef idx="1">
+            <a:schemeClr val="accent1"/>
+          </a:lnRef>
+          <a:fillRef idx="3">
+            <a:schemeClr val="accent1"/>
+          </a:fillRef>
+          <a:effectRef idx="2">
+            <a:schemeClr val="accent1"/>
+          </a:effectRef>
+          <a:fontRef idx="minor">
+            <a:schemeClr val="lt1"/>
+          </a:fontRef>
+        </p:style>
+        <p:txBody>
+          <a:bodyPr wrap="square" lIns="27432" tIns="22860" rIns="27432" bIns="22860" rtlCol="0" anchor="ctr"/>
+          <a:lstStyle/>
+          <a:p>
+            <a:pPr algn="ctr"/>
+            <a:r>
+              <a:rPr sz="2000" b="1" i="0" dirty="0">
+                <a:solidFill>
+                  <a:srgbClr val="FFFFFF"/>
+                </a:solidFill>
+              </a:rPr>
+              <a:t>version 2</a:t>
+            </a:r>
+            <a:r>
+              <a:rPr sz="2000" b="0" i="0" dirty="0">
+                <a:solidFill>
+                  <a:srgbClr val="FFFFFF"/>
+                </a:solidFill>
+              </a:rPr>
+              <a:t>   5%</a:t>
+            </a:r>
+          </a:p>
+        </p:txBody>
+      </p:sp>
+      <p:cxnSp>
+        <p:nvCxnSpPr>
+          <p:cNvPr id="1005" name="Connector"/>
+          <p:cNvCxnSpPr/>
+          <p:nvPr/>
+        </p:nvCxnSpPr>
+        <p:spPr>
+          <a:xfrm>
+            <a:off x="2258568" y="1623060"/>
+            <a:ext cx="640080" cy="0"/>
+          </a:xfrm>
+          <a:prstGeom prst="line">
+            <a:avLst/>
+          </a:prstGeom>
+          <a:ln w="19050">
+            <a:solidFill>
+              <a:srgbClr val="8E6F3E"/>
+            </a:solidFill>
+          </a:ln>
+        </p:spPr>
+        <p:style>
+          <a:lnRef idx="2">
+            <a:schemeClr val="accent1"/>
+          </a:lnRef>
+          <a:fillRef idx="0">
+            <a:schemeClr val="accent1"/>
+          </a:fillRef>
+          <a:effectRef idx="1">
+            <a:schemeClr val="accent1"/>
+          </a:effectRef>
+          <a:fontRef idx="minor">
+            <a:schemeClr val="tx1"/>
+          </a:fontRef>
+        </p:style>
+      </p:cxnSp>
+      <p:cxnSp>
+        <p:nvCxnSpPr>
+          <p:cNvPr id="1006" name="Connector"/>
+          <p:cNvCxnSpPr/>
+          <p:nvPr/>
+        </p:nvCxnSpPr>
+        <p:spPr>
+          <a:xfrm flipV="1">
+            <a:off x="2898648" y="1298448"/>
+            <a:ext cx="0" cy="649224"/>
+          </a:xfrm>
+          <a:prstGeom prst="line">
+            <a:avLst/>
+          </a:prstGeom>
+          <a:ln w="19050">
+            <a:solidFill>
+              <a:srgbClr val="8E6F3E"/>
+            </a:solidFill>
+          </a:ln>
+        </p:spPr>
+        <p:style>
+          <a:lnRef idx="2">
+            <a:schemeClr val="accent1"/>
+          </a:lnRef>
+          <a:fillRef idx="0">
+            <a:schemeClr val="accent1"/>
+          </a:fillRef>
+          <a:effectRef idx="1">
+            <a:schemeClr val="accent1"/>
+          </a:effectRef>
+          <a:fontRef idx="minor">
+            <a:schemeClr val="tx1"/>
+          </a:fontRef>
+        </p:style>
+      </p:cxnSp>
+      <p:cxnSp>
+        <p:nvCxnSpPr>
+          <p:cNvPr id="1007" name="Connector"/>
+          <p:cNvCxnSpPr/>
+          <p:nvPr/>
+        </p:nvCxnSpPr>
+        <p:spPr>
+          <a:xfrm>
+            <a:off x="2898648" y="1298448"/>
+            <a:ext cx="740664" cy="0"/>
+          </a:xfrm>
+          <a:prstGeom prst="line">
+            <a:avLst/>
+          </a:prstGeom>
+          <a:ln w="19050">
+            <a:solidFill>
+              <a:srgbClr val="8E6F3E"/>
+            </a:solidFill>
+            <a:tailEnd type="triangle"/>
+          </a:ln>
+        </p:spPr>
+        <p:style>
+          <a:lnRef idx="2">
+            <a:schemeClr val="accent1"/>
+          </a:lnRef>
+          <a:fillRef idx="0">
+            <a:schemeClr val="accent1"/>
+          </a:fillRef>
+          <a:effectRef idx="1">
+            <a:schemeClr val="accent1"/>
+          </a:effectRef>
+          <a:fontRef idx="minor">
+            <a:schemeClr val="tx1"/>
+          </a:fontRef>
+        </p:style>
+      </p:cxnSp>
+      <p:cxnSp>
+        <p:nvCxnSpPr>
+          <p:cNvPr id="1008" name="Connector"/>
+          <p:cNvCxnSpPr/>
+          <p:nvPr/>
+        </p:nvCxnSpPr>
+        <p:spPr>
+          <a:xfrm>
+            <a:off x="2898648" y="1623060"/>
+            <a:ext cx="0" cy="818388"/>
+          </a:xfrm>
+          <a:prstGeom prst="line">
+            <a:avLst/>
+          </a:prstGeom>
+          <a:ln w="19050">
+            <a:solidFill>
+              <a:srgbClr val="8E6F3E"/>
+            </a:solidFill>
+          </a:ln>
+        </p:spPr>
+        <p:style>
+          <a:lnRef idx="2">
+            <a:schemeClr val="accent1"/>
+          </a:lnRef>
+          <a:fillRef idx="0">
+            <a:schemeClr val="accent1"/>
+          </a:fillRef>
+          <a:effectRef idx="1">
+            <a:schemeClr val="accent1"/>
+          </a:effectRef>
+          <a:fontRef idx="minor">
+            <a:schemeClr val="tx1"/>
+          </a:fontRef>
+        </p:style>
+      </p:cxnSp>
+      <p:cxnSp>
+        <p:nvCxnSpPr>
+          <p:cNvPr id="1009" name="Connector"/>
+          <p:cNvCxnSpPr/>
+          <p:nvPr/>
+        </p:nvCxnSpPr>
+        <p:spPr>
+          <a:xfrm>
+            <a:off x="2898648" y="2441448"/>
+            <a:ext cx="740664" cy="0"/>
+          </a:xfrm>
+          <a:prstGeom prst="line">
+            <a:avLst/>
+          </a:prstGeom>
+          <a:ln w="19050">
+            <a:solidFill>
+              <a:srgbClr val="8E6F3E"/>
+            </a:solidFill>
+            <a:tailEnd type="triangle"/>
+          </a:ln>
+        </p:spPr>
+        <p:style>
+          <a:lnRef idx="2">
+            <a:schemeClr val="accent1"/>
+          </a:lnRef>
+          <a:fillRef idx="0">
+            <a:schemeClr val="accent1"/>
+          </a:fillRef>
+          <a:effectRef idx="1">
+            <a:schemeClr val="accent1"/>
+          </a:effectRef>
+          <a:fontRef idx="minor">
+            <a:schemeClr val="tx1"/>
+          </a:fontRef>
+        </p:style>
+      </p:cxnSp>
+      <p:sp>
+        <p:nvSpPr>
+          <p:cNvPr id="1010" name="Label"/>
+          <p:cNvSpPr/>
+          <p:nvPr/>
+        </p:nvSpPr>
+        <p:spPr>
+          <a:xfrm>
+            <a:off x="411480" y="3108960"/>
+            <a:ext cx="8412480" cy="384048"/>
+          </a:xfrm>
+          <a:prstGeom prst="rect">
+            <a:avLst/>
+          </a:prstGeom>
+          <a:noFill/>
+          <a:ln>
+            <a:noFill/>
+          </a:ln>
+          <a:effectLst/>
+        </p:spPr>
+        <p:style>
+          <a:lnRef idx="1">
+            <a:schemeClr val="accent1"/>
+          </a:lnRef>
+          <a:fillRef idx="3">
+            <a:schemeClr val="accent1"/>
+          </a:fillRef>
+          <a:effectRef idx="2">
+            <a:schemeClr val="accent1"/>
+          </a:effectRef>
+          <a:fontRef idx="minor">
+            <a:schemeClr val="lt1"/>
+          </a:fontRef>
+        </p:style>
+        <p:txBody>
+          <a:bodyPr wrap="square" lIns="27432" tIns="22860" rIns="27432" bIns="22860" rtlCol="0" anchor="ctr"/>
+          <a:lstStyle/>
+          <a:p>
+            <a:pPr algn="ctr"/>
+            <a:r>
+              <a:rPr sz="2000" b="0" i="1" dirty="0">
+                <a:solidFill>
+                  <a:srgbClr val="555960"/>
+                </a:solidFill>
+              </a:rPr>
+              <a:t>grow exposure only as the evidence supports it</a:t>
+            </a:r>
+          </a:p>
+        </p:txBody>
+      </p:sp>
+      <p:sp>
+        <p:nvSpPr>
+          <p:cNvPr id="1011" name="Block"/>
+          <p:cNvSpPr/>
+          <p:nvPr/>
+        </p:nvSpPr>
+        <p:spPr>
+          <a:xfrm>
+            <a:off x="1234440" y="3657600"/>
+            <a:ext cx="1188720" cy="594360"/>
+          </a:xfrm>
+          <a:prstGeom prst="rect">
+            <a:avLst/>
+          </a:prstGeom>
+          <a:solidFill>
+            <a:srgbClr val="8E6F3E"/>
+          </a:solidFill>
+          <a:ln>
+            <a:noFill/>
+          </a:ln>
+          <a:effectLst/>
+        </p:spPr>
+        <p:style>
+          <a:lnRef idx="1">
+            <a:schemeClr val="accent1"/>
+          </a:lnRef>
+          <a:fillRef idx="3">
+            <a:schemeClr val="accent1"/>
+          </a:fillRef>
+          <a:effectRef idx="2">
+            <a:schemeClr val="accent1"/>
+          </a:effectRef>
+          <a:fontRef idx="minor">
+            <a:schemeClr val="lt1"/>
+          </a:fontRef>
+        </p:style>
+        <p:txBody>
+          <a:bodyPr wrap="square" lIns="27432" tIns="22860" rIns="27432" bIns="22860" rtlCol="0" anchor="ctr"/>
+          <a:lstStyle/>
+          <a:p>
+            <a:pPr algn="ctr"/>
+            <a:r>
+              <a:rPr sz="2000" b="1" i="0" dirty="0">
+                <a:solidFill>
+                  <a:srgbClr val="FFFFFF"/>
+                </a:solidFill>
+              </a:rPr>
+              <a:t>5%</a:t>
+            </a:r>
+          </a:p>
+        </p:txBody>
+      </p:sp>
+      <p:sp>
+        <p:nvSpPr>
+          <p:cNvPr id="1012" name="Block"/>
+          <p:cNvSpPr/>
+          <p:nvPr/>
+        </p:nvSpPr>
+        <p:spPr>
+          <a:xfrm>
+            <a:off x="3749040" y="3657600"/>
+            <a:ext cx="1188720" cy="594360"/>
+          </a:xfrm>
+          <a:prstGeom prst="rect">
+            <a:avLst/>
+          </a:prstGeom>
+          <a:solidFill>
+            <a:srgbClr val="8E6F3E"/>
+          </a:solidFill>
+          <a:ln>
+            <a:noFill/>
+          </a:ln>
+          <a:effectLst/>
+        </p:spPr>
+        <p:style>
+          <a:lnRef idx="1">
+            <a:schemeClr val="accent1"/>
+          </a:lnRef>
+          <a:fillRef idx="3">
+            <a:schemeClr val="accent1"/>
+          </a:fillRef>
+          <a:effectRef idx="2">
+            <a:schemeClr val="accent1"/>
+          </a:effectRef>
+          <a:fontRef idx="minor">
+            <a:schemeClr val="lt1"/>
+          </a:fontRef>
+        </p:style>
+        <p:txBody>
+          <a:bodyPr wrap="square" lIns="27432" tIns="22860" rIns="27432" bIns="22860" rtlCol="0" anchor="ctr"/>
+          <a:lstStyle/>
+          <a:p>
+            <a:pPr algn="ctr"/>
+            <a:r>
+              <a:rPr sz="2000" b="1" i="0" dirty="0">
+                <a:solidFill>
+                  <a:srgbClr val="FFFFFF"/>
+                </a:solidFill>
+              </a:rPr>
+              <a:t>25%</a:t>
+            </a:r>
+          </a:p>
+        </p:txBody>
+      </p:sp>
+      <p:cxnSp>
+        <p:nvCxnSpPr>
+          <p:cNvPr id="1013" name="Connector"/>
+          <p:cNvCxnSpPr/>
+          <p:nvPr/>
+        </p:nvCxnSpPr>
+        <p:spPr>
+          <a:xfrm>
+            <a:off x="3630168" y="3954780"/>
+            <a:ext cx="100584" cy="0"/>
+          </a:xfrm>
+          <a:prstGeom prst="line">
+            <a:avLst/>
+          </a:prstGeom>
+          <a:ln w="19050">
+            <a:solidFill>
+              <a:srgbClr val="8E6F3E"/>
+            </a:solidFill>
+            <a:tailEnd type="triangle"/>
+          </a:ln>
+        </p:spPr>
+        <p:style>
+          <a:lnRef idx="2">
+            <a:schemeClr val="accent1"/>
+          </a:lnRef>
+          <a:fillRef idx="0">
+            <a:schemeClr val="accent1"/>
+          </a:fillRef>
+          <a:effectRef idx="1">
+            <a:schemeClr val="accent1"/>
+          </a:effectRef>
+          <a:fontRef idx="minor">
+            <a:schemeClr val="tx1"/>
+          </a:fontRef>
+        </p:style>
+      </p:cxnSp>
+      <p:sp>
+        <p:nvSpPr>
+          <p:cNvPr id="1014" name="Block"/>
+          <p:cNvSpPr/>
+          <p:nvPr/>
+        </p:nvSpPr>
+        <p:spPr>
+          <a:xfrm>
+            <a:off x="6263640" y="3657600"/>
+            <a:ext cx="1188720" cy="594360"/>
+          </a:xfrm>
+          <a:prstGeom prst="rect">
+            <a:avLst/>
+          </a:prstGeom>
+          <a:solidFill>
+            <a:srgbClr val="8E6F3E"/>
+          </a:solidFill>
+          <a:ln>
+            <a:noFill/>
+          </a:ln>
+          <a:effectLst/>
+        </p:spPr>
+        <p:style>
+          <a:lnRef idx="1">
+            <a:schemeClr val="accent1"/>
+          </a:lnRef>
+          <a:fillRef idx="3">
+            <a:schemeClr val="accent1"/>
+          </a:fillRef>
+          <a:effectRef idx="2">
+            <a:schemeClr val="accent1"/>
+          </a:effectRef>
+          <a:fontRef idx="minor">
+            <a:schemeClr val="lt1"/>
+          </a:fontRef>
+        </p:style>
+        <p:txBody>
+          <a:bodyPr wrap="square" lIns="27432" tIns="22860" rIns="27432" bIns="22860" rtlCol="0" anchor="ctr"/>
+          <a:lstStyle/>
+          <a:p>
+            <a:pPr algn="ctr"/>
+            <a:r>
+              <a:rPr sz="2000" b="1" i="0" dirty="0">
+                <a:solidFill>
+                  <a:srgbClr val="FFFFFF"/>
+                </a:solidFill>
+              </a:rPr>
+              <a:t>100%</a:t>
+            </a:r>
+          </a:p>
+        </p:txBody>
+      </p:sp>
+      <p:cxnSp>
+        <p:nvCxnSpPr>
+          <p:cNvPr id="1015" name="Connector"/>
+          <p:cNvCxnSpPr/>
+          <p:nvPr/>
+        </p:nvCxnSpPr>
+        <p:spPr>
+          <a:xfrm>
+            <a:off x="6144768" y="3954780"/>
+            <a:ext cx="100584" cy="0"/>
+          </a:xfrm>
+          <a:prstGeom prst="line">
+            <a:avLst/>
+          </a:prstGeom>
+          <a:ln w="19050">
+            <a:solidFill>
+              <a:srgbClr val="8E6F3E"/>
+            </a:solidFill>
+            <a:tailEnd type="triangle"/>
+          </a:ln>
+        </p:spPr>
+        <p:style>
+          <a:lnRef idx="2">
+            <a:schemeClr val="accent1"/>
+          </a:lnRef>
+          <a:fillRef idx="0">
+            <a:schemeClr val="accent1"/>
+          </a:fillRef>
+          <a:effectRef idx="1">
+            <a:schemeClr val="accent1"/>
+          </a:effectRef>
+          <a:fontRef idx="minor">
+            <a:schemeClr val="tx1"/>
+          </a:fontRef>
+        </p:style>
+      </p:cxnSp>
+      <p:sp>
+        <p:nvSpPr>
+          <p:cNvPr id="1016" name="Card"/>
+          <p:cNvSpPr/>
+          <p:nvPr/>
+        </p:nvSpPr>
+        <p:spPr>
+          <a:xfrm>
+            <a:off x="1234440" y="4526280"/>
+            <a:ext cx="6263640" cy="777240"/>
+          </a:xfrm>
+          <a:prstGeom prst="rect">
+            <a:avLst/>
+          </a:prstGeom>
+          <a:solidFill>
+            <a:srgbClr val="F5F1E8"/>
+          </a:solidFill>
+          <a:ln w="12700">
+            <a:solidFill>
+              <a:srgbClr val="C9B991"/>
+            </a:solidFill>
+          </a:ln>
+          <a:effectLst/>
+        </p:spPr>
+        <p:style>
+          <a:lnRef idx="1">
+            <a:schemeClr val="accent1"/>
+          </a:lnRef>
+          <a:fillRef idx="3">
+            <a:schemeClr val="accent1"/>
+          </a:fillRef>
+          <a:effectRef idx="2">
+            <a:schemeClr val="accent1"/>
+          </a:effectRef>
+          <a:fontRef idx="minor">
+            <a:schemeClr val="lt1"/>
+          </a:fontRef>
+        </p:style>
+        <p:txBody>
+          <a:bodyPr wrap="square" lIns="27432" tIns="22860" rIns="27432" bIns="22860" rtlCol="0" anchor="ctr"/>
+          <a:lstStyle/>
+          <a:p>
+            <a:pPr algn="ctr"/>
+            <a:r>
+              <a:rPr sz="2000" b="0" i="0" dirty="0">
+                <a:solidFill>
+                  <a:srgbClr val="5C4826"/>
+                </a:solidFill>
+              </a:rPr>
+              <a:t>between steps: error rates, latency, user reports</a:t>
+            </a:r>
+          </a:p>
+        </p:txBody>
+      </p:sp>
+    </p:spTree>
+  </p:cSld>
+  <p:clrMapOvr>
+    <a:masterClrMapping/>
+  </p:clrMapOvr>
+</p:sld>
+</file>
+
 <file path=ppt/slides/slide2.xml><?xml version="1.0" encoding="utf-8"?>
 <p:sld xmlns:a="http://schemas.openxmlformats.org/drawingml/2006/main" xmlns:p="http://schemas.openxmlformats.org/presentationml/2006/main" xmlns:r="http://schemas.openxmlformats.org/officeDocument/2006/relationships">
   <p:cSld>
@@ -9690,6 +12851,1596 @@
                 </a:solidFill>
               </a:rPr>
               <a:t>satisfies the application's requirements</a:t>
+            </a:r>
+          </a:p>
+        </p:txBody>
+      </p:sp>
+    </p:spTree>
+  </p:cSld>
+  <p:clrMapOvr>
+    <a:masterClrMapping/>
+  </p:clrMapOvr>
+</p:sld>
+</file>
+
+<file path=ppt/slides/slide20.xml><?xml version="1.0" encoding="utf-8"?>
+<p:sld xmlns:a="http://schemas.openxmlformats.org/drawingml/2006/main" xmlns:p="http://schemas.openxmlformats.org/presentationml/2006/main" xmlns:r="http://schemas.openxmlformats.org/officeDocument/2006/relationships">
+  <p:cSld>
+    <p:spTree>
+      <p:nvGrpSpPr>
+        <p:cNvPr id="1" name=""/>
+        <p:cNvGrpSpPr/>
+        <p:nvPr/>
+      </p:nvGrpSpPr>
+      <p:grpSpPr/>
+      <p:sp>
+        <p:nvSpPr>
+          <p:cNvPr id="3" name="Title 2"/>
+          <p:cNvSpPr>
+            <a:spLocks noGrp="1"/>
+          </p:cNvSpPr>
+          <p:nvPr>
+            <p:ph type="title"/>
+          </p:nvPr>
+        </p:nvSpPr>
+        <p:spPr/>
+        <p:txBody>
+          <a:bodyPr wrap="square"/>
+          <a:lstStyle/>
+          <a:p>
+            <a:pPr algn="l"/>
+            <a:r>
+              <a:rPr sz="2400" b="0" i="0" dirty="0">
+                <a:solidFill>
+                  <a:srgbClr val="000000"/>
+                </a:solidFill>
+              </a:rPr>
+              <a:t>Feature flags</a:t>
+            </a:r>
+          </a:p>
+        </p:txBody>
+      </p:sp>
+      <p:sp>
+        <p:nvSpPr>
+          <p:cNvPr id="1001" name="Slide Number Placeholder 900"/>
+          <p:cNvSpPr>
+            <a:spLocks noGrp="1"/>
+          </p:cNvSpPr>
+          <p:nvPr>
+            <p:ph type="sldNum" sz="quarter" idx="4"/>
+          </p:nvPr>
+        </p:nvSpPr>
+        <p:spPr/>
+        <p:txBody>
+          <a:bodyPr/>
+          <a:lstStyle/>
+          <a:p>
+            <a:fld id="{B3291E67-7172-4DCF-B35F-54404EBE6160}" type="slidenum">
+              <a:rPr lang="en-US" smtClean="0"/>
+              <a:t>1</a:t>
+            </a:fld>
+            <a:endParaRPr lang="en-US"/>
+          </a:p>
+        </p:txBody>
+      </p:sp>
+      <p:sp>
+        <p:nvSpPr>
+          <p:cNvPr id="1002" name="Slab"/>
+          <p:cNvSpPr/>
+          <p:nvPr/>
+        </p:nvSpPr>
+        <p:spPr>
+          <a:xfrm>
+            <a:off x="548640" y="1188720"/>
+            <a:ext cx="5120640" cy="3017520"/>
+          </a:xfrm>
+          <a:prstGeom prst="rect">
+            <a:avLst/>
+          </a:prstGeom>
+          <a:solidFill>
+            <a:srgbClr val="F5F1E8"/>
+          </a:solidFill>
+          <a:ln w="12700">
+            <a:solidFill>
+              <a:srgbClr val="C9B991"/>
+            </a:solidFill>
+          </a:ln>
+          <a:effectLst/>
+        </p:spPr>
+        <p:style>
+          <a:lnRef idx="1">
+            <a:schemeClr val="accent1"/>
+          </a:lnRef>
+          <a:fillRef idx="3">
+            <a:schemeClr val="accent1"/>
+          </a:fillRef>
+          <a:effectRef idx="2">
+            <a:schemeClr val="accent1"/>
+          </a:effectRef>
+          <a:fontRef idx="minor">
+            <a:schemeClr val="lt1"/>
+          </a:fontRef>
+        </p:style>
+        <p:txBody>
+          <a:bodyPr wrap="square" lIns="27432" tIns="22860" rIns="27432" bIns="22860" rtlCol="0" anchor="ctr"/>
+          <a:lstStyle/>
+          <a:p/>
+        </p:txBody>
+      </p:sp>
+      <p:sp>
+        <p:nvSpPr>
+          <p:cNvPr id="1003" name="Label"/>
+          <p:cNvSpPr/>
+          <p:nvPr/>
+        </p:nvSpPr>
+        <p:spPr>
+          <a:xfrm>
+            <a:off x="731520" y="1298448"/>
+            <a:ext cx="4206240" cy="365760"/>
+          </a:xfrm>
+          <a:prstGeom prst="rect">
+            <a:avLst/>
+          </a:prstGeom>
+          <a:noFill/>
+          <a:ln>
+            <a:noFill/>
+          </a:ln>
+          <a:effectLst/>
+        </p:spPr>
+        <p:style>
+          <a:lnRef idx="1">
+            <a:schemeClr val="accent1"/>
+          </a:lnRef>
+          <a:fillRef idx="3">
+            <a:schemeClr val="accent1"/>
+          </a:fillRef>
+          <a:effectRef idx="2">
+            <a:schemeClr val="accent1"/>
+          </a:effectRef>
+          <a:fontRef idx="minor">
+            <a:schemeClr val="lt1"/>
+          </a:fontRef>
+        </p:style>
+        <p:txBody>
+          <a:bodyPr wrap="square" lIns="27432" tIns="22860" rIns="27432" bIns="22860" rtlCol="0" anchor="ctr"/>
+          <a:lstStyle/>
+          <a:p>
+            <a:pPr algn="l"/>
+            <a:r>
+              <a:rPr sz="2000" b="1" i="0" dirty="0">
+                <a:solidFill>
+                  <a:srgbClr val="5C4826"/>
+                </a:solidFill>
+              </a:rPr>
+              <a:t>ONE DEPLOYED APPLICATION</a:t>
+            </a:r>
+          </a:p>
+        </p:txBody>
+      </p:sp>
+      <p:sp>
+        <p:nvSpPr>
+          <p:cNvPr id="1004" name="CodeCard"/>
+          <p:cNvSpPr/>
+          <p:nvPr/>
+        </p:nvSpPr>
+        <p:spPr>
+          <a:xfrm>
+            <a:off x="868680" y="1874520"/>
+            <a:ext cx="2103120" cy="685800"/>
+          </a:xfrm>
+          <a:prstGeom prst="rect">
+            <a:avLst/>
+          </a:prstGeom>
+          <a:solidFill>
+            <a:srgbClr val="F5F1E8"/>
+          </a:solidFill>
+          <a:ln w="12700">
+            <a:solidFill>
+              <a:srgbClr val="C9B991"/>
+            </a:solidFill>
+          </a:ln>
+          <a:effectLst/>
+        </p:spPr>
+        <p:style>
+          <a:lnRef idx="1">
+            <a:schemeClr val="accent1"/>
+          </a:lnRef>
+          <a:fillRef idx="3">
+            <a:schemeClr val="accent1"/>
+          </a:fillRef>
+          <a:effectRef idx="2">
+            <a:schemeClr val="accent1"/>
+          </a:effectRef>
+          <a:fontRef idx="minor">
+            <a:schemeClr val="lt1"/>
+          </a:fontRef>
+        </p:style>
+        <p:txBody>
+          <a:bodyPr wrap="square" lIns="27432" tIns="22860" rIns="27432" bIns="22860" rtlCol="0" anchor="ctr"/>
+          <a:lstStyle/>
+          <a:p>
+            <a:pPr algn="ctr"/>
+            <a:r>
+              <a:rPr sz="2000" b="0" i="0" dirty="0">
+                <a:solidFill>
+                  <a:srgbClr val="5C4826"/>
+                </a:solidFill>
+                <a:latin typeface="Consolas"/>
+              </a:rPr>
+              <a:t>flag:</a:t>
+            </a:r>
+            <a:r>
+              <a:rPr sz="2000" b="1" i="0" dirty="0">
+                <a:solidFill>
+                  <a:srgbClr val="5C4826"/>
+                </a:solidFill>
+                <a:latin typeface="Consolas"/>
+              </a:rPr>
+              <a:t> new_search</a:t>
+            </a:r>
+          </a:p>
+        </p:txBody>
+      </p:sp>
+      <p:sp>
+        <p:nvSpPr>
+          <p:cNvPr id="1005" name="Block"/>
+          <p:cNvSpPr/>
+          <p:nvPr/>
+        </p:nvSpPr>
+        <p:spPr>
+          <a:xfrm>
+            <a:off x="3474720" y="1783080"/>
+            <a:ext cx="1920240" cy="685800"/>
+          </a:xfrm>
+          <a:prstGeom prst="rect">
+            <a:avLst/>
+          </a:prstGeom>
+          <a:solidFill>
+            <a:srgbClr val="8E6F3E"/>
+          </a:solidFill>
+          <a:ln>
+            <a:noFill/>
+          </a:ln>
+          <a:effectLst/>
+        </p:spPr>
+        <p:style>
+          <a:lnRef idx="1">
+            <a:schemeClr val="accent1"/>
+          </a:lnRef>
+          <a:fillRef idx="3">
+            <a:schemeClr val="accent1"/>
+          </a:fillRef>
+          <a:effectRef idx="2">
+            <a:schemeClr val="accent1"/>
+          </a:effectRef>
+          <a:fontRef idx="minor">
+            <a:schemeClr val="lt1"/>
+          </a:fontRef>
+        </p:style>
+        <p:txBody>
+          <a:bodyPr wrap="square" lIns="27432" tIns="22860" rIns="27432" bIns="22860" rtlCol="0" anchor="ctr"/>
+          <a:lstStyle/>
+          <a:p>
+            <a:pPr algn="ctr"/>
+            <a:r>
+              <a:rPr sz="2000" b="1" i="0" dirty="0">
+                <a:solidFill>
+                  <a:srgbClr val="FFFFFF"/>
+                </a:solidFill>
+              </a:rPr>
+              <a:t>behavior A</a:t>
+            </a:r>
+          </a:p>
+          <a:p>
+            <a:pPr algn="ctr"/>
+            <a:r>
+              <a:rPr sz="2000" b="0" i="1" dirty="0">
+                <a:solidFill>
+                  <a:srgbClr val="FFFFFF"/>
+                </a:solidFill>
+              </a:rPr>
+              <a:t>flag off</a:t>
+            </a:r>
+          </a:p>
+        </p:txBody>
+      </p:sp>
+      <p:sp>
+        <p:nvSpPr>
+          <p:cNvPr id="1006" name="Block"/>
+          <p:cNvSpPr/>
+          <p:nvPr/>
+        </p:nvSpPr>
+        <p:spPr>
+          <a:xfrm>
+            <a:off x="3474720" y="3154680"/>
+            <a:ext cx="1920240" cy="685800"/>
+          </a:xfrm>
+          <a:prstGeom prst="rect">
+            <a:avLst/>
+          </a:prstGeom>
+          <a:solidFill>
+            <a:srgbClr val="8E6F3E"/>
+          </a:solidFill>
+          <a:ln>
+            <a:noFill/>
+          </a:ln>
+          <a:effectLst/>
+        </p:spPr>
+        <p:style>
+          <a:lnRef idx="1">
+            <a:schemeClr val="accent1"/>
+          </a:lnRef>
+          <a:fillRef idx="3">
+            <a:schemeClr val="accent1"/>
+          </a:fillRef>
+          <a:effectRef idx="2">
+            <a:schemeClr val="accent1"/>
+          </a:effectRef>
+          <a:fontRef idx="minor">
+            <a:schemeClr val="lt1"/>
+          </a:fontRef>
+        </p:style>
+        <p:txBody>
+          <a:bodyPr wrap="square" lIns="27432" tIns="22860" rIns="27432" bIns="22860" rtlCol="0" anchor="ctr"/>
+          <a:lstStyle/>
+          <a:p>
+            <a:pPr algn="ctr"/>
+            <a:r>
+              <a:rPr sz="2000" b="1" i="0" dirty="0">
+                <a:solidFill>
+                  <a:srgbClr val="FFFFFF"/>
+                </a:solidFill>
+              </a:rPr>
+              <a:t>behavior B</a:t>
+            </a:r>
+          </a:p>
+          <a:p>
+            <a:pPr algn="ctr"/>
+            <a:r>
+              <a:rPr sz="2000" b="0" i="1" dirty="0">
+                <a:solidFill>
+                  <a:srgbClr val="FFFFFF"/>
+                </a:solidFill>
+              </a:rPr>
+              <a:t>flag on</a:t>
+            </a:r>
+          </a:p>
+        </p:txBody>
+      </p:sp>
+      <p:cxnSp>
+        <p:nvCxnSpPr>
+          <p:cNvPr id="1007" name="Connector"/>
+          <p:cNvCxnSpPr/>
+          <p:nvPr/>
+        </p:nvCxnSpPr>
+        <p:spPr>
+          <a:xfrm>
+            <a:off x="2971800" y="2125980"/>
+            <a:ext cx="0" cy="1371600"/>
+          </a:xfrm>
+          <a:prstGeom prst="line">
+            <a:avLst/>
+          </a:prstGeom>
+          <a:ln w="19050">
+            <a:solidFill>
+              <a:srgbClr val="8E6F3E"/>
+            </a:solidFill>
+          </a:ln>
+        </p:spPr>
+        <p:style>
+          <a:lnRef idx="2">
+            <a:schemeClr val="accent1"/>
+          </a:lnRef>
+          <a:fillRef idx="0">
+            <a:schemeClr val="accent1"/>
+          </a:fillRef>
+          <a:effectRef idx="1">
+            <a:schemeClr val="accent1"/>
+          </a:effectRef>
+          <a:fontRef idx="minor">
+            <a:schemeClr val="tx1"/>
+          </a:fontRef>
+        </p:style>
+      </p:cxnSp>
+      <p:cxnSp>
+        <p:nvCxnSpPr>
+          <p:cNvPr id="1008" name="Connector"/>
+          <p:cNvCxnSpPr/>
+          <p:nvPr/>
+        </p:nvCxnSpPr>
+        <p:spPr>
+          <a:xfrm>
+            <a:off x="2971800" y="2125980"/>
+            <a:ext cx="484632" cy="0"/>
+          </a:xfrm>
+          <a:prstGeom prst="line">
+            <a:avLst/>
+          </a:prstGeom>
+          <a:ln w="19050">
+            <a:solidFill>
+              <a:srgbClr val="8E6F3E"/>
+            </a:solidFill>
+            <a:tailEnd type="triangle"/>
+          </a:ln>
+        </p:spPr>
+        <p:style>
+          <a:lnRef idx="2">
+            <a:schemeClr val="accent1"/>
+          </a:lnRef>
+          <a:fillRef idx="0">
+            <a:schemeClr val="accent1"/>
+          </a:fillRef>
+          <a:effectRef idx="1">
+            <a:schemeClr val="accent1"/>
+          </a:effectRef>
+          <a:fontRef idx="minor">
+            <a:schemeClr val="tx1"/>
+          </a:fontRef>
+        </p:style>
+      </p:cxnSp>
+      <p:cxnSp>
+        <p:nvCxnSpPr>
+          <p:cNvPr id="1009" name="Connector"/>
+          <p:cNvCxnSpPr/>
+          <p:nvPr/>
+        </p:nvCxnSpPr>
+        <p:spPr>
+          <a:xfrm>
+            <a:off x="2971800" y="3497580"/>
+            <a:ext cx="484632" cy="0"/>
+          </a:xfrm>
+          <a:prstGeom prst="line">
+            <a:avLst/>
+          </a:prstGeom>
+          <a:ln w="19050">
+            <a:solidFill>
+              <a:srgbClr val="8E6F3E"/>
+            </a:solidFill>
+            <a:tailEnd type="triangle"/>
+          </a:ln>
+        </p:spPr>
+        <p:style>
+          <a:lnRef idx="2">
+            <a:schemeClr val="accent1"/>
+          </a:lnRef>
+          <a:fillRef idx="0">
+            <a:schemeClr val="accent1"/>
+          </a:fillRef>
+          <a:effectRef idx="1">
+            <a:schemeClr val="accent1"/>
+          </a:effectRef>
+          <a:fontRef idx="minor">
+            <a:schemeClr val="tx1"/>
+          </a:fontRef>
+        </p:style>
+      </p:cxnSp>
+      <p:sp>
+        <p:nvSpPr>
+          <p:cNvPr id="1010" name="Label"/>
+          <p:cNvSpPr/>
+          <p:nvPr/>
+        </p:nvSpPr>
+        <p:spPr>
+          <a:xfrm>
+            <a:off x="5943600" y="1463040"/>
+            <a:ext cx="2834640" cy="2651760"/>
+          </a:xfrm>
+          <a:prstGeom prst="rect">
+            <a:avLst/>
+          </a:prstGeom>
+          <a:noFill/>
+          <a:ln>
+            <a:noFill/>
+          </a:ln>
+          <a:effectLst/>
+        </p:spPr>
+        <p:style>
+          <a:lnRef idx="1">
+            <a:schemeClr val="accent1"/>
+          </a:lnRef>
+          <a:fillRef idx="3">
+            <a:schemeClr val="accent1"/>
+          </a:fillRef>
+          <a:effectRef idx="2">
+            <a:schemeClr val="accent1"/>
+          </a:effectRef>
+          <a:fontRef idx="minor">
+            <a:schemeClr val="lt1"/>
+          </a:fontRef>
+        </p:style>
+        <p:txBody>
+          <a:bodyPr wrap="square" lIns="27432" tIns="22860" rIns="27432" bIns="22860" rtlCol="0" anchor="ctr"/>
+          <a:lstStyle/>
+          <a:p>
+            <a:pPr algn="l"/>
+            <a:r>
+              <a:rPr sz="2000" b="0" i="0" dirty="0">
+                <a:solidFill>
+                  <a:srgbClr val="555960"/>
+                </a:solidFill>
+              </a:rPr>
+              <a:t>Deploying code and exposing functionality become separate decisions.</a:t>
+            </a:r>
+          </a:p>
+          <a:p>
+            <a:pPr algn="l">
+              <a:spcBef>
+                <a:spcPts val="1000"/>
+              </a:spcBef>
+            </a:pPr>
+            <a:r>
+              <a:rPr sz="2000" b="0" i="0" dirty="0">
+                <a:solidFill>
+                  <a:srgbClr val="555960"/>
+                </a:solidFill>
+              </a:rPr>
+              <a:t>The flag flips without a deployment.</a:t>
+            </a:r>
+          </a:p>
+        </p:txBody>
+      </p:sp>
+      <p:sp>
+        <p:nvSpPr>
+          <p:cNvPr id="1011" name="Card"/>
+          <p:cNvSpPr/>
+          <p:nvPr/>
+        </p:nvSpPr>
+        <p:spPr>
+          <a:xfrm>
+            <a:off x="548640" y="4480560"/>
+            <a:ext cx="8229600" cy="777240"/>
+          </a:xfrm>
+          <a:prstGeom prst="rect">
+            <a:avLst/>
+          </a:prstGeom>
+          <a:solidFill>
+            <a:srgbClr val="F5F1E8"/>
+          </a:solidFill>
+          <a:ln w="12700">
+            <a:solidFill>
+              <a:srgbClr val="C9B991"/>
+            </a:solidFill>
+          </a:ln>
+          <a:effectLst/>
+        </p:spPr>
+        <p:style>
+          <a:lnRef idx="1">
+            <a:schemeClr val="accent1"/>
+          </a:lnRef>
+          <a:fillRef idx="3">
+            <a:schemeClr val="accent1"/>
+          </a:fillRef>
+          <a:effectRef idx="2">
+            <a:schemeClr val="accent1"/>
+          </a:effectRef>
+          <a:fontRef idx="minor">
+            <a:schemeClr val="lt1"/>
+          </a:fontRef>
+        </p:style>
+        <p:txBody>
+          <a:bodyPr wrap="square" lIns="27432" tIns="22860" rIns="27432" bIns="22860" rtlCol="0" anchor="ctr"/>
+          <a:lstStyle/>
+          <a:p>
+            <a:pPr algn="ctr"/>
+            <a:r>
+              <a:rPr sz="2000" b="0" i="0" dirty="0">
+                <a:solidFill>
+                  <a:srgbClr val="5C4826"/>
+                </a:solidFill>
+              </a:rPr>
+              <a:t>A flag does not make the change safe by itself, and not every flag can safely flip at runtime</a:t>
+            </a:r>
+          </a:p>
+        </p:txBody>
+      </p:sp>
+    </p:spTree>
+  </p:cSld>
+  <p:clrMapOvr>
+    <a:masterClrMapping/>
+  </p:clrMapOvr>
+</p:sld>
+</file>
+
+<file path=ppt/slides/slide21.xml><?xml version="1.0" encoding="utf-8"?>
+<p:sld xmlns:a="http://schemas.openxmlformats.org/drawingml/2006/main" xmlns:p="http://schemas.openxmlformats.org/presentationml/2006/main" xmlns:r="http://schemas.openxmlformats.org/officeDocument/2006/relationships">
+  <p:cSld>
+    <p:spTree>
+      <p:nvGrpSpPr>
+        <p:cNvPr id="1" name=""/>
+        <p:cNvGrpSpPr/>
+        <p:nvPr/>
+      </p:nvGrpSpPr>
+      <p:grpSpPr/>
+      <p:sp>
+        <p:nvSpPr>
+          <p:cNvPr id="3" name="Title 2"/>
+          <p:cNvSpPr>
+            <a:spLocks noGrp="1"/>
+          </p:cNvSpPr>
+          <p:nvPr>
+            <p:ph type="title"/>
+          </p:nvPr>
+        </p:nvSpPr>
+        <p:spPr/>
+        <p:txBody>
+          <a:bodyPr wrap="square"/>
+          <a:lstStyle/>
+          <a:p>
+            <a:pPr algn="l"/>
+            <a:r>
+              <a:rPr sz="2400" b="0" i="0" dirty="0">
+                <a:solidFill>
+                  <a:srgbClr val="000000"/>
+                </a:solidFill>
+              </a:rPr>
+              <a:t>Release cadence and risk</a:t>
+            </a:r>
+          </a:p>
+        </p:txBody>
+      </p:sp>
+      <p:sp>
+        <p:nvSpPr>
+          <p:cNvPr id="1001" name="Slide Number Placeholder 900"/>
+          <p:cNvSpPr>
+            <a:spLocks noGrp="1"/>
+          </p:cNvSpPr>
+          <p:nvPr>
+            <p:ph type="sldNum" sz="quarter" idx="4"/>
+          </p:nvPr>
+        </p:nvSpPr>
+        <p:spPr/>
+        <p:txBody>
+          <a:bodyPr/>
+          <a:lstStyle/>
+          <a:p>
+            <a:fld id="{B3291E67-7172-4DCF-B35F-54404EBE6160}" type="slidenum">
+              <a:rPr lang="en-US" smtClean="0"/>
+              <a:t>1</a:t>
+            </a:fld>
+            <a:endParaRPr lang="en-US"/>
+          </a:p>
+        </p:txBody>
+      </p:sp>
+      <p:sp>
+        <p:nvSpPr>
+          <p:cNvPr id="1002" name="Block"/>
+          <p:cNvSpPr/>
+          <p:nvPr/>
+        </p:nvSpPr>
+        <p:spPr>
+          <a:xfrm>
+            <a:off x="2377440" y="1005840"/>
+            <a:ext cx="3017520" cy="658368"/>
+          </a:xfrm>
+          <a:prstGeom prst="rect">
+            <a:avLst/>
+          </a:prstGeom>
+          <a:solidFill>
+            <a:srgbClr val="8E6F3E"/>
+          </a:solidFill>
+          <a:ln>
+            <a:noFill/>
+          </a:ln>
+          <a:effectLst/>
+        </p:spPr>
+        <p:style>
+          <a:lnRef idx="1">
+            <a:schemeClr val="accent1"/>
+          </a:lnRef>
+          <a:fillRef idx="3">
+            <a:schemeClr val="accent1"/>
+          </a:fillRef>
+          <a:effectRef idx="2">
+            <a:schemeClr val="accent1"/>
+          </a:effectRef>
+          <a:fontRef idx="minor">
+            <a:schemeClr val="lt1"/>
+          </a:fontRef>
+        </p:style>
+        <p:txBody>
+          <a:bodyPr wrap="square" lIns="27432" tIns="22860" rIns="27432" bIns="22860" rtlCol="0" anchor="ctr"/>
+          <a:lstStyle/>
+          <a:p>
+            <a:pPr algn="ctr"/>
+            <a:r>
+              <a:rPr sz="2000" b="1" i="0" dirty="0">
+                <a:solidFill>
+                  <a:srgbClr val="FFFFFF"/>
+                </a:solidFill>
+              </a:rPr>
+              <a:t>FEW, LARGE</a:t>
+            </a:r>
+          </a:p>
+        </p:txBody>
+      </p:sp>
+      <p:sp>
+        <p:nvSpPr>
+          <p:cNvPr id="1003" name="Block"/>
+          <p:cNvSpPr/>
+          <p:nvPr/>
+        </p:nvSpPr>
+        <p:spPr>
+          <a:xfrm>
+            <a:off x="5669280" y="1005840"/>
+            <a:ext cx="3017520" cy="658368"/>
+          </a:xfrm>
+          <a:prstGeom prst="rect">
+            <a:avLst/>
+          </a:prstGeom>
+          <a:solidFill>
+            <a:srgbClr val="8E6F3E"/>
+          </a:solidFill>
+          <a:ln>
+            <a:noFill/>
+          </a:ln>
+          <a:effectLst/>
+        </p:spPr>
+        <p:style>
+          <a:lnRef idx="1">
+            <a:schemeClr val="accent1"/>
+          </a:lnRef>
+          <a:fillRef idx="3">
+            <a:schemeClr val="accent1"/>
+          </a:fillRef>
+          <a:effectRef idx="2">
+            <a:schemeClr val="accent1"/>
+          </a:effectRef>
+          <a:fontRef idx="minor">
+            <a:schemeClr val="lt1"/>
+          </a:fontRef>
+        </p:style>
+        <p:txBody>
+          <a:bodyPr wrap="square" lIns="27432" tIns="22860" rIns="27432" bIns="22860" rtlCol="0" anchor="ctr"/>
+          <a:lstStyle/>
+          <a:p>
+            <a:pPr algn="ctr"/>
+            <a:r>
+              <a:rPr sz="2000" b="1" i="0" dirty="0">
+                <a:solidFill>
+                  <a:srgbClr val="FFFFFF"/>
+                </a:solidFill>
+              </a:rPr>
+              <a:t>MANY, SMALL</a:t>
+            </a:r>
+          </a:p>
+        </p:txBody>
+      </p:sp>
+      <p:sp>
+        <p:nvSpPr>
+          <p:cNvPr id="1004" name="Label"/>
+          <p:cNvSpPr/>
+          <p:nvPr/>
+        </p:nvSpPr>
+        <p:spPr>
+          <a:xfrm>
+            <a:off x="274320" y="1865376"/>
+            <a:ext cx="1965960" cy="457200"/>
+          </a:xfrm>
+          <a:prstGeom prst="rect">
+            <a:avLst/>
+          </a:prstGeom>
+          <a:noFill/>
+          <a:ln>
+            <a:noFill/>
+          </a:ln>
+          <a:effectLst/>
+        </p:spPr>
+        <p:style>
+          <a:lnRef idx="1">
+            <a:schemeClr val="accent1"/>
+          </a:lnRef>
+          <a:fillRef idx="3">
+            <a:schemeClr val="accent1"/>
+          </a:fillRef>
+          <a:effectRef idx="2">
+            <a:schemeClr val="accent1"/>
+          </a:effectRef>
+          <a:fontRef idx="minor">
+            <a:schemeClr val="lt1"/>
+          </a:fontRef>
+        </p:style>
+        <p:txBody>
+          <a:bodyPr wrap="square" lIns="27432" tIns="22860" rIns="27432" bIns="22860" rtlCol="0" anchor="ctr"/>
+          <a:lstStyle/>
+          <a:p>
+            <a:pPr algn="r"/>
+            <a:r>
+              <a:rPr sz="2000" b="0" i="0" dirty="0">
+                <a:solidFill>
+                  <a:srgbClr val="555960"/>
+                </a:solidFill>
+              </a:rPr>
+              <a:t>change per release</a:t>
+            </a:r>
+          </a:p>
+        </p:txBody>
+      </p:sp>
+      <p:sp>
+        <p:nvSpPr>
+          <p:cNvPr id="1005" name="Card"/>
+          <p:cNvSpPr/>
+          <p:nvPr/>
+        </p:nvSpPr>
+        <p:spPr>
+          <a:xfrm>
+            <a:off x="2377440" y="1828800"/>
+            <a:ext cx="3017520" cy="512064"/>
+          </a:xfrm>
+          <a:prstGeom prst="rect">
+            <a:avLst/>
+          </a:prstGeom>
+          <a:solidFill>
+            <a:srgbClr val="F5F1E8"/>
+          </a:solidFill>
+          <a:ln w="12700">
+            <a:solidFill>
+              <a:srgbClr val="C9B991"/>
+            </a:solidFill>
+          </a:ln>
+          <a:effectLst/>
+        </p:spPr>
+        <p:style>
+          <a:lnRef idx="1">
+            <a:schemeClr val="accent1"/>
+          </a:lnRef>
+          <a:fillRef idx="3">
+            <a:schemeClr val="accent1"/>
+          </a:fillRef>
+          <a:effectRef idx="2">
+            <a:schemeClr val="accent1"/>
+          </a:effectRef>
+          <a:fontRef idx="minor">
+            <a:schemeClr val="lt1"/>
+          </a:fontRef>
+        </p:style>
+        <p:txBody>
+          <a:bodyPr wrap="square" lIns="27432" tIns="22860" rIns="27432" bIns="22860" rtlCol="0" anchor="ctr"/>
+          <a:lstStyle/>
+          <a:p>
+            <a:pPr algn="ctr"/>
+            <a:r>
+              <a:rPr sz="2000" b="0" i="0" dirty="0">
+                <a:solidFill>
+                  <a:srgbClr val="5C4826"/>
+                </a:solidFill>
+              </a:rPr>
+              <a:t>months of work</a:t>
+            </a:r>
+          </a:p>
+        </p:txBody>
+      </p:sp>
+      <p:sp>
+        <p:nvSpPr>
+          <p:cNvPr id="1006" name="Card"/>
+          <p:cNvSpPr/>
+          <p:nvPr/>
+        </p:nvSpPr>
+        <p:spPr>
+          <a:xfrm>
+            <a:off x="5669280" y="1828800"/>
+            <a:ext cx="3017520" cy="512064"/>
+          </a:xfrm>
+          <a:prstGeom prst="rect">
+            <a:avLst/>
+          </a:prstGeom>
+          <a:solidFill>
+            <a:srgbClr val="F5F1E8"/>
+          </a:solidFill>
+          <a:ln w="12700">
+            <a:solidFill>
+              <a:srgbClr val="C9B991"/>
+            </a:solidFill>
+          </a:ln>
+          <a:effectLst/>
+        </p:spPr>
+        <p:style>
+          <a:lnRef idx="1">
+            <a:schemeClr val="accent1"/>
+          </a:lnRef>
+          <a:fillRef idx="3">
+            <a:schemeClr val="accent1"/>
+          </a:fillRef>
+          <a:effectRef idx="2">
+            <a:schemeClr val="accent1"/>
+          </a:effectRef>
+          <a:fontRef idx="minor">
+            <a:schemeClr val="lt1"/>
+          </a:fontRef>
+        </p:style>
+        <p:txBody>
+          <a:bodyPr wrap="square" lIns="27432" tIns="22860" rIns="27432" bIns="22860" rtlCol="0" anchor="ctr"/>
+          <a:lstStyle/>
+          <a:p>
+            <a:pPr algn="ctr"/>
+            <a:r>
+              <a:rPr sz="2000" b="0" i="0" dirty="0">
+                <a:solidFill>
+                  <a:srgbClr val="5C4826"/>
+                </a:solidFill>
+              </a:rPr>
+              <a:t>days of work</a:t>
+            </a:r>
+          </a:p>
+        </p:txBody>
+      </p:sp>
+      <p:sp>
+        <p:nvSpPr>
+          <p:cNvPr id="1007" name="Label"/>
+          <p:cNvSpPr/>
+          <p:nvPr/>
+        </p:nvSpPr>
+        <p:spPr>
+          <a:xfrm>
+            <a:off x="274320" y="2487168"/>
+            <a:ext cx="1965960" cy="457200"/>
+          </a:xfrm>
+          <a:prstGeom prst="rect">
+            <a:avLst/>
+          </a:prstGeom>
+          <a:noFill/>
+          <a:ln>
+            <a:noFill/>
+          </a:ln>
+          <a:effectLst/>
+        </p:spPr>
+        <p:style>
+          <a:lnRef idx="1">
+            <a:schemeClr val="accent1"/>
+          </a:lnRef>
+          <a:fillRef idx="3">
+            <a:schemeClr val="accent1"/>
+          </a:fillRef>
+          <a:effectRef idx="2">
+            <a:schemeClr val="accent1"/>
+          </a:effectRef>
+          <a:fontRef idx="minor">
+            <a:schemeClr val="lt1"/>
+          </a:fontRef>
+        </p:style>
+        <p:txBody>
+          <a:bodyPr wrap="square" lIns="27432" tIns="22860" rIns="27432" bIns="22860" rtlCol="0" anchor="ctr"/>
+          <a:lstStyle/>
+          <a:p>
+            <a:pPr algn="r"/>
+            <a:r>
+              <a:rPr sz="2000" b="0" i="0" dirty="0">
+                <a:solidFill>
+                  <a:srgbClr val="555960"/>
+                </a:solidFill>
+              </a:rPr>
+              <a:t>verification cost</a:t>
+            </a:r>
+          </a:p>
+        </p:txBody>
+      </p:sp>
+      <p:sp>
+        <p:nvSpPr>
+          <p:cNvPr id="1008" name="Card"/>
+          <p:cNvSpPr/>
+          <p:nvPr/>
+        </p:nvSpPr>
+        <p:spPr>
+          <a:xfrm>
+            <a:off x="2377440" y="2450592"/>
+            <a:ext cx="3017520" cy="512064"/>
+          </a:xfrm>
+          <a:prstGeom prst="rect">
+            <a:avLst/>
+          </a:prstGeom>
+          <a:solidFill>
+            <a:srgbClr val="F5F1E8"/>
+          </a:solidFill>
+          <a:ln w="12700">
+            <a:solidFill>
+              <a:srgbClr val="C9B991"/>
+            </a:solidFill>
+          </a:ln>
+          <a:effectLst/>
+        </p:spPr>
+        <p:style>
+          <a:lnRef idx="1">
+            <a:schemeClr val="accent1"/>
+          </a:lnRef>
+          <a:fillRef idx="3">
+            <a:schemeClr val="accent1"/>
+          </a:fillRef>
+          <a:effectRef idx="2">
+            <a:schemeClr val="accent1"/>
+          </a:effectRef>
+          <a:fontRef idx="minor">
+            <a:schemeClr val="lt1"/>
+          </a:fontRef>
+        </p:style>
+        <p:txBody>
+          <a:bodyPr wrap="square" lIns="27432" tIns="22860" rIns="27432" bIns="22860" rtlCol="0" anchor="ctr"/>
+          <a:lstStyle/>
+          <a:p>
+            <a:pPr algn="ctr"/>
+            <a:r>
+              <a:rPr sz="2000" b="0" i="0" dirty="0">
+                <a:solidFill>
+                  <a:srgbClr val="5C4826"/>
+                </a:solidFill>
+              </a:rPr>
+              <a:t>long test cycles</a:t>
+            </a:r>
+          </a:p>
+        </p:txBody>
+      </p:sp>
+      <p:sp>
+        <p:nvSpPr>
+          <p:cNvPr id="1009" name="Card"/>
+          <p:cNvSpPr/>
+          <p:nvPr/>
+        </p:nvSpPr>
+        <p:spPr>
+          <a:xfrm>
+            <a:off x="5669280" y="2450592"/>
+            <a:ext cx="3017520" cy="512064"/>
+          </a:xfrm>
+          <a:prstGeom prst="rect">
+            <a:avLst/>
+          </a:prstGeom>
+          <a:solidFill>
+            <a:srgbClr val="F5F1E8"/>
+          </a:solidFill>
+          <a:ln w="12700">
+            <a:solidFill>
+              <a:srgbClr val="C9B991"/>
+            </a:solidFill>
+          </a:ln>
+          <a:effectLst/>
+        </p:spPr>
+        <p:style>
+          <a:lnRef idx="1">
+            <a:schemeClr val="accent1"/>
+          </a:lnRef>
+          <a:fillRef idx="3">
+            <a:schemeClr val="accent1"/>
+          </a:fillRef>
+          <a:effectRef idx="2">
+            <a:schemeClr val="accent1"/>
+          </a:effectRef>
+          <a:fontRef idx="minor">
+            <a:schemeClr val="lt1"/>
+          </a:fontRef>
+        </p:style>
+        <p:txBody>
+          <a:bodyPr wrap="square" lIns="27432" tIns="22860" rIns="27432" bIns="22860" rtlCol="0" anchor="ctr"/>
+          <a:lstStyle/>
+          <a:p>
+            <a:pPr algn="ctr"/>
+            <a:r>
+              <a:rPr sz="2000" b="0" i="0" dirty="0">
+                <a:solidFill>
+                  <a:srgbClr val="5C4826"/>
+                </a:solidFill>
+              </a:rPr>
+              <a:t>automated gates</a:t>
+            </a:r>
+          </a:p>
+        </p:txBody>
+      </p:sp>
+      <p:sp>
+        <p:nvSpPr>
+          <p:cNvPr id="1010" name="Label"/>
+          <p:cNvSpPr/>
+          <p:nvPr/>
+        </p:nvSpPr>
+        <p:spPr>
+          <a:xfrm>
+            <a:off x="274320" y="3108960"/>
+            <a:ext cx="1965960" cy="457200"/>
+          </a:xfrm>
+          <a:prstGeom prst="rect">
+            <a:avLst/>
+          </a:prstGeom>
+          <a:noFill/>
+          <a:ln>
+            <a:noFill/>
+          </a:ln>
+          <a:effectLst/>
+        </p:spPr>
+        <p:style>
+          <a:lnRef idx="1">
+            <a:schemeClr val="accent1"/>
+          </a:lnRef>
+          <a:fillRef idx="3">
+            <a:schemeClr val="accent1"/>
+          </a:fillRef>
+          <a:effectRef idx="2">
+            <a:schemeClr val="accent1"/>
+          </a:effectRef>
+          <a:fontRef idx="minor">
+            <a:schemeClr val="lt1"/>
+          </a:fontRef>
+        </p:style>
+        <p:txBody>
+          <a:bodyPr wrap="square" lIns="27432" tIns="22860" rIns="27432" bIns="22860" rtlCol="0" anchor="ctr"/>
+          <a:lstStyle/>
+          <a:p>
+            <a:pPr algn="r"/>
+            <a:r>
+              <a:rPr sz="2000" b="0" i="0" dirty="0">
+                <a:solidFill>
+                  <a:srgbClr val="555960"/>
+                </a:solidFill>
+              </a:rPr>
+              <a:t>coordination</a:t>
+            </a:r>
+          </a:p>
+        </p:txBody>
+      </p:sp>
+      <p:sp>
+        <p:nvSpPr>
+          <p:cNvPr id="1011" name="Card"/>
+          <p:cNvSpPr/>
+          <p:nvPr/>
+        </p:nvSpPr>
+        <p:spPr>
+          <a:xfrm>
+            <a:off x="2377440" y="3072384"/>
+            <a:ext cx="3017520" cy="512064"/>
+          </a:xfrm>
+          <a:prstGeom prst="rect">
+            <a:avLst/>
+          </a:prstGeom>
+          <a:solidFill>
+            <a:srgbClr val="F5F1E8"/>
+          </a:solidFill>
+          <a:ln w="12700">
+            <a:solidFill>
+              <a:srgbClr val="C9B991"/>
+            </a:solidFill>
+          </a:ln>
+          <a:effectLst/>
+        </p:spPr>
+        <p:style>
+          <a:lnRef idx="1">
+            <a:schemeClr val="accent1"/>
+          </a:lnRef>
+          <a:fillRef idx="3">
+            <a:schemeClr val="accent1"/>
+          </a:fillRef>
+          <a:effectRef idx="2">
+            <a:schemeClr val="accent1"/>
+          </a:effectRef>
+          <a:fontRef idx="minor">
+            <a:schemeClr val="lt1"/>
+          </a:fontRef>
+        </p:style>
+        <p:txBody>
+          <a:bodyPr wrap="square" lIns="27432" tIns="22860" rIns="27432" bIns="22860" rtlCol="0" anchor="ctr"/>
+          <a:lstStyle/>
+          <a:p>
+            <a:pPr algn="ctr"/>
+            <a:r>
+              <a:rPr sz="2000" b="0" i="0" dirty="0">
+                <a:solidFill>
+                  <a:srgbClr val="5C4826"/>
+                </a:solidFill>
+              </a:rPr>
+              <a:t>planned windows</a:t>
+            </a:r>
+          </a:p>
+        </p:txBody>
+      </p:sp>
+      <p:sp>
+        <p:nvSpPr>
+          <p:cNvPr id="1012" name="Card"/>
+          <p:cNvSpPr/>
+          <p:nvPr/>
+        </p:nvSpPr>
+        <p:spPr>
+          <a:xfrm>
+            <a:off x="5669280" y="3072384"/>
+            <a:ext cx="3017520" cy="512064"/>
+          </a:xfrm>
+          <a:prstGeom prst="rect">
+            <a:avLst/>
+          </a:prstGeom>
+          <a:solidFill>
+            <a:srgbClr val="F5F1E8"/>
+          </a:solidFill>
+          <a:ln w="12700">
+            <a:solidFill>
+              <a:srgbClr val="C9B991"/>
+            </a:solidFill>
+          </a:ln>
+          <a:effectLst/>
+        </p:spPr>
+        <p:style>
+          <a:lnRef idx="1">
+            <a:schemeClr val="accent1"/>
+          </a:lnRef>
+          <a:fillRef idx="3">
+            <a:schemeClr val="accent1"/>
+          </a:fillRef>
+          <a:effectRef idx="2">
+            <a:schemeClr val="accent1"/>
+          </a:effectRef>
+          <a:fontRef idx="minor">
+            <a:schemeClr val="lt1"/>
+          </a:fontRef>
+        </p:style>
+        <p:txBody>
+          <a:bodyPr wrap="square" lIns="27432" tIns="22860" rIns="27432" bIns="22860" rtlCol="0" anchor="ctr"/>
+          <a:lstStyle/>
+          <a:p>
+            <a:pPr algn="ctr"/>
+            <a:r>
+              <a:rPr sz="2000" b="0" i="0" dirty="0">
+                <a:solidFill>
+                  <a:srgbClr val="5C4826"/>
+                </a:solidFill>
+              </a:rPr>
+              <a:t>routine</a:t>
+            </a:r>
+          </a:p>
+        </p:txBody>
+      </p:sp>
+      <p:sp>
+        <p:nvSpPr>
+          <p:cNvPr id="1013" name="Label"/>
+          <p:cNvSpPr/>
+          <p:nvPr/>
+        </p:nvSpPr>
+        <p:spPr>
+          <a:xfrm>
+            <a:off x="274320" y="3730752"/>
+            <a:ext cx="1965960" cy="457200"/>
+          </a:xfrm>
+          <a:prstGeom prst="rect">
+            <a:avLst/>
+          </a:prstGeom>
+          <a:noFill/>
+          <a:ln>
+            <a:noFill/>
+          </a:ln>
+          <a:effectLst/>
+        </p:spPr>
+        <p:style>
+          <a:lnRef idx="1">
+            <a:schemeClr val="accent1"/>
+          </a:lnRef>
+          <a:fillRef idx="3">
+            <a:schemeClr val="accent1"/>
+          </a:fillRef>
+          <a:effectRef idx="2">
+            <a:schemeClr val="accent1"/>
+          </a:effectRef>
+          <a:fontRef idx="minor">
+            <a:schemeClr val="lt1"/>
+          </a:fontRef>
+        </p:style>
+        <p:txBody>
+          <a:bodyPr wrap="square" lIns="27432" tIns="22860" rIns="27432" bIns="22860" rtlCol="0" anchor="ctr"/>
+          <a:lstStyle/>
+          <a:p>
+            <a:pPr algn="r"/>
+            <a:r>
+              <a:rPr sz="2000" b="0" i="0" dirty="0">
+                <a:solidFill>
+                  <a:srgbClr val="555960"/>
+                </a:solidFill>
+              </a:rPr>
+              <a:t>detecting a failure</a:t>
+            </a:r>
+          </a:p>
+        </p:txBody>
+      </p:sp>
+      <p:sp>
+        <p:nvSpPr>
+          <p:cNvPr id="1014" name="Card"/>
+          <p:cNvSpPr/>
+          <p:nvPr/>
+        </p:nvSpPr>
+        <p:spPr>
+          <a:xfrm>
+            <a:off x="2377440" y="3694176"/>
+            <a:ext cx="3017520" cy="512064"/>
+          </a:xfrm>
+          <a:prstGeom prst="rect">
+            <a:avLst/>
+          </a:prstGeom>
+          <a:solidFill>
+            <a:srgbClr val="F5F1E8"/>
+          </a:solidFill>
+          <a:ln w="12700">
+            <a:solidFill>
+              <a:srgbClr val="C9B991"/>
+            </a:solidFill>
+          </a:ln>
+          <a:effectLst/>
+        </p:spPr>
+        <p:style>
+          <a:lnRef idx="1">
+            <a:schemeClr val="accent1"/>
+          </a:lnRef>
+          <a:fillRef idx="3">
+            <a:schemeClr val="accent1"/>
+          </a:fillRef>
+          <a:effectRef idx="2">
+            <a:schemeClr val="accent1"/>
+          </a:effectRef>
+          <a:fontRef idx="minor">
+            <a:schemeClr val="lt1"/>
+          </a:fontRef>
+        </p:style>
+        <p:txBody>
+          <a:bodyPr wrap="square" lIns="27432" tIns="22860" rIns="27432" bIns="22860" rtlCol="0" anchor="ctr"/>
+          <a:lstStyle/>
+          <a:p>
+            <a:pPr algn="ctr"/>
+            <a:r>
+              <a:rPr sz="2000" b="0" i="0" dirty="0">
+                <a:solidFill>
+                  <a:srgbClr val="5C4826"/>
+                </a:solidFill>
+              </a:rPr>
+              <a:t>harder to attribute</a:t>
+            </a:r>
+          </a:p>
+        </p:txBody>
+      </p:sp>
+      <p:sp>
+        <p:nvSpPr>
+          <p:cNvPr id="1015" name="Card"/>
+          <p:cNvSpPr/>
+          <p:nvPr/>
+        </p:nvSpPr>
+        <p:spPr>
+          <a:xfrm>
+            <a:off x="5669280" y="3694176"/>
+            <a:ext cx="3017520" cy="512064"/>
+          </a:xfrm>
+          <a:prstGeom prst="rect">
+            <a:avLst/>
+          </a:prstGeom>
+          <a:solidFill>
+            <a:srgbClr val="F5F1E8"/>
+          </a:solidFill>
+          <a:ln w="12700">
+            <a:solidFill>
+              <a:srgbClr val="C9B991"/>
+            </a:solidFill>
+          </a:ln>
+          <a:effectLst/>
+        </p:spPr>
+        <p:style>
+          <a:lnRef idx="1">
+            <a:schemeClr val="accent1"/>
+          </a:lnRef>
+          <a:fillRef idx="3">
+            <a:schemeClr val="accent1"/>
+          </a:fillRef>
+          <a:effectRef idx="2">
+            <a:schemeClr val="accent1"/>
+          </a:effectRef>
+          <a:fontRef idx="minor">
+            <a:schemeClr val="lt1"/>
+          </a:fontRef>
+        </p:style>
+        <p:txBody>
+          <a:bodyPr wrap="square" lIns="27432" tIns="22860" rIns="27432" bIns="22860" rtlCol="0" anchor="ctr"/>
+          <a:lstStyle/>
+          <a:p>
+            <a:pPr algn="ctr"/>
+            <a:r>
+              <a:rPr sz="2000" b="0" i="0" dirty="0">
+                <a:solidFill>
+                  <a:srgbClr val="5C4826"/>
+                </a:solidFill>
+              </a:rPr>
+              <a:t>small suspect set</a:t>
+            </a:r>
+          </a:p>
+        </p:txBody>
+      </p:sp>
+      <p:sp>
+        <p:nvSpPr>
+          <p:cNvPr id="1016" name="Label"/>
+          <p:cNvSpPr/>
+          <p:nvPr/>
+        </p:nvSpPr>
+        <p:spPr>
+          <a:xfrm>
+            <a:off x="274320" y="4352544"/>
+            <a:ext cx="1965960" cy="457200"/>
+          </a:xfrm>
+          <a:prstGeom prst="rect">
+            <a:avLst/>
+          </a:prstGeom>
+          <a:noFill/>
+          <a:ln>
+            <a:noFill/>
+          </a:ln>
+          <a:effectLst/>
+        </p:spPr>
+        <p:style>
+          <a:lnRef idx="1">
+            <a:schemeClr val="accent1"/>
+          </a:lnRef>
+          <a:fillRef idx="3">
+            <a:schemeClr val="accent1"/>
+          </a:fillRef>
+          <a:effectRef idx="2">
+            <a:schemeClr val="accent1"/>
+          </a:effectRef>
+          <a:fontRef idx="minor">
+            <a:schemeClr val="lt1"/>
+          </a:fontRef>
+        </p:style>
+        <p:txBody>
+          <a:bodyPr wrap="square" lIns="27432" tIns="22860" rIns="27432" bIns="22860" rtlCol="0" anchor="ctr"/>
+          <a:lstStyle/>
+          <a:p>
+            <a:pPr algn="r"/>
+            <a:r>
+              <a:rPr sz="2000" b="0" i="0" dirty="0">
+                <a:solidFill>
+                  <a:srgbClr val="555960"/>
+                </a:solidFill>
+              </a:rPr>
+              <a:t>reversing a failure</a:t>
+            </a:r>
+          </a:p>
+        </p:txBody>
+      </p:sp>
+      <p:sp>
+        <p:nvSpPr>
+          <p:cNvPr id="1017" name="Card"/>
+          <p:cNvSpPr/>
+          <p:nvPr/>
+        </p:nvSpPr>
+        <p:spPr>
+          <a:xfrm>
+            <a:off x="2377440" y="4315968"/>
+            <a:ext cx="3017520" cy="512064"/>
+          </a:xfrm>
+          <a:prstGeom prst="rect">
+            <a:avLst/>
+          </a:prstGeom>
+          <a:solidFill>
+            <a:srgbClr val="F5F1E8"/>
+          </a:solidFill>
+          <a:ln w="12700">
+            <a:solidFill>
+              <a:srgbClr val="C9B991"/>
+            </a:solidFill>
+          </a:ln>
+          <a:effectLst/>
+        </p:spPr>
+        <p:style>
+          <a:lnRef idx="1">
+            <a:schemeClr val="accent1"/>
+          </a:lnRef>
+          <a:fillRef idx="3">
+            <a:schemeClr val="accent1"/>
+          </a:fillRef>
+          <a:effectRef idx="2">
+            <a:schemeClr val="accent1"/>
+          </a:effectRef>
+          <a:fontRef idx="minor">
+            <a:schemeClr val="lt1"/>
+          </a:fontRef>
+        </p:style>
+        <p:txBody>
+          <a:bodyPr wrap="square" lIns="27432" tIns="22860" rIns="27432" bIns="22860" rtlCol="0" anchor="ctr"/>
+          <a:lstStyle/>
+          <a:p>
+            <a:pPr algn="ctr"/>
+            <a:r>
+              <a:rPr sz="2000" b="0" i="0" dirty="0">
+                <a:solidFill>
+                  <a:srgbClr val="5C4826"/>
+                </a:solidFill>
+              </a:rPr>
+              <a:t>big rollback</a:t>
+            </a:r>
+          </a:p>
+        </p:txBody>
+      </p:sp>
+      <p:sp>
+        <p:nvSpPr>
+          <p:cNvPr id="1018" name="Card"/>
+          <p:cNvSpPr/>
+          <p:nvPr/>
+        </p:nvSpPr>
+        <p:spPr>
+          <a:xfrm>
+            <a:off x="5669280" y="4315968"/>
+            <a:ext cx="3017520" cy="512064"/>
+          </a:xfrm>
+          <a:prstGeom prst="rect">
+            <a:avLst/>
+          </a:prstGeom>
+          <a:solidFill>
+            <a:srgbClr val="F5F1E8"/>
+          </a:solidFill>
+          <a:ln w="12700">
+            <a:solidFill>
+              <a:srgbClr val="C9B991"/>
+            </a:solidFill>
+          </a:ln>
+          <a:effectLst/>
+        </p:spPr>
+        <p:style>
+          <a:lnRef idx="1">
+            <a:schemeClr val="accent1"/>
+          </a:lnRef>
+          <a:fillRef idx="3">
+            <a:schemeClr val="accent1"/>
+          </a:fillRef>
+          <a:effectRef idx="2">
+            <a:schemeClr val="accent1"/>
+          </a:effectRef>
+          <a:fontRef idx="minor">
+            <a:schemeClr val="lt1"/>
+          </a:fontRef>
+        </p:style>
+        <p:txBody>
+          <a:bodyPr wrap="square" lIns="27432" tIns="22860" rIns="27432" bIns="22860" rtlCol="0" anchor="ctr"/>
+          <a:lstStyle/>
+          <a:p>
+            <a:pPr algn="ctr"/>
+            <a:r>
+              <a:rPr sz="2000" b="0" i="0" dirty="0">
+                <a:solidFill>
+                  <a:srgbClr val="5C4826"/>
+                </a:solidFill>
+              </a:rPr>
+              <a:t>small rollback</a:t>
+            </a:r>
+          </a:p>
+        </p:txBody>
+      </p:sp>
+      <p:sp>
+        <p:nvSpPr>
+          <p:cNvPr id="1019" name="Label"/>
+          <p:cNvSpPr/>
+          <p:nvPr/>
+        </p:nvSpPr>
+        <p:spPr>
+          <a:xfrm>
+            <a:off x="365760" y="5029200"/>
+            <a:ext cx="8412480" cy="658368"/>
+          </a:xfrm>
+          <a:prstGeom prst="rect">
+            <a:avLst/>
+          </a:prstGeom>
+          <a:noFill/>
+          <a:ln>
+            <a:noFill/>
+          </a:ln>
+          <a:effectLst/>
+        </p:spPr>
+        <p:style>
+          <a:lnRef idx="1">
+            <a:schemeClr val="accent1"/>
+          </a:lnRef>
+          <a:fillRef idx="3">
+            <a:schemeClr val="accent1"/>
+          </a:fillRef>
+          <a:effectRef idx="2">
+            <a:schemeClr val="accent1"/>
+          </a:effectRef>
+          <a:fontRef idx="minor">
+            <a:schemeClr val="lt1"/>
+          </a:fontRef>
+        </p:style>
+        <p:txBody>
+          <a:bodyPr wrap="square" lIns="27432" tIns="22860" rIns="27432" bIns="22860" rtlCol="0" anchor="ctr"/>
+          <a:lstStyle/>
+          <a:p>
+            <a:pPr algn="ctr"/>
+            <a:r>
+              <a:rPr sz="2000" b="0" i="1" dirty="0">
+                <a:solidFill>
+                  <a:srgbClr val="555960"/>
+                </a:solidFill>
+              </a:rPr>
+              <a:t>Industry baselines for these tradeoffs (the DORA metrics) return in Operations &amp; SRE</a:t>
             </a:r>
           </a:p>
         </p:txBody>

</xml_diff>

<commit_message>
deck 3-1: closing worked example and synthesis — slides 22-23; deck complete
The two-option decision exercise (local installation vs managed
service, argued from the deployment model under shifting requirements)
and the synthesis slide that populates the kickoff method rows for
deployment, closing on the handoff to Data Management. Deck totals:
23 slides, TIMING 65 minutes, gold banner on five slides (2, 6, 16,
22, 23), pptx_validate clean.

Co-Authored-By: Claude Opus 5 <noreply@anthropic.com>
</commit_message>
<xml_diff>
--- a/course/lectures/act-3-software-in-the-world/02-compute-environments-and-data-management/3-1-Compute-Environments-and-Deployment.pptx
+++ b/course/lectures/act-3-software-in-the-world/02-compute-environments-and-data-management/3-1-Compute-Environments-and-Deployment.pptx
@@ -29,6 +29,8 @@
     <p:sldId id="274" r:id="rId26"/>
     <p:sldId id="275" r:id="rId27"/>
     <p:sldId id="276" r:id="rId28"/>
+    <p:sldId id="277" r:id="rId29"/>
+    <p:sldId id="278" r:id="rId30"/>
   </p:sldIdLst>
   <p:sldSz cx="9144000" cy="6858000" type="screen4x3"/>
   <p:notesSz cx="6858000" cy="9144000"/>
@@ -2347,6 +2349,186 @@
 </p:notes>
 </file>
 
+<file path=ppt/notesSlides/notesSlide22.xml><?xml version="1.0" encoding="utf-8"?>
+<p:notes xmlns:a="http://schemas.openxmlformats.org/drawingml/2006/main" xmlns:p="http://schemas.openxmlformats.org/presentationml/2006/main" xmlns:r="http://schemas.openxmlformats.org/officeDocument/2006/relationships">
+  <p:cSld>
+    <p:spTree>
+      <p:nvGrpSpPr>
+        <p:cNvPr id="1" name=""/>
+        <p:cNvGrpSpPr/>
+        <p:nvPr/>
+      </p:nvGrpSpPr>
+      <p:grpSpPr>
+        <a:xfrm>
+          <a:off x="0" y="0"/>
+          <a:ext cx="0" cy="0"/>
+          <a:chOff x="0" y="0"/>
+          <a:chExt cx="0" cy="0"/>
+        </a:xfrm>
+      </p:grpSpPr>
+      <p:sp>
+        <p:nvSpPr>
+          <p:cNvPr id="2" name="Slide Image Placeholder 1"/>
+          <p:cNvSpPr>
+            <a:spLocks noGrp="1"/>
+          </p:cNvSpPr>
+          <p:nvPr>
+            <p:ph type="sldImg" idx="2"/>
+          </p:nvPr>
+        </p:nvSpPr>
+        <p:spPr/>
+      </p:sp>
+      <p:sp>
+        <p:nvSpPr>
+          <p:cNvPr id="3" name="Notes Placeholder 2"/>
+          <p:cNvSpPr>
+            <a:spLocks noGrp="1"/>
+          </p:cNvSpPr>
+          <p:nvPr>
+            <p:ph type="body" idx="3" sz="quarter"/>
+          </p:nvPr>
+        </p:nvSpPr>
+        <p:spPr/>
+        <p:txBody>
+          <a:bodyPr/>
+          <a:lstStyle/>
+          <a:p>
+            <a:r>
+              <a:t>TIMING: 5 minutes. THE DECISION EXERCISE; a discussion, not a programming demonstration.</a:t>
+            </a:r>
+          </a:p>
+          <a:p>
+            <a:r>
+              <a:t>SETUP (half a minute): two candidate deployments for the reservation service. Option A, local installation on a university-managed workstation, updated by installing a new version at each machine. Option B, a managed service platform, reached by browser, updated centrally through the release gates this section built.</a:t>
+            </a:r>
+          </a:p>
+          <a:p>
+            <a:r>
+              <a:t>RUN IT (three minutes): pairs or trios pick an option and defend it FROM THE MODEL: execution environment, resources, topology, configuration, plus the deployment process each option implies. Push on the two printed perturbations: no network access swings the argument to A; hundreds of simultaneous users swing it to B. The point is that the ANSWER MOVES when the requirements move, and the model is what lets you see it move.</a:t>
+            </a:r>
+          </a:p>
+          <a:p>
+            <a:r>
+              <a:t>DEBRIEF (a minute and a half): collect one argument per side; name the assumption it rests on. If a group says 'B, obviously', change a requirement until they flinch.</a:t>
+            </a:r>
+          </a:p>
+          <a:p>
+            <a:r>
+              <a:t>EXPECTED QUALITY BAR: answers that cite availability, operations burden, update mechanics, or configuration are engaging the model; answers that cite fashion are not.</a:t>
+            </a:r>
+          </a:p>
+          <a:p>
+            <a:r>
+              <a:t>TRANSITION: close the loop on the whole lecture.</a:t>
+            </a:r>
+          </a:p>
+        </p:txBody>
+      </p:sp>
+      <p:sp>
+        <p:nvSpPr>
+          <p:cNvPr id="4" name="Slide Number Placeholder 3"/>
+          <p:cNvSpPr>
+            <a:spLocks noGrp="1"/>
+          </p:cNvSpPr>
+          <p:nvPr>
+            <p:ph type="sldNum" idx="5" sz="quarter"/>
+          </p:nvPr>
+        </p:nvSpPr>
+        <p:spPr/>
+      </p:sp>
+    </p:spTree>
+  </p:cSld>
+  <p:clrMapOvr>
+    <a:masterClrMapping/>
+  </p:clrMapOvr>
+</p:notes>
+</file>
+
+<file path=ppt/notesSlides/notesSlide23.xml><?xml version="1.0" encoding="utf-8"?>
+<p:notes xmlns:a="http://schemas.openxmlformats.org/drawingml/2006/main" xmlns:p="http://schemas.openxmlformats.org/presentationml/2006/main" xmlns:r="http://schemas.openxmlformats.org/officeDocument/2006/relationships">
+  <p:cSld>
+    <p:spTree>
+      <p:nvGrpSpPr>
+        <p:cNvPr id="1" name=""/>
+        <p:cNvGrpSpPr/>
+        <p:nvPr/>
+      </p:nvGrpSpPr>
+      <p:grpSpPr>
+        <a:xfrm>
+          <a:off x="0" y="0"/>
+          <a:ext cx="0" cy="0"/>
+          <a:chOff x="0" y="0"/>
+          <a:chExt cx="0" cy="0"/>
+        </a:xfrm>
+      </p:grpSpPr>
+      <p:sp>
+        <p:nvSpPr>
+          <p:cNvPr id="2" name="Slide Image Placeholder 1"/>
+          <p:cNvSpPr>
+            <a:spLocks noGrp="1"/>
+          </p:cNvSpPr>
+          <p:nvPr>
+            <p:ph type="sldImg" idx="2"/>
+          </p:nvPr>
+        </p:nvSpPr>
+        <p:spPr/>
+      </p:sp>
+      <p:sp>
+        <p:nvSpPr>
+          <p:cNvPr id="3" name="Notes Placeholder 2"/>
+          <p:cNvSpPr>
+            <a:spLocks noGrp="1"/>
+          </p:cNvSpPr>
+          <p:nvPr>
+            <p:ph type="body" idx="3" sz="quarter"/>
+          </p:nvPr>
+        </p:nvSpPr>
+        <p:spPr/>
+        <p:txBody>
+          <a:bodyPr/>
+          <a:lstStyle/>
+          <a:p>
+            <a:r>
+              <a:t>TIMING: 3 minutes. THE SYNTHESIS: the kickoff method, populated for deployment. The rows ARE the kickoff flowchart's steps in order, with Alignment in its own color exactly as the motif draws it; students should recognize the shape without re-explanation.</a:t>
+            </a:r>
+          </a:p>
+          <a:p>
+            <a:r>
+              <a:t>WALK THE ROWS: the problem was that software must run acceptably outside development. The model is the deployed system: execution environment, resources, topology, configuration (the two-part model's state half). The judgment chose among local, self-hosted, and managed. Realization is the deployment process: build, validate, release. Evidence came from build, integration, deployment, and runtime checks. Alignment held throughout as declared configuration, CI gates, and release policies, constraining realization and judging its results.</a:t>
+            </a:r>
+          </a:p>
+          <a:p>
+            <a:r>
+              <a:t>SAY ONCE, because it is the lecture's thesis: CI/CD and release management were not the subject; they are mechanisms for moving an implementation into an acceptable execution environment. The environment question organized everything.</a:t>
+            </a:r>
+          </a:p>
+          <a:p>
+            <a:r>
+              <a:t>THE HANDOFF (the footer): the service now runs in a suitable environment, and every restart still destroys every reservation, because the state is in memory by declared assumption. What happens to its data when the process stops is the Data Management lecture.</a:t>
+            </a:r>
+          </a:p>
+        </p:txBody>
+      </p:sp>
+      <p:sp>
+        <p:nvSpPr>
+          <p:cNvPr id="4" name="Slide Number Placeholder 3"/>
+          <p:cNvSpPr>
+            <a:spLocks noGrp="1"/>
+          </p:cNvSpPr>
+          <p:nvPr>
+            <p:ph type="sldNum" idx="5" sz="quarter"/>
+          </p:nvPr>
+        </p:nvSpPr>
+        <p:spPr/>
+      </p:sp>
+    </p:spTree>
+  </p:cSld>
+  <p:clrMapOvr>
+    <a:masterClrMapping/>
+  </p:clrMapOvr>
+</p:notes>
+</file>
+
 <file path=ppt/notesSlides/notesSlide3.xml><?xml version="1.0" encoding="utf-8"?>
 <p:notes xmlns:a="http://schemas.openxmlformats.org/drawingml/2006/main" xmlns:p="http://schemas.openxmlformats.org/presentationml/2006/main" xmlns:r="http://schemas.openxmlformats.org/officeDocument/2006/relationships">
   <p:cSld>
@@ -14453,6 +14635,1216 @@
 </p:sld>
 </file>
 
+<file path=ppt/slides/slide22.xml><?xml version="1.0" encoding="utf-8"?>
+<p:sld xmlns:a="http://schemas.openxmlformats.org/drawingml/2006/main" xmlns:p="http://schemas.openxmlformats.org/presentationml/2006/main" xmlns:r="http://schemas.openxmlformats.org/officeDocument/2006/relationships">
+  <p:cSld>
+    <p:spTree>
+      <p:nvGrpSpPr>
+        <p:cNvPr id="1" name=""/>
+        <p:cNvGrpSpPr/>
+        <p:nvPr/>
+      </p:nvGrpSpPr>
+      <p:grpSpPr/>
+      <p:sp>
+        <p:nvSpPr>
+          <p:cNvPr id="3" name="Title 2"/>
+          <p:cNvSpPr>
+            <a:spLocks noGrp="1"/>
+          </p:cNvSpPr>
+          <p:nvPr>
+            <p:ph type="title"/>
+          </p:nvPr>
+        </p:nvSpPr>
+        <p:spPr/>
+        <p:txBody>
+          <a:bodyPr wrap="square"/>
+          <a:lstStyle/>
+          <a:p>
+            <a:pPr algn="l"/>
+            <a:r>
+              <a:rPr sz="2400" b="0" i="0" dirty="0">
+                <a:solidFill>
+                  <a:srgbClr val="000000"/>
+                </a:solidFill>
+              </a:rPr>
+              <a:t>Deploy the reservation service</a:t>
+            </a:r>
+          </a:p>
+        </p:txBody>
+      </p:sp>
+      <p:sp>
+        <p:nvSpPr>
+          <p:cNvPr id="1001" name="Slide Number Placeholder 900"/>
+          <p:cNvSpPr>
+            <a:spLocks noGrp="1"/>
+          </p:cNvSpPr>
+          <p:nvPr>
+            <p:ph type="sldNum" sz="quarter" idx="4"/>
+          </p:nvPr>
+        </p:nvSpPr>
+        <p:spPr/>
+        <p:txBody>
+          <a:bodyPr/>
+          <a:lstStyle/>
+          <a:p>
+            <a:fld id="{B3291E67-7172-4DCF-B35F-54404EBE6160}" type="slidenum">
+              <a:rPr lang="en-US" smtClean="0"/>
+              <a:t>1</a:t>
+            </a:fld>
+            <a:endParaRPr lang="en-US"/>
+          </a:p>
+        </p:txBody>
+      </p:sp>
+      <p:sp>
+        <p:nvSpPr>
+          <p:cNvPr id="1002" name="Card"/>
+          <p:cNvSpPr/>
+          <p:nvPr/>
+        </p:nvSpPr>
+        <p:spPr>
+          <a:xfrm>
+            <a:off x="411480" y="1051560"/>
+            <a:ext cx="4023360" cy="2514600"/>
+          </a:xfrm>
+          <a:prstGeom prst="rect">
+            <a:avLst/>
+          </a:prstGeom>
+          <a:solidFill>
+            <a:srgbClr val="F5F1E8"/>
+          </a:solidFill>
+          <a:ln w="12700">
+            <a:solidFill>
+              <a:srgbClr val="C9B991"/>
+            </a:solidFill>
+          </a:ln>
+          <a:effectLst/>
+        </p:spPr>
+        <p:style>
+          <a:lnRef idx="1">
+            <a:schemeClr val="accent1"/>
+          </a:lnRef>
+          <a:fillRef idx="3">
+            <a:schemeClr val="accent1"/>
+          </a:fillRef>
+          <a:effectRef idx="2">
+            <a:schemeClr val="accent1"/>
+          </a:effectRef>
+          <a:fontRef idx="minor">
+            <a:schemeClr val="lt1"/>
+          </a:fontRef>
+        </p:style>
+        <p:txBody>
+          <a:bodyPr wrap="square" lIns="27432" tIns="22860" rIns="27432" bIns="22860" rtlCol="0" anchor="t"/>
+          <a:lstStyle/>
+          <a:p>
+            <a:pPr algn="ctr"/>
+            <a:r>
+              <a:rPr sz="2000" b="1" i="0" dirty="0">
+                <a:solidFill>
+                  <a:srgbClr val="5C4826"/>
+                </a:solidFill>
+              </a:rPr>
+              <a:t>OPTION A: LOCAL INSTALLATION</a:t>
+            </a:r>
+          </a:p>
+          <a:p>
+            <a:pPr algn="ctr">
+              <a:spcBef>
+                <a:spcPts val="800"/>
+              </a:spcBef>
+            </a:pPr>
+            <a:r>
+              <a:rPr sz="2000" b="0" i="0" dirty="0">
+                <a:solidFill>
+                  <a:srgbClr val="5C4826"/>
+                </a:solidFill>
+              </a:rPr>
+              <a:t>runs on a university-managed</a:t>
+            </a:r>
+          </a:p>
+          <a:p>
+            <a:pPr algn="ctr">
+              <a:spcBef>
+                <a:spcPts val="200"/>
+              </a:spcBef>
+            </a:pPr>
+            <a:r>
+              <a:rPr sz="2000" b="0" i="0" dirty="0">
+                <a:solidFill>
+                  <a:srgbClr val="5C4826"/>
+                </a:solidFill>
+              </a:rPr>
+              <a:t>workstation</a:t>
+            </a:r>
+          </a:p>
+          <a:p>
+            <a:pPr algn="ctr">
+              <a:spcBef>
+                <a:spcPts val="800"/>
+              </a:spcBef>
+            </a:pPr>
+            <a:r>
+              <a:rPr sz="2000" b="0" i="0" dirty="0">
+                <a:solidFill>
+                  <a:srgbClr val="5C4826"/>
+                </a:solidFill>
+              </a:rPr>
+              <a:t>updates: install a new version</a:t>
+            </a:r>
+          </a:p>
+          <a:p>
+            <a:pPr algn="ctr">
+              <a:spcBef>
+                <a:spcPts val="200"/>
+              </a:spcBef>
+            </a:pPr>
+            <a:r>
+              <a:rPr sz="2000" b="0" i="0" dirty="0">
+                <a:solidFill>
+                  <a:srgbClr val="5C4826"/>
+                </a:solidFill>
+              </a:rPr>
+              <a:t>at each machine</a:t>
+            </a:r>
+          </a:p>
+        </p:txBody>
+      </p:sp>
+      <p:sp>
+        <p:nvSpPr>
+          <p:cNvPr id="1003" name="Card"/>
+          <p:cNvSpPr/>
+          <p:nvPr/>
+        </p:nvSpPr>
+        <p:spPr>
+          <a:xfrm>
+            <a:off x="4709160" y="1051560"/>
+            <a:ext cx="4023360" cy="2514600"/>
+          </a:xfrm>
+          <a:prstGeom prst="rect">
+            <a:avLst/>
+          </a:prstGeom>
+          <a:solidFill>
+            <a:srgbClr val="F5F1E8"/>
+          </a:solidFill>
+          <a:ln w="12700">
+            <a:solidFill>
+              <a:srgbClr val="C9B991"/>
+            </a:solidFill>
+          </a:ln>
+          <a:effectLst/>
+        </p:spPr>
+        <p:style>
+          <a:lnRef idx="1">
+            <a:schemeClr val="accent1"/>
+          </a:lnRef>
+          <a:fillRef idx="3">
+            <a:schemeClr val="accent1"/>
+          </a:fillRef>
+          <a:effectRef idx="2">
+            <a:schemeClr val="accent1"/>
+          </a:effectRef>
+          <a:fontRef idx="minor">
+            <a:schemeClr val="lt1"/>
+          </a:fontRef>
+        </p:style>
+        <p:txBody>
+          <a:bodyPr wrap="square" lIns="27432" tIns="22860" rIns="27432" bIns="22860" rtlCol="0" anchor="t"/>
+          <a:lstStyle/>
+          <a:p>
+            <a:pPr algn="ctr"/>
+            <a:r>
+              <a:rPr sz="2000" b="1" i="0" dirty="0">
+                <a:solidFill>
+                  <a:srgbClr val="5C4826"/>
+                </a:solidFill>
+              </a:rPr>
+              <a:t>OPTION B: MANAGED SERVICE</a:t>
+            </a:r>
+          </a:p>
+          <a:p>
+            <a:pPr algn="ctr">
+              <a:spcBef>
+                <a:spcPts val="800"/>
+              </a:spcBef>
+            </a:pPr>
+            <a:r>
+              <a:rPr sz="2000" b="0" i="0" dirty="0">
+                <a:solidFill>
+                  <a:srgbClr val="5C4826"/>
+                </a:solidFill>
+              </a:rPr>
+              <a:t>runs on a managed platform;</a:t>
+            </a:r>
+          </a:p>
+          <a:p>
+            <a:pPr algn="ctr">
+              <a:spcBef>
+                <a:spcPts val="200"/>
+              </a:spcBef>
+            </a:pPr>
+            <a:r>
+              <a:rPr sz="2000" b="0" i="0" dirty="0">
+                <a:solidFill>
+                  <a:srgbClr val="5C4826"/>
+                </a:solidFill>
+              </a:rPr>
+              <a:t>users reach it in a browser</a:t>
+            </a:r>
+          </a:p>
+          <a:p>
+            <a:pPr algn="ctr">
+              <a:spcBef>
+                <a:spcPts val="800"/>
+              </a:spcBef>
+            </a:pPr>
+            <a:r>
+              <a:rPr sz="2000" b="0" i="0" dirty="0">
+                <a:solidFill>
+                  <a:srgbClr val="5C4826"/>
+                </a:solidFill>
+              </a:rPr>
+              <a:t>updates: deployed centrally,</a:t>
+            </a:r>
+          </a:p>
+          <a:p>
+            <a:pPr algn="ctr">
+              <a:spcBef>
+                <a:spcPts val="200"/>
+              </a:spcBef>
+            </a:pPr>
+            <a:r>
+              <a:rPr sz="2000" b="0" i="0" dirty="0">
+                <a:solidFill>
+                  <a:srgbClr val="5C4826"/>
+                </a:solidFill>
+              </a:rPr>
+              <a:t>behind the release gates</a:t>
+            </a:r>
+          </a:p>
+        </p:txBody>
+      </p:sp>
+      <p:sp>
+        <p:nvSpPr>
+          <p:cNvPr id="1004" name="Label"/>
+          <p:cNvSpPr/>
+          <p:nvPr/>
+        </p:nvSpPr>
+        <p:spPr>
+          <a:xfrm>
+            <a:off x="411480" y="3675888"/>
+            <a:ext cx="8412480" cy="658368"/>
+          </a:xfrm>
+          <a:prstGeom prst="rect">
+            <a:avLst/>
+          </a:prstGeom>
+          <a:noFill/>
+          <a:ln>
+            <a:noFill/>
+          </a:ln>
+          <a:effectLst/>
+        </p:spPr>
+        <p:style>
+          <a:lnRef idx="1">
+            <a:schemeClr val="accent1"/>
+          </a:lnRef>
+          <a:fillRef idx="3">
+            <a:schemeClr val="accent1"/>
+          </a:fillRef>
+          <a:effectRef idx="2">
+            <a:schemeClr val="accent1"/>
+          </a:effectRef>
+          <a:fontRef idx="minor">
+            <a:schemeClr val="lt1"/>
+          </a:fontRef>
+        </p:style>
+        <p:txBody>
+          <a:bodyPr wrap="square" lIns="27432" tIns="22860" rIns="27432" bIns="22860" rtlCol="0" anchor="ctr"/>
+          <a:lstStyle/>
+          <a:p>
+            <a:pPr algn="ctr"/>
+            <a:r>
+              <a:rPr sz="2000" b="1" i="0" dirty="0">
+                <a:solidFill>
+                  <a:srgbClr val="5C4826"/>
+                </a:solidFill>
+              </a:rPr>
+              <a:t>Argue from the model: environment, resources, topology, configuration</a:t>
+            </a:r>
+          </a:p>
+        </p:txBody>
+      </p:sp>
+      <p:sp>
+        <p:nvSpPr>
+          <p:cNvPr id="1005" name="Label"/>
+          <p:cNvSpPr/>
+          <p:nvPr/>
+        </p:nvSpPr>
+        <p:spPr>
+          <a:xfrm>
+            <a:off x="411480" y="4434840"/>
+            <a:ext cx="8412480" cy="914400"/>
+          </a:xfrm>
+          <a:prstGeom prst="rect">
+            <a:avLst/>
+          </a:prstGeom>
+          <a:noFill/>
+          <a:ln>
+            <a:noFill/>
+          </a:ln>
+          <a:effectLst/>
+        </p:spPr>
+        <p:style>
+          <a:lnRef idx="1">
+            <a:schemeClr val="accent1"/>
+          </a:lnRef>
+          <a:fillRef idx="3">
+            <a:schemeClr val="accent1"/>
+          </a:fillRef>
+          <a:effectRef idx="2">
+            <a:schemeClr val="accent1"/>
+          </a:effectRef>
+          <a:fontRef idx="minor">
+            <a:schemeClr val="lt1"/>
+          </a:fontRef>
+        </p:style>
+        <p:txBody>
+          <a:bodyPr wrap="square" lIns="27432" tIns="22860" rIns="27432" bIns="22860" rtlCol="0" anchor="ctr"/>
+          <a:lstStyle/>
+          <a:p>
+            <a:pPr algn="l"/>
+            <a:r>
+              <a:rPr sz="2000" b="0" i="0" dirty="0">
+                <a:solidFill>
+                  <a:srgbClr val="555960"/>
+                </a:solidFill>
+              </a:rPr>
+              <a:t>What changes if it must keep working with no network access?</a:t>
+            </a:r>
+          </a:p>
+          <a:p>
+            <a:pPr algn="l">
+              <a:spcBef>
+                <a:spcPts val="600"/>
+              </a:spcBef>
+            </a:pPr>
+            <a:r>
+              <a:rPr sz="2000" b="0" i="0" dirty="0">
+                <a:solidFill>
+                  <a:srgbClr val="555960"/>
+                </a:solidFill>
+              </a:rPr>
+              <a:t>What changes if hundreds of students reserve rooms at once?</a:t>
+            </a:r>
+          </a:p>
+        </p:txBody>
+      </p:sp>
+      <p:sp>
+        <p:nvSpPr>
+          <p:cNvPr id="1006" name="FooterBand"/>
+          <p:cNvSpPr/>
+          <p:nvPr/>
+        </p:nvSpPr>
+        <p:spPr>
+          <a:xfrm>
+            <a:off x="274320" y="5512918"/>
+            <a:ext cx="8595360" cy="905256"/>
+          </a:xfrm>
+          <a:prstGeom prst="rect">
+            <a:avLst/>
+          </a:prstGeom>
+          <a:solidFill>
+            <a:srgbClr val="8E6F3E"/>
+          </a:solidFill>
+          <a:ln>
+            <a:noFill/>
+          </a:ln>
+          <a:effectLst/>
+        </p:spPr>
+        <p:style>
+          <a:lnRef idx="1">
+            <a:schemeClr val="accent1"/>
+          </a:lnRef>
+          <a:fillRef idx="3">
+            <a:schemeClr val="accent1"/>
+          </a:fillRef>
+          <a:effectRef idx="2">
+            <a:schemeClr val="accent1"/>
+          </a:effectRef>
+          <a:fontRef idx="minor">
+            <a:schemeClr val="lt1"/>
+          </a:fontRef>
+        </p:style>
+        <p:txBody>
+          <a:bodyPr wrap="square" lIns="27432" tIns="22860" rIns="27432" bIns="22860" rtlCol="0" anchor="ctr"/>
+          <a:lstStyle/>
+          <a:p>
+            <a:pPr algn="ctr"/>
+            <a:r>
+              <a:rPr sz="2000" b="1" i="0" dirty="0">
+                <a:solidFill>
+                  <a:srgbClr val="FFFFFF"/>
+                </a:solidFill>
+              </a:rPr>
+              <a:t>Which deployment, under which requirements? Defend your model.</a:t>
+            </a:r>
+          </a:p>
+        </p:txBody>
+      </p:sp>
+    </p:spTree>
+  </p:cSld>
+  <p:clrMapOvr>
+    <a:masterClrMapping/>
+  </p:clrMapOvr>
+</p:sld>
+</file>
+
+<file path=ppt/slides/slide23.xml><?xml version="1.0" encoding="utf-8"?>
+<p:sld xmlns:a="http://schemas.openxmlformats.org/drawingml/2006/main" xmlns:p="http://schemas.openxmlformats.org/presentationml/2006/main" xmlns:r="http://schemas.openxmlformats.org/officeDocument/2006/relationships">
+  <p:cSld>
+    <p:spTree>
+      <p:nvGrpSpPr>
+        <p:cNvPr id="1" name=""/>
+        <p:cNvGrpSpPr/>
+        <p:nvPr/>
+      </p:nvGrpSpPr>
+      <p:grpSpPr/>
+      <p:sp>
+        <p:nvSpPr>
+          <p:cNvPr id="3" name="Title 2"/>
+          <p:cNvSpPr>
+            <a:spLocks noGrp="1"/>
+          </p:cNvSpPr>
+          <p:nvPr>
+            <p:ph type="title"/>
+          </p:nvPr>
+        </p:nvSpPr>
+        <p:spPr/>
+        <p:txBody>
+          <a:bodyPr wrap="square"/>
+          <a:lstStyle/>
+          <a:p>
+            <a:pPr algn="l"/>
+            <a:r>
+              <a:rPr sz="2400" b="0" i="0" dirty="0">
+                <a:solidFill>
+                  <a:srgbClr val="000000"/>
+                </a:solidFill>
+              </a:rPr>
+              <a:t>Deployment decisions and their evidence</a:t>
+            </a:r>
+          </a:p>
+        </p:txBody>
+      </p:sp>
+      <p:sp>
+        <p:nvSpPr>
+          <p:cNvPr id="1001" name="Slide Number Placeholder 900"/>
+          <p:cNvSpPr>
+            <a:spLocks noGrp="1"/>
+          </p:cNvSpPr>
+          <p:nvPr>
+            <p:ph type="sldNum" sz="quarter" idx="4"/>
+          </p:nvPr>
+        </p:nvSpPr>
+        <p:spPr/>
+        <p:txBody>
+          <a:bodyPr/>
+          <a:lstStyle/>
+          <a:p>
+            <a:fld id="{B3291E67-7172-4DCF-B35F-54404EBE6160}" type="slidenum">
+              <a:rPr lang="en-US" smtClean="0"/>
+              <a:t>1</a:t>
+            </a:fld>
+            <a:endParaRPr lang="en-US"/>
+          </a:p>
+        </p:txBody>
+      </p:sp>
+      <p:sp>
+        <p:nvSpPr>
+          <p:cNvPr id="1002" name="Method PROBLEM"/>
+          <p:cNvSpPr/>
+          <p:nvPr/>
+        </p:nvSpPr>
+        <p:spPr>
+          <a:xfrm>
+            <a:off x="365760" y="1024128"/>
+            <a:ext cx="1920240" cy="585216"/>
+          </a:xfrm>
+          <a:prstGeom prst="rect">
+            <a:avLst/>
+          </a:prstGeom>
+          <a:solidFill>
+            <a:srgbClr val="8E6F3E"/>
+          </a:solidFill>
+          <a:ln>
+            <a:noFill/>
+          </a:ln>
+          <a:effectLst/>
+        </p:spPr>
+        <p:style>
+          <a:lnRef idx="1">
+            <a:schemeClr val="accent1"/>
+          </a:lnRef>
+          <a:fillRef idx="3">
+            <a:schemeClr val="accent1"/>
+          </a:fillRef>
+          <a:effectRef idx="2">
+            <a:schemeClr val="accent1"/>
+          </a:effectRef>
+          <a:fontRef idx="minor">
+            <a:schemeClr val="lt1"/>
+          </a:fontRef>
+        </p:style>
+        <p:txBody>
+          <a:bodyPr wrap="square" lIns="27432" tIns="22860" rIns="27432" bIns="22860" rtlCol="0" anchor="ctr"/>
+          <a:lstStyle/>
+          <a:p>
+            <a:pPr algn="ctr"/>
+            <a:r>
+              <a:rPr sz="2000" b="1" i="0" dirty="0">
+                <a:solidFill>
+                  <a:srgbClr val="FFFFFF"/>
+                </a:solidFill>
+              </a:rPr>
+              <a:t>PROBLEM</a:t>
+            </a:r>
+          </a:p>
+        </p:txBody>
+      </p:sp>
+      <p:sp>
+        <p:nvSpPr>
+          <p:cNvPr id="1003" name="Label"/>
+          <p:cNvSpPr/>
+          <p:nvPr/>
+        </p:nvSpPr>
+        <p:spPr>
+          <a:xfrm>
+            <a:off x="2514600" y="987552"/>
+            <a:ext cx="6309360" cy="658368"/>
+          </a:xfrm>
+          <a:prstGeom prst="rect">
+            <a:avLst/>
+          </a:prstGeom>
+          <a:noFill/>
+          <a:ln>
+            <a:noFill/>
+          </a:ln>
+          <a:effectLst/>
+        </p:spPr>
+        <p:style>
+          <a:lnRef idx="1">
+            <a:schemeClr val="accent1"/>
+          </a:lnRef>
+          <a:fillRef idx="3">
+            <a:schemeClr val="accent1"/>
+          </a:fillRef>
+          <a:effectRef idx="2">
+            <a:schemeClr val="accent1"/>
+          </a:effectRef>
+          <a:fontRef idx="minor">
+            <a:schemeClr val="lt1"/>
+          </a:fontRef>
+        </p:style>
+        <p:txBody>
+          <a:bodyPr wrap="square" lIns="27432" tIns="22860" rIns="27432" bIns="22860" rtlCol="0" anchor="ctr"/>
+          <a:lstStyle/>
+          <a:p>
+            <a:pPr algn="l"/>
+            <a:r>
+              <a:rPr sz="2000" b="0" i="0" dirty="0">
+                <a:solidFill>
+                  <a:srgbClr val="555960"/>
+                </a:solidFill>
+              </a:rPr>
+              <a:t>software must run acceptably outside development</a:t>
+            </a:r>
+          </a:p>
+        </p:txBody>
+      </p:sp>
+      <p:sp>
+        <p:nvSpPr>
+          <p:cNvPr id="1004" name="Method MODEL"/>
+          <p:cNvSpPr/>
+          <p:nvPr/>
+        </p:nvSpPr>
+        <p:spPr>
+          <a:xfrm>
+            <a:off x="365760" y="1719072"/>
+            <a:ext cx="1920240" cy="585216"/>
+          </a:xfrm>
+          <a:prstGeom prst="rect">
+            <a:avLst/>
+          </a:prstGeom>
+          <a:solidFill>
+            <a:srgbClr val="8E6F3E"/>
+          </a:solidFill>
+          <a:ln>
+            <a:noFill/>
+          </a:ln>
+          <a:effectLst/>
+        </p:spPr>
+        <p:style>
+          <a:lnRef idx="1">
+            <a:schemeClr val="accent1"/>
+          </a:lnRef>
+          <a:fillRef idx="3">
+            <a:schemeClr val="accent1"/>
+          </a:fillRef>
+          <a:effectRef idx="2">
+            <a:schemeClr val="accent1"/>
+          </a:effectRef>
+          <a:fontRef idx="minor">
+            <a:schemeClr val="lt1"/>
+          </a:fontRef>
+        </p:style>
+        <p:txBody>
+          <a:bodyPr wrap="square" lIns="27432" tIns="22860" rIns="27432" bIns="22860" rtlCol="0" anchor="ctr"/>
+          <a:lstStyle/>
+          <a:p>
+            <a:pPr algn="ctr"/>
+            <a:r>
+              <a:rPr sz="2000" b="1" i="0" dirty="0">
+                <a:solidFill>
+                  <a:srgbClr val="FFFFFF"/>
+                </a:solidFill>
+              </a:rPr>
+              <a:t>MODEL</a:t>
+            </a:r>
+          </a:p>
+        </p:txBody>
+      </p:sp>
+      <p:sp>
+        <p:nvSpPr>
+          <p:cNvPr id="1005" name="Label"/>
+          <p:cNvSpPr/>
+          <p:nvPr/>
+        </p:nvSpPr>
+        <p:spPr>
+          <a:xfrm>
+            <a:off x="2514600" y="1682496"/>
+            <a:ext cx="6309360" cy="658368"/>
+          </a:xfrm>
+          <a:prstGeom prst="rect">
+            <a:avLst/>
+          </a:prstGeom>
+          <a:noFill/>
+          <a:ln>
+            <a:noFill/>
+          </a:ln>
+          <a:effectLst/>
+        </p:spPr>
+        <p:style>
+          <a:lnRef idx="1">
+            <a:schemeClr val="accent1"/>
+          </a:lnRef>
+          <a:fillRef idx="3">
+            <a:schemeClr val="accent1"/>
+          </a:fillRef>
+          <a:effectRef idx="2">
+            <a:schemeClr val="accent1"/>
+          </a:effectRef>
+          <a:fontRef idx="minor">
+            <a:schemeClr val="lt1"/>
+          </a:fontRef>
+        </p:style>
+        <p:txBody>
+          <a:bodyPr wrap="square" lIns="27432" tIns="22860" rIns="27432" bIns="22860" rtlCol="0" anchor="ctr"/>
+          <a:lstStyle/>
+          <a:p>
+            <a:pPr algn="l"/>
+            <a:r>
+              <a:rPr sz="2000" b="0" i="0" dirty="0">
+                <a:solidFill>
+                  <a:srgbClr val="555960"/>
+                </a:solidFill>
+              </a:rPr>
+              <a:t>the deployed system: environment, resources, topology, config</a:t>
+            </a:r>
+          </a:p>
+        </p:txBody>
+      </p:sp>
+      <p:sp>
+        <p:nvSpPr>
+          <p:cNvPr id="1006" name="Method JUDGMENT"/>
+          <p:cNvSpPr/>
+          <p:nvPr/>
+        </p:nvSpPr>
+        <p:spPr>
+          <a:xfrm>
+            <a:off x="365760" y="2414016"/>
+            <a:ext cx="1920240" cy="585216"/>
+          </a:xfrm>
+          <a:prstGeom prst="rect">
+            <a:avLst/>
+          </a:prstGeom>
+          <a:solidFill>
+            <a:srgbClr val="8E6F3E"/>
+          </a:solidFill>
+          <a:ln>
+            <a:noFill/>
+          </a:ln>
+          <a:effectLst/>
+        </p:spPr>
+        <p:style>
+          <a:lnRef idx="1">
+            <a:schemeClr val="accent1"/>
+          </a:lnRef>
+          <a:fillRef idx="3">
+            <a:schemeClr val="accent1"/>
+          </a:fillRef>
+          <a:effectRef idx="2">
+            <a:schemeClr val="accent1"/>
+          </a:effectRef>
+          <a:fontRef idx="minor">
+            <a:schemeClr val="lt1"/>
+          </a:fontRef>
+        </p:style>
+        <p:txBody>
+          <a:bodyPr wrap="square" lIns="27432" tIns="22860" rIns="27432" bIns="22860" rtlCol="0" anchor="ctr"/>
+          <a:lstStyle/>
+          <a:p>
+            <a:pPr algn="ctr"/>
+            <a:r>
+              <a:rPr sz="2000" b="1" i="0" dirty="0">
+                <a:solidFill>
+                  <a:srgbClr val="FFFFFF"/>
+                </a:solidFill>
+              </a:rPr>
+              <a:t>JUDGMENT</a:t>
+            </a:r>
+          </a:p>
+        </p:txBody>
+      </p:sp>
+      <p:sp>
+        <p:nvSpPr>
+          <p:cNvPr id="1007" name="Label"/>
+          <p:cNvSpPr/>
+          <p:nvPr/>
+        </p:nvSpPr>
+        <p:spPr>
+          <a:xfrm>
+            <a:off x="2514600" y="2377440"/>
+            <a:ext cx="6309360" cy="658368"/>
+          </a:xfrm>
+          <a:prstGeom prst="rect">
+            <a:avLst/>
+          </a:prstGeom>
+          <a:noFill/>
+          <a:ln>
+            <a:noFill/>
+          </a:ln>
+          <a:effectLst/>
+        </p:spPr>
+        <p:style>
+          <a:lnRef idx="1">
+            <a:schemeClr val="accent1"/>
+          </a:lnRef>
+          <a:fillRef idx="3">
+            <a:schemeClr val="accent1"/>
+          </a:fillRef>
+          <a:effectRef idx="2">
+            <a:schemeClr val="accent1"/>
+          </a:effectRef>
+          <a:fontRef idx="minor">
+            <a:schemeClr val="lt1"/>
+          </a:fontRef>
+        </p:style>
+        <p:txBody>
+          <a:bodyPr wrap="square" lIns="27432" tIns="22860" rIns="27432" bIns="22860" rtlCol="0" anchor="ctr"/>
+          <a:lstStyle/>
+          <a:p>
+            <a:pPr algn="l"/>
+            <a:r>
+              <a:rPr sz="2000" b="0" i="0" dirty="0">
+                <a:solidFill>
+                  <a:srgbClr val="555960"/>
+                </a:solidFill>
+              </a:rPr>
+              <a:t>local, self-hosted, or managed service</a:t>
+            </a:r>
+          </a:p>
+        </p:txBody>
+      </p:sp>
+      <p:sp>
+        <p:nvSpPr>
+          <p:cNvPr id="1008" name="Method REALIZE"/>
+          <p:cNvSpPr/>
+          <p:nvPr/>
+        </p:nvSpPr>
+        <p:spPr>
+          <a:xfrm>
+            <a:off x="365760" y="3108960"/>
+            <a:ext cx="1920240" cy="585216"/>
+          </a:xfrm>
+          <a:prstGeom prst="rect">
+            <a:avLst/>
+          </a:prstGeom>
+          <a:solidFill>
+            <a:srgbClr val="8E6F3E"/>
+          </a:solidFill>
+          <a:ln>
+            <a:noFill/>
+          </a:ln>
+          <a:effectLst/>
+        </p:spPr>
+        <p:style>
+          <a:lnRef idx="1">
+            <a:schemeClr val="accent1"/>
+          </a:lnRef>
+          <a:fillRef idx="3">
+            <a:schemeClr val="accent1"/>
+          </a:fillRef>
+          <a:effectRef idx="2">
+            <a:schemeClr val="accent1"/>
+          </a:effectRef>
+          <a:fontRef idx="minor">
+            <a:schemeClr val="lt1"/>
+          </a:fontRef>
+        </p:style>
+        <p:txBody>
+          <a:bodyPr wrap="square" lIns="27432" tIns="22860" rIns="27432" bIns="22860" rtlCol="0" anchor="ctr"/>
+          <a:lstStyle/>
+          <a:p>
+            <a:pPr algn="ctr"/>
+            <a:r>
+              <a:rPr sz="2000" b="1" i="0" dirty="0">
+                <a:solidFill>
+                  <a:srgbClr val="FFFFFF"/>
+                </a:solidFill>
+              </a:rPr>
+              <a:t>REALIZE</a:t>
+            </a:r>
+          </a:p>
+        </p:txBody>
+      </p:sp>
+      <p:sp>
+        <p:nvSpPr>
+          <p:cNvPr id="1009" name="Label"/>
+          <p:cNvSpPr/>
+          <p:nvPr/>
+        </p:nvSpPr>
+        <p:spPr>
+          <a:xfrm>
+            <a:off x="2514600" y="3072384"/>
+            <a:ext cx="6309360" cy="658368"/>
+          </a:xfrm>
+          <a:prstGeom prst="rect">
+            <a:avLst/>
+          </a:prstGeom>
+          <a:noFill/>
+          <a:ln>
+            <a:noFill/>
+          </a:ln>
+          <a:effectLst/>
+        </p:spPr>
+        <p:style>
+          <a:lnRef idx="1">
+            <a:schemeClr val="accent1"/>
+          </a:lnRef>
+          <a:fillRef idx="3">
+            <a:schemeClr val="accent1"/>
+          </a:fillRef>
+          <a:effectRef idx="2">
+            <a:schemeClr val="accent1"/>
+          </a:effectRef>
+          <a:fontRef idx="minor">
+            <a:schemeClr val="lt1"/>
+          </a:fontRef>
+        </p:style>
+        <p:txBody>
+          <a:bodyPr wrap="square" lIns="27432" tIns="22860" rIns="27432" bIns="22860" rtlCol="0" anchor="ctr"/>
+          <a:lstStyle/>
+          <a:p>
+            <a:pPr algn="l"/>
+            <a:r>
+              <a:rPr sz="2000" b="0" i="0" dirty="0">
+                <a:solidFill>
+                  <a:srgbClr val="555960"/>
+                </a:solidFill>
+              </a:rPr>
+              <a:t>the deployment process: build, validate, release</a:t>
+            </a:r>
+          </a:p>
+        </p:txBody>
+      </p:sp>
+      <p:sp>
+        <p:nvSpPr>
+          <p:cNvPr id="1010" name="Method EVIDENCE"/>
+          <p:cNvSpPr/>
+          <p:nvPr/>
+        </p:nvSpPr>
+        <p:spPr>
+          <a:xfrm>
+            <a:off x="365760" y="3803904"/>
+            <a:ext cx="1920240" cy="585216"/>
+          </a:xfrm>
+          <a:prstGeom prst="rect">
+            <a:avLst/>
+          </a:prstGeom>
+          <a:solidFill>
+            <a:srgbClr val="8E6F3E"/>
+          </a:solidFill>
+          <a:ln>
+            <a:noFill/>
+          </a:ln>
+          <a:effectLst/>
+        </p:spPr>
+        <p:style>
+          <a:lnRef idx="1">
+            <a:schemeClr val="accent1"/>
+          </a:lnRef>
+          <a:fillRef idx="3">
+            <a:schemeClr val="accent1"/>
+          </a:fillRef>
+          <a:effectRef idx="2">
+            <a:schemeClr val="accent1"/>
+          </a:effectRef>
+          <a:fontRef idx="minor">
+            <a:schemeClr val="lt1"/>
+          </a:fontRef>
+        </p:style>
+        <p:txBody>
+          <a:bodyPr wrap="square" lIns="27432" tIns="22860" rIns="27432" bIns="22860" rtlCol="0" anchor="ctr"/>
+          <a:lstStyle/>
+          <a:p>
+            <a:pPr algn="ctr"/>
+            <a:r>
+              <a:rPr sz="2000" b="1" i="0" dirty="0">
+                <a:solidFill>
+                  <a:srgbClr val="FFFFFF"/>
+                </a:solidFill>
+              </a:rPr>
+              <a:t>EVIDENCE</a:t>
+            </a:r>
+          </a:p>
+        </p:txBody>
+      </p:sp>
+      <p:sp>
+        <p:nvSpPr>
+          <p:cNvPr id="1011" name="Label"/>
+          <p:cNvSpPr/>
+          <p:nvPr/>
+        </p:nvSpPr>
+        <p:spPr>
+          <a:xfrm>
+            <a:off x="2514600" y="3767328"/>
+            <a:ext cx="6309360" cy="658368"/>
+          </a:xfrm>
+          <a:prstGeom prst="rect">
+            <a:avLst/>
+          </a:prstGeom>
+          <a:noFill/>
+          <a:ln>
+            <a:noFill/>
+          </a:ln>
+          <a:effectLst/>
+        </p:spPr>
+        <p:style>
+          <a:lnRef idx="1">
+            <a:schemeClr val="accent1"/>
+          </a:lnRef>
+          <a:fillRef idx="3">
+            <a:schemeClr val="accent1"/>
+          </a:fillRef>
+          <a:effectRef idx="2">
+            <a:schemeClr val="accent1"/>
+          </a:effectRef>
+          <a:fontRef idx="minor">
+            <a:schemeClr val="lt1"/>
+          </a:fontRef>
+        </p:style>
+        <p:txBody>
+          <a:bodyPr wrap="square" lIns="27432" tIns="22860" rIns="27432" bIns="22860" rtlCol="0" anchor="ctr"/>
+          <a:lstStyle/>
+          <a:p>
+            <a:pPr algn="l"/>
+            <a:r>
+              <a:rPr sz="2000" b="0" i="0" dirty="0">
+                <a:solidFill>
+                  <a:srgbClr val="555960"/>
+                </a:solidFill>
+              </a:rPr>
+              <a:t>build, integration, deployment, and runtime checks</a:t>
+            </a:r>
+          </a:p>
+        </p:txBody>
+      </p:sp>
+      <p:sp>
+        <p:nvSpPr>
+          <p:cNvPr id="1012" name="Method ALIGNMENT"/>
+          <p:cNvSpPr/>
+          <p:nvPr/>
+        </p:nvSpPr>
+        <p:spPr>
+          <a:xfrm>
+            <a:off x="365760" y="4498848"/>
+            <a:ext cx="1920240" cy="585216"/>
+          </a:xfrm>
+          <a:prstGeom prst="rect">
+            <a:avLst/>
+          </a:prstGeom>
+          <a:solidFill>
+            <a:srgbClr val="3E5C6F"/>
+          </a:solidFill>
+          <a:ln>
+            <a:noFill/>
+          </a:ln>
+          <a:effectLst/>
+        </p:spPr>
+        <p:style>
+          <a:lnRef idx="1">
+            <a:schemeClr val="accent1"/>
+          </a:lnRef>
+          <a:fillRef idx="3">
+            <a:schemeClr val="accent1"/>
+          </a:fillRef>
+          <a:effectRef idx="2">
+            <a:schemeClr val="accent1"/>
+          </a:effectRef>
+          <a:fontRef idx="minor">
+            <a:schemeClr val="lt1"/>
+          </a:fontRef>
+        </p:style>
+        <p:txBody>
+          <a:bodyPr wrap="square" lIns="27432" tIns="22860" rIns="27432" bIns="22860" rtlCol="0" anchor="ctr"/>
+          <a:lstStyle/>
+          <a:p>
+            <a:pPr algn="ctr"/>
+            <a:r>
+              <a:rPr sz="2000" b="1" i="0" dirty="0">
+                <a:solidFill>
+                  <a:srgbClr val="FFFFFF"/>
+                </a:solidFill>
+              </a:rPr>
+              <a:t>ALIGNMENT</a:t>
+            </a:r>
+          </a:p>
+        </p:txBody>
+      </p:sp>
+      <p:sp>
+        <p:nvSpPr>
+          <p:cNvPr id="1013" name="Label"/>
+          <p:cNvSpPr/>
+          <p:nvPr/>
+        </p:nvSpPr>
+        <p:spPr>
+          <a:xfrm>
+            <a:off x="2514600" y="4462272"/>
+            <a:ext cx="6309360" cy="658368"/>
+          </a:xfrm>
+          <a:prstGeom prst="rect">
+            <a:avLst/>
+          </a:prstGeom>
+          <a:noFill/>
+          <a:ln>
+            <a:noFill/>
+          </a:ln>
+          <a:effectLst/>
+        </p:spPr>
+        <p:style>
+          <a:lnRef idx="1">
+            <a:schemeClr val="accent1"/>
+          </a:lnRef>
+          <a:fillRef idx="3">
+            <a:schemeClr val="accent1"/>
+          </a:fillRef>
+          <a:effectRef idx="2">
+            <a:schemeClr val="accent1"/>
+          </a:effectRef>
+          <a:fontRef idx="minor">
+            <a:schemeClr val="lt1"/>
+          </a:fontRef>
+        </p:style>
+        <p:txBody>
+          <a:bodyPr wrap="square" lIns="27432" tIns="22860" rIns="27432" bIns="22860" rtlCol="0" anchor="ctr"/>
+          <a:lstStyle/>
+          <a:p>
+            <a:pPr algn="l"/>
+            <a:r>
+              <a:rPr sz="2000" b="0" i="0" dirty="0">
+                <a:solidFill>
+                  <a:srgbClr val="555960"/>
+                </a:solidFill>
+              </a:rPr>
+              <a:t>declared configuration, CI gates, release policies</a:t>
+            </a:r>
+          </a:p>
+        </p:txBody>
+      </p:sp>
+      <p:sp>
+        <p:nvSpPr>
+          <p:cNvPr id="1014" name="FooterBand"/>
+          <p:cNvSpPr/>
+          <p:nvPr/>
+        </p:nvSpPr>
+        <p:spPr>
+          <a:xfrm>
+            <a:off x="274320" y="5512918"/>
+            <a:ext cx="8595360" cy="905256"/>
+          </a:xfrm>
+          <a:prstGeom prst="rect">
+            <a:avLst/>
+          </a:prstGeom>
+          <a:solidFill>
+            <a:srgbClr val="8E6F3E"/>
+          </a:solidFill>
+          <a:ln>
+            <a:noFill/>
+          </a:ln>
+          <a:effectLst/>
+        </p:spPr>
+        <p:style>
+          <a:lnRef idx="1">
+            <a:schemeClr val="accent1"/>
+          </a:lnRef>
+          <a:fillRef idx="3">
+            <a:schemeClr val="accent1"/>
+          </a:fillRef>
+          <a:effectRef idx="2">
+            <a:schemeClr val="accent1"/>
+          </a:effectRef>
+          <a:fontRef idx="minor">
+            <a:schemeClr val="lt1"/>
+          </a:fontRef>
+        </p:style>
+        <p:txBody>
+          <a:bodyPr wrap="square" lIns="27432" tIns="22860" rIns="27432" bIns="22860" rtlCol="0" anchor="ctr"/>
+          <a:lstStyle/>
+          <a:p>
+            <a:pPr algn="ctr"/>
+            <a:r>
+              <a:rPr sz="2000" b="1" i="0" dirty="0">
+                <a:solidFill>
+                  <a:srgbClr val="FFFFFF"/>
+                </a:solidFill>
+              </a:rPr>
+              <a:t>The service now runs in a suitable environment.</a:t>
+            </a:r>
+          </a:p>
+          <a:p>
+            <a:pPr algn="ctr">
+              <a:spcBef>
+                <a:spcPts val="300"/>
+              </a:spcBef>
+            </a:pPr>
+            <a:r>
+              <a:rPr sz="2000" b="1" i="0" dirty="0">
+                <a:solidFill>
+                  <a:srgbClr val="FFFFFF"/>
+                </a:solidFill>
+              </a:rPr>
+              <a:t>What happens to its data when the process stops?</a:t>
+            </a:r>
+          </a:p>
+        </p:txBody>
+      </p:sp>
+    </p:spTree>
+  </p:cSld>
+  <p:clrMapOvr>
+    <a:masterClrMapping/>
+  </p:clrMapOvr>
+</p:sld>
+</file>
+
 <file path=ppt/slides/slide3.xml><?xml version="1.0" encoding="utf-8"?>
 <p:sld xmlns:a="http://schemas.openxmlformats.org/drawingml/2006/main" xmlns:p="http://schemas.openxmlformats.org/presentationml/2006/main" xmlns:r="http://schemas.openxmlformats.org/officeDocument/2006/relationships">
   <p:cSld>

</xml_diff>